<commit_message>
Add persona slide to enterprise deck
Add slide 15, "One pattern, four field audiences.", after the workflows
slide. It shows how account teams, customer success, solution sales and
developer stakeholders would use the Bearing pattern, with honest
Prototype / Emerging / Proposed tags (only developer onboarding is
implemented). Footers now read N / 17; README deck description updated.

Co-authored-by: Copilot App <223556219+Copilot@users.noreply.github.com>
Copilot-Session: 0ebb2219-7cfd-45f5-b9f7-9e9bb62344b2
</commit_message>
<xml_diff>
--- a/submission/bearing-enterprise-deck.pptx
+++ b/submission/bearing-enterprise-deck.pptx
@@ -19,6 +19,7 @@
     <p:sldId id="267" r:id="rId19"/>
     <p:sldId id="268" r:id="rId20"/>
     <p:sldId id="269" r:id="rId21"/>
+    <p:sldId id="272" r:id="rId24"/>
     <p:sldId id="270" r:id="rId22"/>
     <p:sldId id="271" r:id="rId23"/>
   </p:sldIdLst>
@@ -1048,6 +1049,76 @@
           <a:p>
             <a:r>
               <a:t>The Kyndryl 2025 survey dates are June 20–August 15, 2025. The 2024 announcement was October 16, 2024. Vendor research describes its stated populations, not the customer's estate. The four-week schedule and all backlog examples are illustrative. Artifacts use the official neutral/green palette with a restrained Copilot Purple accent: green marks what exists today, purple marks illustrative or proposed content. Mona Sans is used for display type and Arial for body text so the files stay portable. They do not imply GitHub endorsement of Bearing.</a:t>
+            </a:r>
+          </a:p>
+        </p:txBody>
+      </p:sp>
+      <p:sp>
+        <p:nvSpPr>
+          <p:cNvPr id="4" name="Slide Number Placeholder 3"/>
+          <p:cNvSpPr>
+            <a:spLocks noGrp="1"/>
+          </p:cNvSpPr>
+          <p:nvPr>
+            <p:ph type="sldNum" idx="5" sz="quarter"/>
+          </p:nvPr>
+        </p:nvSpPr>
+        <p:spPr/>
+      </p:sp>
+    </p:spTree>
+  </p:cSld>
+  <p:clrMapOvr>
+    <a:masterClrMapping/>
+  </p:clrMapOvr>
+</p:notes>
+</file>
+
+<file path=ppt/notesSlides/notesSlide17.xml><?xml version="1.0" encoding="utf-8"?>
+<p:notes xmlns:a="http://schemas.openxmlformats.org/drawingml/2006/main" xmlns:p="http://schemas.openxmlformats.org/presentationml/2006/main" xmlns:r="http://schemas.openxmlformats.org/officeDocument/2006/relationships">
+  <p:cSld>
+    <p:spTree>
+      <p:nvGrpSpPr>
+        <p:cNvPr id="1" name=""/>
+        <p:cNvGrpSpPr/>
+        <p:nvPr/>
+      </p:nvGrpSpPr>
+      <p:grpSpPr>
+        <a:xfrm>
+          <a:off x="0" y="0"/>
+          <a:ext cx="0" cy="0"/>
+          <a:chOff x="0" y="0"/>
+          <a:chExt cx="0" cy="0"/>
+        </a:xfrm>
+      </p:grpSpPr>
+      <p:sp>
+        <p:nvSpPr>
+          <p:cNvPr id="2" name="Slide Image Placeholder 1"/>
+          <p:cNvSpPr>
+            <a:spLocks noGrp="1"/>
+          </p:cNvSpPr>
+          <p:nvPr>
+            <p:ph type="sldImg" idx="2"/>
+          </p:nvPr>
+        </p:nvSpPr>
+        <p:spPr/>
+      </p:sp>
+      <p:sp>
+        <p:nvSpPr>
+          <p:cNvPr id="3" name="Notes Placeholder 2"/>
+          <p:cNvSpPr>
+            <a:spLocks noGrp="1"/>
+          </p:cNvSpPr>
+          <p:nvPr>
+            <p:ph type="body" idx="3" sz="quarter"/>
+          </p:nvPr>
+        </p:nvSpPr>
+        <p:spPr/>
+        <p:txBody>
+          <a:bodyPr/>
+          <a:lstStyle/>
+          <a:p>
+            <a:r>
+              <a:t>Only developer onboarding is implemented today. The other three rows are reuse patterns of the same guide format and review discipline. Emerging: today’s guide could be reused as-is but has not been validated with that audience. Proposed: the workflow is not built. No adoption, telemetry, time-saving or customer-validation results are claimed. Any field use still needs repository eligibility, owner review and a human decision before action. Slide 14 lists workflows; this slide lists who would use the pattern.</a:t>
             </a:r>
           </a:p>
         </p:txBody>
@@ -4950,7 +5021,7 @@
       </p:sp>
       <p:sp>
         <p:nvSpPr>
-          <p:cNvPr id="6" name="01 / 16"/>
+          <p:cNvPr id="6" name="01 / 17"/>
           <p:cNvSpPr txBox="1"/>
           <p:nvPr/>
         </p:nvSpPr>
@@ -4985,7 +5056,7 @@
                 </a:solidFill>
                 <a:latin typeface="Arial"/>
               </a:rPr>
-              <a:t>01 / 16</a:t>
+              <a:t>01 / 17</a:t>
             </a:r>
           </a:p>
         </p:txBody>
@@ -6242,7 +6313,7 @@
       </p:sp>
       <p:sp>
         <p:nvSpPr>
-          <p:cNvPr id="6" name="10 / 16"/>
+          <p:cNvPr id="6" name="10 / 17"/>
           <p:cNvSpPr txBox="1"/>
           <p:nvPr/>
         </p:nvSpPr>
@@ -6277,7 +6348,7 @@
                 </a:solidFill>
                 <a:latin typeface="Arial"/>
               </a:rPr>
-              <a:t>10 / 16</a:t>
+              <a:t>10 / 17</a:t>
             </a:r>
           </a:p>
         </p:txBody>
@@ -7642,7 +7713,7 @@
       </p:sp>
       <p:sp>
         <p:nvSpPr>
-          <p:cNvPr id="6" name="11 / 16"/>
+          <p:cNvPr id="6" name="11 / 17"/>
           <p:cNvSpPr txBox="1"/>
           <p:nvPr/>
         </p:nvSpPr>
@@ -7677,7 +7748,7 @@
                 </a:solidFill>
                 <a:latin typeface="Arial"/>
               </a:rPr>
-              <a:t>11 / 16</a:t>
+              <a:t>11 / 17</a:t>
             </a:r>
           </a:p>
         </p:txBody>
@@ -8829,7 +8900,7 @@
       </p:sp>
       <p:sp>
         <p:nvSpPr>
-          <p:cNvPr id="6" name="12 / 16"/>
+          <p:cNvPr id="6" name="12 / 17"/>
           <p:cNvSpPr txBox="1"/>
           <p:nvPr/>
         </p:nvSpPr>
@@ -8864,7 +8935,7 @@
                 </a:solidFill>
                 <a:latin typeface="Arial"/>
               </a:rPr>
-              <a:t>12 / 16</a:t>
+              <a:t>12 / 17</a:t>
             </a:r>
           </a:p>
         </p:txBody>
@@ -9705,7 +9776,7 @@
       </p:sp>
       <p:sp>
         <p:nvSpPr>
-          <p:cNvPr id="6" name="13 / 16"/>
+          <p:cNvPr id="6" name="13 / 17"/>
           <p:cNvSpPr txBox="1"/>
           <p:nvPr/>
         </p:nvSpPr>
@@ -9740,7 +9811,7 @@
                 </a:solidFill>
                 <a:latin typeface="Arial"/>
               </a:rPr>
-              <a:t>13 / 16</a:t>
+              <a:t>13 / 17</a:t>
             </a:r>
           </a:p>
         </p:txBody>
@@ -11154,7 +11225,7 @@
       </p:sp>
       <p:sp>
         <p:nvSpPr>
-          <p:cNvPr id="6" name="14 / 16"/>
+          <p:cNvPr id="6" name="14 / 17"/>
           <p:cNvSpPr txBox="1"/>
           <p:nvPr/>
         </p:nvSpPr>
@@ -11189,7 +11260,7 @@
                 </a:solidFill>
                 <a:latin typeface="Arial"/>
               </a:rPr>
-              <a:t>14 / 16</a:t>
+              <a:t>14 / 17</a:t>
             </a:r>
           </a:p>
         </p:txBody>
@@ -12897,7 +12968,7 @@
       </p:sp>
       <p:sp>
         <p:nvSpPr>
-          <p:cNvPr id="6" name="15 / 16"/>
+          <p:cNvPr id="6" name="16 / 17"/>
           <p:cNvSpPr txBox="1"/>
           <p:nvPr/>
         </p:nvSpPr>
@@ -12932,7 +13003,7 @@
                 </a:solidFill>
                 <a:latin typeface="Arial"/>
               </a:rPr>
-              <a:t>15 / 16</a:t>
+              <a:t>16 / 17</a:t>
             </a:r>
           </a:p>
         </p:txBody>
@@ -13694,7 +13765,7 @@
       </p:sp>
       <p:sp>
         <p:nvSpPr>
-          <p:cNvPr id="6" name="16 / 16"/>
+          <p:cNvPr id="6" name="17 / 17"/>
           <p:cNvSpPr txBox="1"/>
           <p:nvPr/>
         </p:nvSpPr>
@@ -13729,7 +13800,7 @@
                 </a:solidFill>
                 <a:latin typeface="Arial"/>
               </a:rPr>
-              <a:t>16 / 16</a:t>
+              <a:t>17 / 17</a:t>
             </a:r>
           </a:p>
         </p:txBody>
@@ -14207,6 +14278,1528 @@
                 <a:latin typeface="Arial"/>
               </a:rPr>
               <a:t>Checked October 5, 2026. No customer ROI or shipped modernization capability is claimed.</a:t>
+            </a:r>
+          </a:p>
+        </p:txBody>
+      </p:sp>
+    </p:spTree>
+  </p:cSld>
+  <p:clrMapOvr>
+    <a:masterClrMapping/>
+  </p:clrMapOvr>
+</p:sld>
+</file>
+
+<file path=ppt/slides/slide17.xml><?xml version="1.0" encoding="utf-8"?>
+<p:sld xmlns:a="http://schemas.openxmlformats.org/drawingml/2006/main" xmlns:p="http://schemas.openxmlformats.org/presentationml/2006/main" xmlns:r="http://schemas.openxmlformats.org/officeDocument/2006/relationships">
+  <p:cSld>
+    <p:bg>
+      <p:bgPr>
+        <a:solidFill>
+          <a:srgbClr val="FFFFFF"/>
+        </a:solidFill>
+        <a:effectLst/>
+      </p:bgPr>
+    </p:bg>
+    <p:spTree>
+      <p:nvGrpSpPr>
+        <p:cNvPr id="1" name=""/>
+        <p:cNvGrpSpPr/>
+        <p:nvPr/>
+      </p:nvGrpSpPr>
+      <p:grpSpPr/>
+      <p:sp>
+        <p:nvSpPr>
+          <p:cNvPr id="2" name="One pattern, four field audiences."/>
+          <p:cNvSpPr txBox="1"/>
+          <p:nvPr/>
+        </p:nvSpPr>
+        <p:spPr>
+          <a:xfrm>
+            <a:off x="594360" y="502920"/>
+            <a:ext cx="10972800" cy="1005840"/>
+          </a:xfrm>
+          <a:prstGeom prst="rect">
+            <a:avLst/>
+          </a:prstGeom>
+          <a:noFill/>
+        </p:spPr>
+        <p:txBody>
+          <a:bodyPr wrap="square" lIns="0" rIns="0" tIns="0" bIns="0">
+            <a:spAutoFit/>
+          </a:bodyPr>
+          <a:lstStyle/>
+          <a:p>
+            <a:pPr>
+              <a:lnSpc>
+                <a:spcPct val="107000"/>
+              </a:lnSpc>
+              <a:spcAft>
+                <a:spcPts val="500"/>
+              </a:spcAft>
+            </a:pPr>
+            <a:r>
+              <a:rPr sz="3200" b="1">
+                <a:solidFill>
+                  <a:srgbClr val="101411"/>
+                </a:solidFill>
+                <a:latin typeface="Mona Sans"/>
+              </a:rPr>
+              <a:t>One pattern, four field audiences.</a:t>
+            </a:r>
+          </a:p>
+        </p:txBody>
+      </p:sp>
+      <p:sp>
+        <p:nvSpPr>
+          <p:cNvPr id="3" name="Rectangle 2"/>
+          <p:cNvSpPr/>
+          <p:nvPr/>
+        </p:nvSpPr>
+        <p:spPr>
+          <a:xfrm>
+            <a:off x="594360" y="6327648"/>
+            <a:ext cx="10972800" cy="10972"/>
+          </a:xfrm>
+          <a:prstGeom prst="rect">
+            <a:avLst/>
+          </a:prstGeom>
+          <a:solidFill>
+            <a:srgbClr val="E4EBE6"/>
+          </a:solidFill>
+          <a:ln>
+            <a:noFill/>
+          </a:ln>
+        </p:spPr>
+        <p:style>
+          <a:lnRef idx="1">
+            <a:schemeClr val="accent1"/>
+          </a:lnRef>
+          <a:fillRef idx="3">
+            <a:schemeClr val="accent1"/>
+          </a:fillRef>
+          <a:effectRef idx="2">
+            <a:schemeClr val="accent1"/>
+          </a:effectRef>
+          <a:fontRef idx="minor">
+            <a:schemeClr val="lt1"/>
+          </a:fontRef>
+        </p:style>
+        <p:txBody>
+          <a:bodyPr rtlCol="0" anchor="ctr"/>
+          <a:lstStyle/>
+          <a:p>
+            <a:pPr algn="ctr"/>
+          </a:p>
+        </p:txBody>
+      </p:sp>
+      <p:sp>
+        <p:nvSpPr>
+          <p:cNvPr id="4" name="GitHub mark" descr="GitHub logo"/>
+          <p:cNvSpPr/>
+          <p:nvPr/>
+        </p:nvSpPr>
+        <p:spPr>
+          <a:xfrm>
+            <a:off x="594360" y="6419088"/>
+            <a:ext cx="182880" cy="182880"/>
+          </a:xfrm>
+          <a:custGeom>
+            <a:avLst/>
+            <a:gdLst/>
+            <a:ahLst/>
+            <a:cxnLst/>
+            <a:rect l="0" t="0" r="r" b="b"/>
+            <a:pathLst>
+              <a:path w="16000" h="16000">
+                <a:moveTo>
+                  <a:pt x="8000" y="0"/>
+                </a:moveTo>
+                <a:cubicBezTo>
+                  <a:pt x="3580" y="0"/>
+                  <a:pt x="0" y="3580"/>
+                  <a:pt x="0" y="8000"/>
+                </a:cubicBezTo>
+                <a:cubicBezTo>
+                  <a:pt x="0" y="11540"/>
+                  <a:pt x="2290" y="14530"/>
+                  <a:pt x="5470" y="15590"/>
+                </a:cubicBezTo>
+                <a:cubicBezTo>
+                  <a:pt x="5870" y="15660"/>
+                  <a:pt x="6020" y="15420"/>
+                  <a:pt x="6020" y="15210"/>
+                </a:cubicBezTo>
+                <a:cubicBezTo>
+                  <a:pt x="6020" y="15020"/>
+                  <a:pt x="6010" y="14390"/>
+                  <a:pt x="6010" y="13720"/>
+                </a:cubicBezTo>
+                <a:cubicBezTo>
+                  <a:pt x="4000" y="14090"/>
+                  <a:pt x="3480" y="13230"/>
+                  <a:pt x="3320" y="12780"/>
+                </a:cubicBezTo>
+                <a:cubicBezTo>
+                  <a:pt x="3230" y="12550"/>
+                  <a:pt x="2840" y="11840"/>
+                  <a:pt x="2500" y="11650"/>
+                </a:cubicBezTo>
+                <a:cubicBezTo>
+                  <a:pt x="2220" y="11500"/>
+                  <a:pt x="1820" y="11130"/>
+                  <a:pt x="2490" y="11120"/>
+                </a:cubicBezTo>
+                <a:cubicBezTo>
+                  <a:pt x="3120" y="11110"/>
+                  <a:pt x="3570" y="11700"/>
+                  <a:pt x="3720" y="11940"/>
+                </a:cubicBezTo>
+                <a:cubicBezTo>
+                  <a:pt x="4440" y="13150"/>
+                  <a:pt x="5590" y="12810"/>
+                  <a:pt x="6050" y="12600"/>
+                </a:cubicBezTo>
+                <a:cubicBezTo>
+                  <a:pt x="6120" y="12080"/>
+                  <a:pt x="6330" y="11730"/>
+                  <a:pt x="6560" y="11530"/>
+                </a:cubicBezTo>
+                <a:cubicBezTo>
+                  <a:pt x="4780" y="11330"/>
+                  <a:pt x="2920" y="10640"/>
+                  <a:pt x="2920" y="7580"/>
+                </a:cubicBezTo>
+                <a:cubicBezTo>
+                  <a:pt x="2920" y="6710"/>
+                  <a:pt x="3230" y="5990"/>
+                  <a:pt x="3740" y="5430"/>
+                </a:cubicBezTo>
+                <a:cubicBezTo>
+                  <a:pt x="3660" y="5230"/>
+                  <a:pt x="3380" y="4410"/>
+                  <a:pt x="3820" y="3310"/>
+                </a:cubicBezTo>
+                <a:cubicBezTo>
+                  <a:pt x="3820" y="3310"/>
+                  <a:pt x="4490" y="3100"/>
+                  <a:pt x="6020" y="4130"/>
+                </a:cubicBezTo>
+                <a:cubicBezTo>
+                  <a:pt x="6660" y="3950"/>
+                  <a:pt x="7340" y="3860"/>
+                  <a:pt x="8020" y="3860"/>
+                </a:cubicBezTo>
+                <a:cubicBezTo>
+                  <a:pt x="8700" y="3860"/>
+                  <a:pt x="9380" y="3950"/>
+                  <a:pt x="10020" y="4130"/>
+                </a:cubicBezTo>
+                <a:cubicBezTo>
+                  <a:pt x="11550" y="3090"/>
+                  <a:pt x="12220" y="3310"/>
+                  <a:pt x="12220" y="3310"/>
+                </a:cubicBezTo>
+                <a:cubicBezTo>
+                  <a:pt x="12660" y="4410"/>
+                  <a:pt x="12380" y="5230"/>
+                  <a:pt x="12300" y="5430"/>
+                </a:cubicBezTo>
+                <a:cubicBezTo>
+                  <a:pt x="12810" y="5990"/>
+                  <a:pt x="13120" y="6700"/>
+                  <a:pt x="13120" y="7580"/>
+                </a:cubicBezTo>
+                <a:cubicBezTo>
+                  <a:pt x="13120" y="10650"/>
+                  <a:pt x="11250" y="11330"/>
+                  <a:pt x="9470" y="11530"/>
+                </a:cubicBezTo>
+                <a:cubicBezTo>
+                  <a:pt x="9760" y="11780"/>
+                  <a:pt x="10010" y="12260"/>
+                  <a:pt x="10010" y="13010"/>
+                </a:cubicBezTo>
+                <a:cubicBezTo>
+                  <a:pt x="10010" y="14080"/>
+                  <a:pt x="10000" y="14940"/>
+                  <a:pt x="10000" y="15210"/>
+                </a:cubicBezTo>
+                <a:cubicBezTo>
+                  <a:pt x="10000" y="15420"/>
+                  <a:pt x="10150" y="15670"/>
+                  <a:pt x="10550" y="15590"/>
+                </a:cubicBezTo>
+                <a:cubicBezTo>
+                  <a:pt x="11604" y="15234"/>
+                  <a:pt x="12572" y="14663"/>
+                  <a:pt x="13394" y="13912"/>
+                </a:cubicBezTo>
+                <a:cubicBezTo>
+                  <a:pt x="14215" y="13162"/>
+                  <a:pt x="14870" y="12248"/>
+                  <a:pt x="15319" y="11231"/>
+                </a:cubicBezTo>
+                <a:cubicBezTo>
+                  <a:pt x="15768" y="10213"/>
+                  <a:pt x="16000" y="9112"/>
+                  <a:pt x="16000" y="8000"/>
+                </a:cubicBezTo>
+                <a:cubicBezTo>
+                  <a:pt x="16000" y="3580"/>
+                  <a:pt x="12420" y="0"/>
+                  <a:pt x="8000" y="0"/>
+                </a:cubicBezTo>
+                <a:close/>
+              </a:path>
+            </a:pathLst>
+          </a:custGeom>
+          <a:solidFill>
+            <a:srgbClr val="101411"/>
+          </a:solidFill>
+          <a:ln>
+            <a:noFill/>
+          </a:ln>
+        </p:spPr>
+        <p:style>
+          <a:lnRef idx="1">
+            <a:schemeClr val="accent1"/>
+          </a:lnRef>
+          <a:fillRef idx="3">
+            <a:schemeClr val="accent1"/>
+          </a:fillRef>
+          <a:effectRef idx="2">
+            <a:schemeClr val="accent1"/>
+          </a:effectRef>
+          <a:fontRef idx="minor">
+            <a:schemeClr val="lt1"/>
+          </a:fontRef>
+        </p:style>
+        <p:txBody>
+          <a:bodyPr rtlCol="0" anchor="ctr"/>
+          <a:lstStyle/>
+          <a:p>
+            <a:pPr algn="ctr"/>
+          </a:p>
+        </p:txBody>
+      </p:sp>
+      <p:sp>
+        <p:nvSpPr>
+          <p:cNvPr id="5" name="Bearing  |  GitHub Copilot App workflow"/>
+          <p:cNvSpPr txBox="1"/>
+          <p:nvPr/>
+        </p:nvSpPr>
+        <p:spPr>
+          <a:xfrm>
+            <a:off x="914400" y="6428232"/>
+            <a:ext cx="7726679" cy="201168"/>
+          </a:xfrm>
+          <a:prstGeom prst="rect">
+            <a:avLst/>
+          </a:prstGeom>
+          <a:noFill/>
+        </p:spPr>
+        <p:txBody>
+          <a:bodyPr wrap="square" lIns="0" rIns="0" tIns="0" bIns="0">
+            <a:spAutoFit/>
+          </a:bodyPr>
+          <a:lstStyle/>
+          <a:p>
+            <a:pPr>
+              <a:lnSpc>
+                <a:spcPct val="107000"/>
+              </a:lnSpc>
+              <a:spcAft>
+                <a:spcPts val="500"/>
+              </a:spcAft>
+            </a:pPr>
+            <a:r>
+              <a:rPr sz="1000" b="0">
+                <a:solidFill>
+                  <a:srgbClr val="232925"/>
+                </a:solidFill>
+                <a:latin typeface="Arial"/>
+              </a:rPr>
+              <a:t>Bearing  |  GitHub Copilot App workflow</a:t>
+            </a:r>
+          </a:p>
+        </p:txBody>
+      </p:sp>
+      <p:sp>
+        <p:nvSpPr>
+          <p:cNvPr id="6" name="15 / 17"/>
+          <p:cNvSpPr txBox="1"/>
+          <p:nvPr/>
+        </p:nvSpPr>
+        <p:spPr>
+          <a:xfrm>
+            <a:off x="10744200" y="6428232"/>
+            <a:ext cx="822960" cy="201168"/>
+          </a:xfrm>
+          <a:prstGeom prst="rect">
+            <a:avLst/>
+          </a:prstGeom>
+          <a:noFill/>
+        </p:spPr>
+        <p:txBody>
+          <a:bodyPr wrap="square" lIns="0" rIns="0" tIns="0" bIns="0">
+            <a:spAutoFit/>
+          </a:bodyPr>
+          <a:lstStyle/>
+          <a:p>
+            <a:pPr>
+              <a:lnSpc>
+                <a:spcPct val="107000"/>
+              </a:lnSpc>
+              <a:spcAft>
+                <a:spcPts val="500"/>
+              </a:spcAft>
+            </a:pPr>
+            <a:r>
+              <a:rPr sz="1000" b="0">
+                <a:solidFill>
+                  <a:srgbClr val="232925"/>
+                </a:solidFill>
+                <a:latin typeface="Arial"/>
+              </a:rPr>
+              <a:t>15 / 17</a:t>
+            </a:r>
+          </a:p>
+        </p:txBody>
+      </p:sp>
+      <p:sp>
+        <p:nvSpPr>
+          <p:cNvPr id="7" name="Rectangle 6"/>
+          <p:cNvSpPr/>
+          <p:nvPr/>
+        </p:nvSpPr>
+        <p:spPr>
+          <a:xfrm>
+            <a:off x="594360" y="1627632"/>
+            <a:ext cx="10972800" cy="548640"/>
+          </a:xfrm>
+          <a:prstGeom prst="rect">
+            <a:avLst/>
+          </a:prstGeom>
+          <a:solidFill>
+            <a:srgbClr val="101411"/>
+          </a:solidFill>
+          <a:ln>
+            <a:noFill/>
+          </a:ln>
+        </p:spPr>
+        <p:style>
+          <a:lnRef idx="1">
+            <a:schemeClr val="accent1"/>
+          </a:lnRef>
+          <a:fillRef idx="3">
+            <a:schemeClr val="accent1"/>
+          </a:fillRef>
+          <a:effectRef idx="2">
+            <a:schemeClr val="accent1"/>
+          </a:effectRef>
+          <a:fontRef idx="minor">
+            <a:schemeClr val="lt1"/>
+          </a:fontRef>
+        </p:style>
+        <p:txBody>
+          <a:bodyPr rtlCol="0" anchor="ctr"/>
+          <a:lstStyle/>
+          <a:p>
+            <a:pPr algn="ctr"/>
+          </a:p>
+        </p:txBody>
+      </p:sp>
+      <p:sp>
+        <p:nvSpPr>
+          <p:cNvPr id="8" name="Audience"/>
+          <p:cNvSpPr txBox="1"/>
+          <p:nvPr/>
+        </p:nvSpPr>
+        <p:spPr>
+          <a:xfrm>
+            <a:off x="704088" y="1755648"/>
+            <a:ext cx="2194560" cy="320040"/>
+          </a:xfrm>
+          <a:prstGeom prst="rect">
+            <a:avLst/>
+          </a:prstGeom>
+          <a:noFill/>
+        </p:spPr>
+        <p:txBody>
+          <a:bodyPr wrap="square" lIns="0" rIns="0" tIns="0" bIns="0">
+            <a:spAutoFit/>
+          </a:bodyPr>
+          <a:lstStyle/>
+          <a:p>
+            <a:pPr>
+              <a:lnSpc>
+                <a:spcPct val="107000"/>
+              </a:lnSpc>
+              <a:spcAft>
+                <a:spcPts val="500"/>
+              </a:spcAft>
+            </a:pPr>
+            <a:r>
+              <a:rPr sz="1700" b="1">
+                <a:solidFill>
+                  <a:srgbClr val="FFFFFF"/>
+                </a:solidFill>
+                <a:latin typeface="Arial"/>
+              </a:rPr>
+              <a:t>Audience</a:t>
+            </a:r>
+          </a:p>
+        </p:txBody>
+      </p:sp>
+      <p:sp>
+        <p:nvSpPr>
+          <p:cNvPr id="9" name="How they use it"/>
+          <p:cNvSpPr txBox="1"/>
+          <p:nvPr/>
+        </p:nvSpPr>
+        <p:spPr>
+          <a:xfrm>
+            <a:off x="3108960" y="1755648"/>
+            <a:ext cx="3474720" cy="320040"/>
+          </a:xfrm>
+          <a:prstGeom prst="rect">
+            <a:avLst/>
+          </a:prstGeom>
+          <a:noFill/>
+        </p:spPr>
+        <p:txBody>
+          <a:bodyPr wrap="square" lIns="0" rIns="0" tIns="0" bIns="0">
+            <a:spAutoFit/>
+          </a:bodyPr>
+          <a:lstStyle/>
+          <a:p>
+            <a:pPr>
+              <a:lnSpc>
+                <a:spcPct val="107000"/>
+              </a:lnSpc>
+              <a:spcAft>
+                <a:spcPts val="500"/>
+              </a:spcAft>
+            </a:pPr>
+            <a:r>
+              <a:rPr sz="1700" b="1">
+                <a:solidFill>
+                  <a:srgbClr val="FFFFFF"/>
+                </a:solidFill>
+                <a:latin typeface="Arial"/>
+              </a:rPr>
+              <a:t>How they use it</a:t>
+            </a:r>
+          </a:p>
+        </p:txBody>
+      </p:sp>
+      <p:sp>
+        <p:nvSpPr>
+          <p:cNvPr id="10" name="Value"/>
+          <p:cNvSpPr txBox="1"/>
+          <p:nvPr/>
+        </p:nvSpPr>
+        <p:spPr>
+          <a:xfrm>
+            <a:off x="6711696" y="1755648"/>
+            <a:ext cx="3657600" cy="320040"/>
+          </a:xfrm>
+          <a:prstGeom prst="rect">
+            <a:avLst/>
+          </a:prstGeom>
+          <a:noFill/>
+        </p:spPr>
+        <p:txBody>
+          <a:bodyPr wrap="square" lIns="0" rIns="0" tIns="0" bIns="0">
+            <a:spAutoFit/>
+          </a:bodyPr>
+          <a:lstStyle/>
+          <a:p>
+            <a:pPr>
+              <a:lnSpc>
+                <a:spcPct val="107000"/>
+              </a:lnSpc>
+              <a:spcAft>
+                <a:spcPts val="500"/>
+              </a:spcAft>
+            </a:pPr>
+            <a:r>
+              <a:rPr sz="1700" b="1">
+                <a:solidFill>
+                  <a:srgbClr val="FFFFFF"/>
+                </a:solidFill>
+                <a:latin typeface="Arial"/>
+              </a:rPr>
+              <a:t>Value</a:t>
+            </a:r>
+          </a:p>
+        </p:txBody>
+      </p:sp>
+      <p:sp>
+        <p:nvSpPr>
+          <p:cNvPr id="11" name="Status"/>
+          <p:cNvSpPr txBox="1"/>
+          <p:nvPr/>
+        </p:nvSpPr>
+        <p:spPr>
+          <a:xfrm>
+            <a:off x="10579607" y="1755648"/>
+            <a:ext cx="877824" cy="320040"/>
+          </a:xfrm>
+          <a:prstGeom prst="rect">
+            <a:avLst/>
+          </a:prstGeom>
+          <a:noFill/>
+        </p:spPr>
+        <p:txBody>
+          <a:bodyPr wrap="square" lIns="0" rIns="0" tIns="0" bIns="0">
+            <a:spAutoFit/>
+          </a:bodyPr>
+          <a:lstStyle/>
+          <a:p>
+            <a:pPr>
+              <a:lnSpc>
+                <a:spcPct val="107000"/>
+              </a:lnSpc>
+              <a:spcAft>
+                <a:spcPts val="500"/>
+              </a:spcAft>
+            </a:pPr>
+            <a:r>
+              <a:rPr sz="1700" b="1">
+                <a:solidFill>
+                  <a:srgbClr val="FFFFFF"/>
+                </a:solidFill>
+                <a:latin typeface="Arial"/>
+              </a:rPr>
+              <a:t>Status</a:t>
+            </a:r>
+          </a:p>
+        </p:txBody>
+      </p:sp>
+      <p:sp>
+        <p:nvSpPr>
+          <p:cNvPr id="12" name="Rectangle 11"/>
+          <p:cNvSpPr/>
+          <p:nvPr/>
+        </p:nvSpPr>
+        <p:spPr>
+          <a:xfrm>
+            <a:off x="594360" y="2988259"/>
+            <a:ext cx="10972800" cy="10972"/>
+          </a:xfrm>
+          <a:prstGeom prst="rect">
+            <a:avLst/>
+          </a:prstGeom>
+          <a:solidFill>
+            <a:srgbClr val="E4EBE6"/>
+          </a:solidFill>
+          <a:ln>
+            <a:noFill/>
+          </a:ln>
+        </p:spPr>
+        <p:style>
+          <a:lnRef idx="1">
+            <a:schemeClr val="accent1"/>
+          </a:lnRef>
+          <a:fillRef idx="3">
+            <a:schemeClr val="accent1"/>
+          </a:fillRef>
+          <a:effectRef idx="2">
+            <a:schemeClr val="accent1"/>
+          </a:effectRef>
+          <a:fontRef idx="minor">
+            <a:schemeClr val="lt1"/>
+          </a:fontRef>
+        </p:style>
+        <p:txBody>
+          <a:bodyPr rtlCol="0" anchor="ctr"/>
+          <a:lstStyle/>
+          <a:p>
+            <a:pPr algn="ctr"/>
+          </a:p>
+        </p:txBody>
+      </p:sp>
+      <p:sp>
+        <p:nvSpPr>
+          <p:cNvPr id="13" name="Account teams"/>
+          <p:cNvSpPr txBox="1"/>
+          <p:nvPr/>
+        </p:nvSpPr>
+        <p:spPr>
+          <a:xfrm>
+            <a:off x="704088" y="2286000"/>
+            <a:ext cx="2194560" cy="640080"/>
+          </a:xfrm>
+          <a:prstGeom prst="rect">
+            <a:avLst/>
+          </a:prstGeom>
+          <a:noFill/>
+        </p:spPr>
+        <p:txBody>
+          <a:bodyPr wrap="square" lIns="0" rIns="0" tIns="0" bIns="0">
+            <a:spAutoFit/>
+          </a:bodyPr>
+          <a:lstStyle/>
+          <a:p>
+            <a:pPr>
+              <a:lnSpc>
+                <a:spcPct val="107000"/>
+              </a:lnSpc>
+              <a:spcAft>
+                <a:spcPts val="500"/>
+              </a:spcAft>
+            </a:pPr>
+            <a:r>
+              <a:rPr sz="1500" b="1">
+                <a:solidFill>
+                  <a:srgbClr val="101411"/>
+                </a:solidFill>
+                <a:latin typeface="Arial"/>
+              </a:rPr>
+              <a:t>Account teams</a:t>
+            </a:r>
+          </a:p>
+        </p:txBody>
+      </p:sp>
+      <p:sp>
+        <p:nvSpPr>
+          <p:cNvPr id="14" name="Frame a one-service pilot with the customer: agree the service, owner and review gate."/>
+          <p:cNvSpPr txBox="1"/>
+          <p:nvPr/>
+        </p:nvSpPr>
+        <p:spPr>
+          <a:xfrm>
+            <a:off x="3108960" y="2286000"/>
+            <a:ext cx="3474720" cy="640080"/>
+          </a:xfrm>
+          <a:prstGeom prst="rect">
+            <a:avLst/>
+          </a:prstGeom>
+          <a:noFill/>
+        </p:spPr>
+        <p:txBody>
+          <a:bodyPr wrap="square" lIns="0" rIns="0" tIns="0" bIns="0">
+            <a:spAutoFit/>
+          </a:bodyPr>
+          <a:lstStyle/>
+          <a:p>
+            <a:pPr>
+              <a:lnSpc>
+                <a:spcPct val="107000"/>
+              </a:lnSpc>
+              <a:spcAft>
+                <a:spcPts val="500"/>
+              </a:spcAft>
+            </a:pPr>
+            <a:r>
+              <a:rPr sz="1500" b="0">
+                <a:solidFill>
+                  <a:srgbClr val="232925"/>
+                </a:solidFill>
+                <a:latin typeface="Arial"/>
+              </a:rPr>
+              <a:t>Frame a one-service pilot with the customer: agree the service, owner and review gate.</a:t>
+            </a:r>
+          </a:p>
+        </p:txBody>
+      </p:sp>
+      <p:sp>
+        <p:nvSpPr>
+          <p:cNvPr id="15" name="A pilot the customer can verify, not just a pitch."/>
+          <p:cNvSpPr txBox="1"/>
+          <p:nvPr/>
+        </p:nvSpPr>
+        <p:spPr>
+          <a:xfrm>
+            <a:off x="6711696" y="2286000"/>
+            <a:ext cx="3657600" cy="640080"/>
+          </a:xfrm>
+          <a:prstGeom prst="rect">
+            <a:avLst/>
+          </a:prstGeom>
+          <a:noFill/>
+        </p:spPr>
+        <p:txBody>
+          <a:bodyPr wrap="square" lIns="0" rIns="0" tIns="0" bIns="0">
+            <a:spAutoFit/>
+          </a:bodyPr>
+          <a:lstStyle/>
+          <a:p>
+            <a:pPr>
+              <a:lnSpc>
+                <a:spcPct val="107000"/>
+              </a:lnSpc>
+              <a:spcAft>
+                <a:spcPts val="500"/>
+              </a:spcAft>
+            </a:pPr>
+            <a:r>
+              <a:rPr sz="1500" b="0">
+                <a:solidFill>
+                  <a:srgbClr val="232925"/>
+                </a:solidFill>
+                <a:latin typeface="Arial"/>
+              </a:rPr>
+              <a:t>A pilot the customer can verify, not just a pitch.</a:t>
+            </a:r>
+          </a:p>
+        </p:txBody>
+      </p:sp>
+      <p:sp>
+        <p:nvSpPr>
+          <p:cNvPr id="16" name="Chip: Proposed"/>
+          <p:cNvSpPr/>
+          <p:nvPr/>
+        </p:nvSpPr>
+        <p:spPr>
+          <a:xfrm>
+            <a:off x="10579607" y="2382012"/>
+            <a:ext cx="822959" cy="274320"/>
+          </a:xfrm>
+          <a:prstGeom prst="roundRect">
+            <a:avLst/>
+          </a:prstGeom>
+          <a:solidFill>
+            <a:srgbClr val="8534F3"/>
+          </a:solidFill>
+          <a:ln>
+            <a:noFill/>
+          </a:ln>
+        </p:spPr>
+        <p:style>
+          <a:lnRef idx="1">
+            <a:schemeClr val="accent1"/>
+          </a:lnRef>
+          <a:fillRef idx="3">
+            <a:schemeClr val="accent1"/>
+          </a:fillRef>
+          <a:effectRef idx="2">
+            <a:schemeClr val="accent1"/>
+          </a:effectRef>
+          <a:fontRef idx="minor">
+            <a:schemeClr val="lt1"/>
+          </a:fontRef>
+        </p:style>
+        <p:txBody>
+          <a:bodyPr rtlCol="0" anchor="ctr" lIns="36576" rIns="36576" tIns="0" bIns="0" wrap="square"/>
+          <a:lstStyle/>
+          <a:p>
+            <a:pPr algn="ctr"/>
+            <a:r>
+              <a:rPr sz="1200" b="1">
+                <a:solidFill>
+                  <a:srgbClr val="FFFFFF"/>
+                </a:solidFill>
+                <a:latin typeface="Arial"/>
+              </a:rPr>
+              <a:t>Proposed</a:t>
+            </a:r>
+          </a:p>
+        </p:txBody>
+      </p:sp>
+      <p:sp>
+        <p:nvSpPr>
+          <p:cNvPr id="17" name="Rectangle 16"/>
+          <p:cNvSpPr/>
+          <p:nvPr/>
+        </p:nvSpPr>
+        <p:spPr>
+          <a:xfrm>
+            <a:off x="594360" y="3811219"/>
+            <a:ext cx="10972800" cy="10972"/>
+          </a:xfrm>
+          <a:prstGeom prst="rect">
+            <a:avLst/>
+          </a:prstGeom>
+          <a:solidFill>
+            <a:srgbClr val="E4EBE6"/>
+          </a:solidFill>
+          <a:ln>
+            <a:noFill/>
+          </a:ln>
+        </p:spPr>
+        <p:style>
+          <a:lnRef idx="1">
+            <a:schemeClr val="accent1"/>
+          </a:lnRef>
+          <a:fillRef idx="3">
+            <a:schemeClr val="accent1"/>
+          </a:fillRef>
+          <a:effectRef idx="2">
+            <a:schemeClr val="accent1"/>
+          </a:effectRef>
+          <a:fontRef idx="minor">
+            <a:schemeClr val="lt1"/>
+          </a:fontRef>
+        </p:style>
+        <p:txBody>
+          <a:bodyPr rtlCol="0" anchor="ctr"/>
+          <a:lstStyle/>
+          <a:p>
+            <a:pPr algn="ctr"/>
+          </a:p>
+        </p:txBody>
+      </p:sp>
+      <p:sp>
+        <p:nvSpPr>
+          <p:cNvPr id="18" name="Customer success"/>
+          <p:cNvSpPr txBox="1"/>
+          <p:nvPr/>
+        </p:nvSpPr>
+        <p:spPr>
+          <a:xfrm>
+            <a:off x="704088" y="3108960"/>
+            <a:ext cx="2194560" cy="640080"/>
+          </a:xfrm>
+          <a:prstGeom prst="rect">
+            <a:avLst/>
+          </a:prstGeom>
+          <a:noFill/>
+        </p:spPr>
+        <p:txBody>
+          <a:bodyPr wrap="square" lIns="0" rIns="0" tIns="0" bIns="0">
+            <a:spAutoFit/>
+          </a:bodyPr>
+          <a:lstStyle/>
+          <a:p>
+            <a:pPr>
+              <a:lnSpc>
+                <a:spcPct val="107000"/>
+              </a:lnSpc>
+              <a:spcAft>
+                <a:spcPts val="500"/>
+              </a:spcAft>
+            </a:pPr>
+            <a:r>
+              <a:rPr sz="1500" b="1">
+                <a:solidFill>
+                  <a:srgbClr val="101411"/>
+                </a:solidFill>
+                <a:latin typeface="Arial"/>
+              </a:rPr>
+              <a:t>Customer success</a:t>
+            </a:r>
+          </a:p>
+        </p:txBody>
+      </p:sp>
+      <p:sp>
+        <p:nvSpPr>
+          <p:cNvPr id="19" name="Run today’s guide with the service owner; log gaps and unavailable sections."/>
+          <p:cNvSpPr txBox="1"/>
+          <p:nvPr/>
+        </p:nvSpPr>
+        <p:spPr>
+          <a:xfrm>
+            <a:off x="3108960" y="3108960"/>
+            <a:ext cx="3474720" cy="640080"/>
+          </a:xfrm>
+          <a:prstGeom prst="rect">
+            <a:avLst/>
+          </a:prstGeom>
+          <a:noFill/>
+        </p:spPr>
+        <p:txBody>
+          <a:bodyPr wrap="square" lIns="0" rIns="0" tIns="0" bIns="0">
+            <a:spAutoFit/>
+          </a:bodyPr>
+          <a:lstStyle/>
+          <a:p>
+            <a:pPr>
+              <a:lnSpc>
+                <a:spcPct val="107000"/>
+              </a:lnSpc>
+              <a:spcAft>
+                <a:spcPts val="500"/>
+              </a:spcAft>
+            </a:pPr>
+            <a:r>
+              <a:rPr sz="1500" b="0">
+                <a:solidFill>
+                  <a:srgbClr val="232925"/>
+                </a:solidFill>
+                <a:latin typeface="Arial"/>
+              </a:rPr>
+              <a:t>Run today’s guide with the service owner; log gaps and unavailable sections.</a:t>
+            </a:r>
+          </a:p>
+        </p:txBody>
+      </p:sp>
+      <p:sp>
+        <p:nvSpPr>
+          <p:cNvPr id="20" name="Gaps surface early; owners review instead of re-explaining."/>
+          <p:cNvSpPr txBox="1"/>
+          <p:nvPr/>
+        </p:nvSpPr>
+        <p:spPr>
+          <a:xfrm>
+            <a:off x="6711696" y="3108960"/>
+            <a:ext cx="3657600" cy="640080"/>
+          </a:xfrm>
+          <a:prstGeom prst="rect">
+            <a:avLst/>
+          </a:prstGeom>
+          <a:noFill/>
+        </p:spPr>
+        <p:txBody>
+          <a:bodyPr wrap="square" lIns="0" rIns="0" tIns="0" bIns="0">
+            <a:spAutoFit/>
+          </a:bodyPr>
+          <a:lstStyle/>
+          <a:p>
+            <a:pPr>
+              <a:lnSpc>
+                <a:spcPct val="107000"/>
+              </a:lnSpc>
+              <a:spcAft>
+                <a:spcPts val="500"/>
+              </a:spcAft>
+            </a:pPr>
+            <a:r>
+              <a:rPr sz="1500" b="0">
+                <a:solidFill>
+                  <a:srgbClr val="232925"/>
+                </a:solidFill>
+                <a:latin typeface="Arial"/>
+              </a:rPr>
+              <a:t>Gaps surface early; owners review instead of re-explaining.</a:t>
+            </a:r>
+          </a:p>
+        </p:txBody>
+      </p:sp>
+      <p:sp>
+        <p:nvSpPr>
+          <p:cNvPr id="21" name="Chip: Emerging"/>
+          <p:cNvSpPr/>
+          <p:nvPr/>
+        </p:nvSpPr>
+        <p:spPr>
+          <a:xfrm>
+            <a:off x="10579607" y="3204972"/>
+            <a:ext cx="822959" cy="274320"/>
+          </a:xfrm>
+          <a:prstGeom prst="roundRect">
+            <a:avLst/>
+          </a:prstGeom>
+          <a:solidFill>
+            <a:srgbClr val="101411"/>
+          </a:solidFill>
+          <a:ln>
+            <a:noFill/>
+          </a:ln>
+        </p:spPr>
+        <p:style>
+          <a:lnRef idx="1">
+            <a:schemeClr val="accent1"/>
+          </a:lnRef>
+          <a:fillRef idx="3">
+            <a:schemeClr val="accent1"/>
+          </a:fillRef>
+          <a:effectRef idx="2">
+            <a:schemeClr val="accent1"/>
+          </a:effectRef>
+          <a:fontRef idx="minor">
+            <a:schemeClr val="lt1"/>
+          </a:fontRef>
+        </p:style>
+        <p:txBody>
+          <a:bodyPr rtlCol="0" anchor="ctr" lIns="36576" rIns="36576" tIns="0" bIns="0" wrap="square"/>
+          <a:lstStyle/>
+          <a:p>
+            <a:pPr algn="ctr"/>
+            <a:r>
+              <a:rPr sz="1200" b="1">
+                <a:solidFill>
+                  <a:srgbClr val="FFFFFF"/>
+                </a:solidFill>
+                <a:latin typeface="Arial"/>
+              </a:rPr>
+              <a:t>Emerging</a:t>
+            </a:r>
+          </a:p>
+        </p:txBody>
+      </p:sp>
+      <p:sp>
+        <p:nvSpPr>
+          <p:cNvPr id="22" name="Rectangle 21"/>
+          <p:cNvSpPr/>
+          <p:nvPr/>
+        </p:nvSpPr>
+        <p:spPr>
+          <a:xfrm>
+            <a:off x="594360" y="4634179"/>
+            <a:ext cx="10972800" cy="10972"/>
+          </a:xfrm>
+          <a:prstGeom prst="rect">
+            <a:avLst/>
+          </a:prstGeom>
+          <a:solidFill>
+            <a:srgbClr val="E4EBE6"/>
+          </a:solidFill>
+          <a:ln>
+            <a:noFill/>
+          </a:ln>
+        </p:spPr>
+        <p:style>
+          <a:lnRef idx="1">
+            <a:schemeClr val="accent1"/>
+          </a:lnRef>
+          <a:fillRef idx="3">
+            <a:schemeClr val="accent1"/>
+          </a:fillRef>
+          <a:effectRef idx="2">
+            <a:schemeClr val="accent1"/>
+          </a:effectRef>
+          <a:fontRef idx="minor">
+            <a:schemeClr val="lt1"/>
+          </a:fontRef>
+        </p:style>
+        <p:txBody>
+          <a:bodyPr rtlCol="0" anchor="ctr"/>
+          <a:lstStyle/>
+          <a:p>
+            <a:pPr algn="ctr"/>
+          </a:p>
+        </p:txBody>
+      </p:sp>
+      <p:sp>
+        <p:nvSpPr>
+          <p:cNvPr id="23" name="Solution sales"/>
+          <p:cNvSpPr txBox="1"/>
+          <p:nvPr/>
+        </p:nvSpPr>
+        <p:spPr>
+          <a:xfrm>
+            <a:off x="704088" y="3931920"/>
+            <a:ext cx="2194560" cy="640080"/>
+          </a:xfrm>
+          <a:prstGeom prst="rect">
+            <a:avLst/>
+          </a:prstGeom>
+          <a:noFill/>
+        </p:spPr>
+        <p:txBody>
+          <a:bodyPr wrap="square" lIns="0" rIns="0" tIns="0" bIns="0">
+            <a:spAutoFit/>
+          </a:bodyPr>
+          <a:lstStyle/>
+          <a:p>
+            <a:pPr>
+              <a:lnSpc>
+                <a:spcPct val="107000"/>
+              </a:lnSpc>
+              <a:spcAft>
+                <a:spcPts val="500"/>
+              </a:spcAft>
+            </a:pPr>
+            <a:r>
+              <a:rPr sz="1500" b="1">
+                <a:solidFill>
+                  <a:srgbClr val="101411"/>
+                </a:solidFill>
+                <a:latin typeface="Arial"/>
+              </a:rPr>
+              <a:t>Solution sales</a:t>
+            </a:r>
+          </a:p>
+        </p:txBody>
+      </p:sp>
+      <p:sp>
+        <p:nvSpPr>
+          <p:cNvPr id="24" name="Build a cited map of a customer service before the technical deep-dive."/>
+          <p:cNvSpPr txBox="1"/>
+          <p:nvPr/>
+        </p:nvSpPr>
+        <p:spPr>
+          <a:xfrm>
+            <a:off x="3108960" y="3931920"/>
+            <a:ext cx="3474720" cy="640080"/>
+          </a:xfrm>
+          <a:prstGeom prst="rect">
+            <a:avLst/>
+          </a:prstGeom>
+          <a:noFill/>
+        </p:spPr>
+        <p:txBody>
+          <a:bodyPr wrap="square" lIns="0" rIns="0" tIns="0" bIns="0">
+            <a:spAutoFit/>
+          </a:bodyPr>
+          <a:lstStyle/>
+          <a:p>
+            <a:pPr>
+              <a:lnSpc>
+                <a:spcPct val="107000"/>
+              </a:lnSpc>
+              <a:spcAft>
+                <a:spcPts val="500"/>
+              </a:spcAft>
+            </a:pPr>
+            <a:r>
+              <a:rPr sz="1500" b="0">
+                <a:solidFill>
+                  <a:srgbClr val="232925"/>
+                </a:solidFill>
+                <a:latin typeface="Arial"/>
+              </a:rPr>
+              <a:t>Build a cited map of a customer service before the technical deep-dive.</a:t>
+            </a:r>
+          </a:p>
+        </p:txBody>
+      </p:sp>
+      <p:sp>
+        <p:nvSpPr>
+          <p:cNvPr id="25" name="Go into the session with sources, not discovery questions."/>
+          <p:cNvSpPr txBox="1"/>
+          <p:nvPr/>
+        </p:nvSpPr>
+        <p:spPr>
+          <a:xfrm>
+            <a:off x="6711696" y="3931920"/>
+            <a:ext cx="3657600" cy="640080"/>
+          </a:xfrm>
+          <a:prstGeom prst="rect">
+            <a:avLst/>
+          </a:prstGeom>
+          <a:noFill/>
+        </p:spPr>
+        <p:txBody>
+          <a:bodyPr wrap="square" lIns="0" rIns="0" tIns="0" bIns="0">
+            <a:spAutoFit/>
+          </a:bodyPr>
+          <a:lstStyle/>
+          <a:p>
+            <a:pPr>
+              <a:lnSpc>
+                <a:spcPct val="107000"/>
+              </a:lnSpc>
+              <a:spcAft>
+                <a:spcPts val="500"/>
+              </a:spcAft>
+            </a:pPr>
+            <a:r>
+              <a:rPr sz="1500" b="0">
+                <a:solidFill>
+                  <a:srgbClr val="232925"/>
+                </a:solidFill>
+                <a:latin typeface="Arial"/>
+              </a:rPr>
+              <a:t>Go into the session with sources, not discovery questions.</a:t>
+            </a:r>
+          </a:p>
+        </p:txBody>
+      </p:sp>
+      <p:sp>
+        <p:nvSpPr>
+          <p:cNvPr id="26" name="Chip: Proposed"/>
+          <p:cNvSpPr/>
+          <p:nvPr/>
+        </p:nvSpPr>
+        <p:spPr>
+          <a:xfrm>
+            <a:off x="10579607" y="4027932"/>
+            <a:ext cx="822959" cy="274320"/>
+          </a:xfrm>
+          <a:prstGeom prst="roundRect">
+            <a:avLst/>
+          </a:prstGeom>
+          <a:solidFill>
+            <a:srgbClr val="8534F3"/>
+          </a:solidFill>
+          <a:ln>
+            <a:noFill/>
+          </a:ln>
+        </p:spPr>
+        <p:style>
+          <a:lnRef idx="1">
+            <a:schemeClr val="accent1"/>
+          </a:lnRef>
+          <a:fillRef idx="3">
+            <a:schemeClr val="accent1"/>
+          </a:fillRef>
+          <a:effectRef idx="2">
+            <a:schemeClr val="accent1"/>
+          </a:effectRef>
+          <a:fontRef idx="minor">
+            <a:schemeClr val="lt1"/>
+          </a:fontRef>
+        </p:style>
+        <p:txBody>
+          <a:bodyPr rtlCol="0" anchor="ctr" lIns="36576" rIns="36576" tIns="0" bIns="0" wrap="square"/>
+          <a:lstStyle/>
+          <a:p>
+            <a:pPr algn="ctr"/>
+            <a:r>
+              <a:rPr sz="1200" b="1">
+                <a:solidFill>
+                  <a:srgbClr val="FFFFFF"/>
+                </a:solidFill>
+                <a:latin typeface="Arial"/>
+              </a:rPr>
+              <a:t>Proposed</a:t>
+            </a:r>
+          </a:p>
+        </p:txBody>
+      </p:sp>
+      <p:sp>
+        <p:nvSpPr>
+          <p:cNvPr id="27" name="Rectangle 26"/>
+          <p:cNvSpPr/>
+          <p:nvPr/>
+        </p:nvSpPr>
+        <p:spPr>
+          <a:xfrm>
+            <a:off x="594360" y="5457139"/>
+            <a:ext cx="10972800" cy="10972"/>
+          </a:xfrm>
+          <a:prstGeom prst="rect">
+            <a:avLst/>
+          </a:prstGeom>
+          <a:solidFill>
+            <a:srgbClr val="E4EBE6"/>
+          </a:solidFill>
+          <a:ln>
+            <a:noFill/>
+          </a:ln>
+        </p:spPr>
+        <p:style>
+          <a:lnRef idx="1">
+            <a:schemeClr val="accent1"/>
+          </a:lnRef>
+          <a:fillRef idx="3">
+            <a:schemeClr val="accent1"/>
+          </a:fillRef>
+          <a:effectRef idx="2">
+            <a:schemeClr val="accent1"/>
+          </a:effectRef>
+          <a:fontRef idx="minor">
+            <a:schemeClr val="lt1"/>
+          </a:fontRef>
+        </p:style>
+        <p:txBody>
+          <a:bodyPr rtlCol="0" anchor="ctr"/>
+          <a:lstStyle/>
+          <a:p>
+            <a:pPr algn="ctr"/>
+          </a:p>
+        </p:txBody>
+      </p:sp>
+      <p:sp>
+        <p:nvSpPr>
+          <p:cNvPr id="28" name="Developer stakeholders"/>
+          <p:cNvSpPr txBox="1"/>
+          <p:nvPr/>
+        </p:nvSpPr>
+        <p:spPr>
+          <a:xfrm>
+            <a:off x="704088" y="4754880"/>
+            <a:ext cx="2194560" cy="640080"/>
+          </a:xfrm>
+          <a:prstGeom prst="rect">
+            <a:avLst/>
+          </a:prstGeom>
+          <a:noFill/>
+        </p:spPr>
+        <p:txBody>
+          <a:bodyPr wrap="square" lIns="0" rIns="0" tIns="0" bIns="0">
+            <a:spAutoFit/>
+          </a:bodyPr>
+          <a:lstStyle/>
+          <a:p>
+            <a:pPr>
+              <a:lnSpc>
+                <a:spcPct val="107000"/>
+              </a:lnSpc>
+              <a:spcAft>
+                <a:spcPts val="500"/>
+              </a:spcAft>
+            </a:pPr>
+            <a:r>
+              <a:rPr sz="1500" b="1">
+                <a:solidFill>
+                  <a:srgbClr val="101411"/>
+                </a:solidFill>
+                <a:latin typeface="Arial"/>
+              </a:rPr>
+              <a:t>Developer stakeholders</a:t>
+            </a:r>
+          </a:p>
+        </p:txBody>
+      </p:sp>
+      <p:sp>
+        <p:nvSpPr>
+          <p:cNvPr id="29" name="Run /onboard-repo, inspect the cited files, then decide the first task."/>
+          <p:cNvSpPr txBox="1"/>
+          <p:nvPr/>
+        </p:nvSpPr>
+        <p:spPr>
+          <a:xfrm>
+            <a:off x="3108960" y="4754880"/>
+            <a:ext cx="3474720" cy="640080"/>
+          </a:xfrm>
+          <a:prstGeom prst="rect">
+            <a:avLst/>
+          </a:prstGeom>
+          <a:noFill/>
+        </p:spPr>
+        <p:txBody>
+          <a:bodyPr wrap="square" lIns="0" rIns="0" tIns="0" bIns="0">
+            <a:spAutoFit/>
+          </a:bodyPr>
+          <a:lstStyle/>
+          <a:p>
+            <a:pPr>
+              <a:lnSpc>
+                <a:spcPct val="107000"/>
+              </a:lnSpc>
+              <a:spcAft>
+                <a:spcPts val="500"/>
+              </a:spcAft>
+            </a:pPr>
+            <a:r>
+              <a:rPr sz="1500" b="0">
+                <a:solidFill>
+                  <a:srgbClr val="232925"/>
+                </a:solidFill>
+                <a:latin typeface="Arial"/>
+              </a:rPr>
+              <a:t>Run /onboard-repo, inspect the cited files, then decide the first task.</a:t>
+            </a:r>
+          </a:p>
+        </p:txBody>
+      </p:sp>
+      <p:sp>
+        <p:nvSpPr>
+          <p:cNvPr id="30" name="Less repeated discovery; claims to verify, not trust."/>
+          <p:cNvSpPr txBox="1"/>
+          <p:nvPr/>
+        </p:nvSpPr>
+        <p:spPr>
+          <a:xfrm>
+            <a:off x="6711696" y="4754880"/>
+            <a:ext cx="3657600" cy="640080"/>
+          </a:xfrm>
+          <a:prstGeom prst="rect">
+            <a:avLst/>
+          </a:prstGeom>
+          <a:noFill/>
+        </p:spPr>
+        <p:txBody>
+          <a:bodyPr wrap="square" lIns="0" rIns="0" tIns="0" bIns="0">
+            <a:spAutoFit/>
+          </a:bodyPr>
+          <a:lstStyle/>
+          <a:p>
+            <a:pPr>
+              <a:lnSpc>
+                <a:spcPct val="107000"/>
+              </a:lnSpc>
+              <a:spcAft>
+                <a:spcPts val="500"/>
+              </a:spcAft>
+            </a:pPr>
+            <a:r>
+              <a:rPr sz="1500" b="0">
+                <a:solidFill>
+                  <a:srgbClr val="232925"/>
+                </a:solidFill>
+                <a:latin typeface="Arial"/>
+              </a:rPr>
+              <a:t>Less repeated discovery; claims to verify, not trust.</a:t>
+            </a:r>
+          </a:p>
+        </p:txBody>
+      </p:sp>
+      <p:sp>
+        <p:nvSpPr>
+          <p:cNvPr id="31" name="Chip: Prototype"/>
+          <p:cNvSpPr/>
+          <p:nvPr/>
+        </p:nvSpPr>
+        <p:spPr>
+          <a:xfrm>
+            <a:off x="10579607" y="4850892"/>
+            <a:ext cx="822959" cy="274320"/>
+          </a:xfrm>
+          <a:prstGeom prst="roundRect">
+            <a:avLst/>
+          </a:prstGeom>
+          <a:solidFill>
+            <a:srgbClr val="08872B"/>
+          </a:solidFill>
+          <a:ln>
+            <a:noFill/>
+          </a:ln>
+        </p:spPr>
+        <p:style>
+          <a:lnRef idx="1">
+            <a:schemeClr val="accent1"/>
+          </a:lnRef>
+          <a:fillRef idx="3">
+            <a:schemeClr val="accent1"/>
+          </a:fillRef>
+          <a:effectRef idx="2">
+            <a:schemeClr val="accent1"/>
+          </a:effectRef>
+          <a:fontRef idx="minor">
+            <a:schemeClr val="lt1"/>
+          </a:fontRef>
+        </p:style>
+        <p:txBody>
+          <a:bodyPr rtlCol="0" anchor="ctr" lIns="36576" rIns="36576" tIns="0" bIns="0" wrap="square"/>
+          <a:lstStyle/>
+          <a:p>
+            <a:pPr algn="ctr"/>
+            <a:r>
+              <a:rPr sz="1200" b="1">
+                <a:solidFill>
+                  <a:srgbClr val="FFFFFF"/>
+                </a:solidFill>
+                <a:latin typeface="Arial"/>
+              </a:rPr>
+              <a:t>Prototype</a:t>
+            </a:r>
+          </a:p>
+        </p:txBody>
+      </p:sp>
+      <p:sp>
+        <p:nvSpPr>
+          <p:cNvPr id="37" name="Prototype: implemented in this repository. Emerging: today’s guide reused as-is, not yet validated with this audience. Proposed: not built. Only developer onboarding exists today."/>
+          <p:cNvSpPr txBox="1"/>
+          <p:nvPr/>
+        </p:nvSpPr>
+        <p:spPr>
+          <a:xfrm>
+            <a:off x="594360" y="5733288"/>
+            <a:ext cx="10972800" cy="457200"/>
+          </a:xfrm>
+          <a:prstGeom prst="rect">
+            <a:avLst/>
+          </a:prstGeom>
+          <a:noFill/>
+        </p:spPr>
+        <p:txBody>
+          <a:bodyPr wrap="square" lIns="0" rIns="0" tIns="0" bIns="0">
+            <a:spAutoFit/>
+          </a:bodyPr>
+          <a:lstStyle/>
+          <a:p>
+            <a:pPr>
+              <a:lnSpc>
+                <a:spcPct val="107000"/>
+              </a:lnSpc>
+              <a:spcAft>
+                <a:spcPts val="500"/>
+              </a:spcAft>
+            </a:pPr>
+            <a:r>
+              <a:rPr sz="1400" b="0">
+                <a:solidFill>
+                  <a:srgbClr val="232925"/>
+                </a:solidFill>
+                <a:latin typeface="Arial"/>
+              </a:rPr>
+              <a:t>Prototype: implemented in this repository. Emerging: today’s guide reused as-is, not yet validated with this audience. Proposed: not built. Only developer onboarding exists today.</a:t>
             </a:r>
           </a:p>
         </p:txBody>
@@ -14556,7 +16149,7 @@
       </p:sp>
       <p:sp>
         <p:nvSpPr>
-          <p:cNvPr id="6" name="02 / 16"/>
+          <p:cNvPr id="6" name="02 / 17"/>
           <p:cNvSpPr txBox="1"/>
           <p:nvPr/>
         </p:nvSpPr>
@@ -14591,7 +16184,7 @@
                 </a:solidFill>
                 <a:latin typeface="Arial"/>
               </a:rPr>
-              <a:t>02 / 16</a:t>
+              <a:t>02 / 17</a:t>
             </a:r>
           </a:p>
         </p:txBody>
@@ -15916,7 +17509,7 @@
       </p:sp>
       <p:sp>
         <p:nvSpPr>
-          <p:cNvPr id="6" name="03 / 16"/>
+          <p:cNvPr id="6" name="03 / 17"/>
           <p:cNvSpPr txBox="1"/>
           <p:nvPr/>
         </p:nvSpPr>
@@ -15951,7 +17544,7 @@
                 </a:solidFill>
                 <a:latin typeface="Arial"/>
               </a:rPr>
-              <a:t>03 / 16</a:t>
+              <a:t>03 / 17</a:t>
             </a:r>
           </a:p>
         </p:txBody>
@@ -17406,7 +18999,7 @@
       </p:sp>
       <p:sp>
         <p:nvSpPr>
-          <p:cNvPr id="6" name="04 / 16"/>
+          <p:cNvPr id="6" name="04 / 17"/>
           <p:cNvSpPr txBox="1"/>
           <p:nvPr/>
         </p:nvSpPr>
@@ -17441,7 +19034,7 @@
                 </a:solidFill>
                 <a:latin typeface="Arial"/>
               </a:rPr>
-              <a:t>04 / 16</a:t>
+              <a:t>04 / 17</a:t>
             </a:r>
           </a:p>
         </p:txBody>
@@ -26799,7 +28392,7 @@
       </p:sp>
       <p:sp>
         <p:nvSpPr>
-          <p:cNvPr id="6" name="05 / 16"/>
+          <p:cNvPr id="6" name="05 / 17"/>
           <p:cNvSpPr txBox="1"/>
           <p:nvPr/>
         </p:nvSpPr>
@@ -26834,7 +28427,7 @@
                 </a:solidFill>
                 <a:latin typeface="Arial"/>
               </a:rPr>
-              <a:t>05 / 16</a:t>
+              <a:t>05 / 17</a:t>
             </a:r>
           </a:p>
         </p:txBody>
@@ -27653,7 +29246,7 @@
       </p:sp>
       <p:sp>
         <p:nvSpPr>
-          <p:cNvPr id="6" name="06 / 16"/>
+          <p:cNvPr id="6" name="06 / 17"/>
           <p:cNvSpPr txBox="1"/>
           <p:nvPr/>
         </p:nvSpPr>
@@ -27688,7 +29281,7 @@
                 </a:solidFill>
                 <a:latin typeface="Arial"/>
               </a:rPr>
-              <a:t>06 / 16</a:t>
+              <a:t>06 / 17</a:t>
             </a:r>
           </a:p>
         </p:txBody>
@@ -29035,7 +30628,7 @@
       </p:sp>
       <p:sp>
         <p:nvSpPr>
-          <p:cNvPr id="6" name="07 / 16"/>
+          <p:cNvPr id="6" name="07 / 17"/>
           <p:cNvSpPr txBox="1"/>
           <p:nvPr/>
         </p:nvSpPr>
@@ -29070,7 +30663,7 @@
                 </a:solidFill>
                 <a:latin typeface="Arial"/>
               </a:rPr>
-              <a:t>07 / 16</a:t>
+              <a:t>07 / 17</a:t>
             </a:r>
           </a:p>
         </p:txBody>
@@ -30739,7 +32332,7 @@
       </p:sp>
       <p:sp>
         <p:nvSpPr>
-          <p:cNvPr id="6" name="08 / 16"/>
+          <p:cNvPr id="6" name="08 / 17"/>
           <p:cNvSpPr txBox="1"/>
           <p:nvPr/>
         </p:nvSpPr>
@@ -30774,7 +32367,7 @@
                 </a:solidFill>
                 <a:latin typeface="Arial"/>
               </a:rPr>
-              <a:t>08 / 16</a:t>
+              <a:t>08 / 17</a:t>
             </a:r>
           </a:p>
         </p:txBody>
@@ -32714,7 +34307,7 @@
       </p:sp>
       <p:sp>
         <p:nvSpPr>
-          <p:cNvPr id="6" name="09 / 16"/>
+          <p:cNvPr id="6" name="09 / 17"/>
           <p:cNvSpPr txBox="1"/>
           <p:nvPr/>
         </p:nvSpPr>
@@ -32749,7 +34342,7 @@
                 </a:solidFill>
                 <a:latin typeface="Arial"/>
               </a:rPr>
-              <a:t>09 / 16</a:t>
+              <a:t>09 / 17</a:t>
             </a:r>
           </a:p>
         </p:txBody>

</xml_diff>

<commit_message>
Add delegation and review gates slide to enterprise deck
Co-authored-by: Copilot App <223556219+Copilot@users.noreply.github.com>
Copilot-Session: 1d2ad6a0-8ad1-4ced-8e7f-e31ebce5fcee
</commit_message>
<xml_diff>
--- a/submission/bearing-enterprise-deck.pptx
+++ b/submission/bearing-enterprise-deck.pptx
@@ -8,6 +8,7 @@
     <p:sldId id="256" r:id="rId7"/>
     <p:sldId id="257" r:id="rId9"/>
     <p:sldId id="258" r:id="rId10"/>
+    <p:sldId id="273" r:id="rId99"/>
     <p:sldId id="259" r:id="rId11"/>
     <p:sldId id="260" r:id="rId12"/>
     <p:sldId id="261" r:id="rId13"/>
@@ -5021,7 +5022,7 @@
       </p:sp>
       <p:sp>
         <p:nvSpPr>
-          <p:cNvPr id="6" name="01 / 17"/>
+          <p:cNvPr id="6" name="01 / 18"/>
           <p:cNvSpPr txBox="1"/>
           <p:nvPr/>
         </p:nvSpPr>
@@ -5056,7 +5057,7 @@
                 </a:solidFill>
                 <a:latin typeface="Arial"/>
               </a:rPr>
-              <a:t>01 / 17</a:t>
+              <a:t>01 / 18</a:t>
             </a:r>
           </a:p>
         </p:txBody>
@@ -6313,7 +6314,7 @@
       </p:sp>
       <p:sp>
         <p:nvSpPr>
-          <p:cNvPr id="6" name="10 / 17"/>
+          <p:cNvPr id="6" name="11 / 18"/>
           <p:cNvSpPr txBox="1"/>
           <p:nvPr/>
         </p:nvSpPr>
@@ -6348,7 +6349,7 @@
                 </a:solidFill>
                 <a:latin typeface="Arial"/>
               </a:rPr>
-              <a:t>10 / 17</a:t>
+              <a:t>11 / 18</a:t>
             </a:r>
           </a:p>
         </p:txBody>
@@ -7713,7 +7714,7 @@
       </p:sp>
       <p:sp>
         <p:nvSpPr>
-          <p:cNvPr id="6" name="11 / 17"/>
+          <p:cNvPr id="6" name="12 / 18"/>
           <p:cNvSpPr txBox="1"/>
           <p:nvPr/>
         </p:nvSpPr>
@@ -7748,7 +7749,7 @@
                 </a:solidFill>
                 <a:latin typeface="Arial"/>
               </a:rPr>
-              <a:t>11 / 17</a:t>
+              <a:t>12 / 18</a:t>
             </a:r>
           </a:p>
         </p:txBody>
@@ -8900,7 +8901,7 @@
       </p:sp>
       <p:sp>
         <p:nvSpPr>
-          <p:cNvPr id="6" name="12 / 17"/>
+          <p:cNvPr id="6" name="13 / 18"/>
           <p:cNvSpPr txBox="1"/>
           <p:nvPr/>
         </p:nvSpPr>
@@ -8935,7 +8936,7 @@
                 </a:solidFill>
                 <a:latin typeface="Arial"/>
               </a:rPr>
-              <a:t>12 / 17</a:t>
+              <a:t>13 / 18</a:t>
             </a:r>
           </a:p>
         </p:txBody>
@@ -9776,7 +9777,7 @@
       </p:sp>
       <p:sp>
         <p:nvSpPr>
-          <p:cNvPr id="6" name="13 / 17"/>
+          <p:cNvPr id="6" name="14 / 18"/>
           <p:cNvSpPr txBox="1"/>
           <p:nvPr/>
         </p:nvSpPr>
@@ -9811,7 +9812,7 @@
                 </a:solidFill>
                 <a:latin typeface="Arial"/>
               </a:rPr>
-              <a:t>13 / 17</a:t>
+              <a:t>14 / 18</a:t>
             </a:r>
           </a:p>
         </p:txBody>
@@ -11225,7 +11226,7 @@
       </p:sp>
       <p:sp>
         <p:nvSpPr>
-          <p:cNvPr id="6" name="14 / 17"/>
+          <p:cNvPr id="6" name="15 / 18"/>
           <p:cNvSpPr txBox="1"/>
           <p:nvPr/>
         </p:nvSpPr>
@@ -11260,7 +11261,7 @@
                 </a:solidFill>
                 <a:latin typeface="Arial"/>
               </a:rPr>
-              <a:t>14 / 17</a:t>
+              <a:t>15 / 18</a:t>
             </a:r>
           </a:p>
         </p:txBody>
@@ -12968,7 +12969,7 @@
       </p:sp>
       <p:sp>
         <p:nvSpPr>
-          <p:cNvPr id="6" name="16 / 17"/>
+          <p:cNvPr id="6" name="17 / 18"/>
           <p:cNvSpPr txBox="1"/>
           <p:nvPr/>
         </p:nvSpPr>
@@ -13003,7 +13004,7 @@
                 </a:solidFill>
                 <a:latin typeface="Arial"/>
               </a:rPr>
-              <a:t>16 / 17</a:t>
+              <a:t>17 / 18</a:t>
             </a:r>
           </a:p>
         </p:txBody>
@@ -13765,7 +13766,7 @@
       </p:sp>
       <p:sp>
         <p:nvSpPr>
-          <p:cNvPr id="6" name="17 / 17"/>
+          <p:cNvPr id="6" name="18 / 18"/>
           <p:cNvSpPr txBox="1"/>
           <p:nvPr/>
         </p:nvSpPr>
@@ -13800,7 +13801,7 @@
                 </a:solidFill>
                 <a:latin typeface="Arial"/>
               </a:rPr>
-              <a:t>17 / 17</a:t>
+              <a:t>18 / 18</a:t>
             </a:r>
           </a:p>
         </p:txBody>
@@ -14627,7 +14628,7 @@
       </p:sp>
       <p:sp>
         <p:nvSpPr>
-          <p:cNvPr id="6" name="15 / 17"/>
+          <p:cNvPr id="6" name="16 / 18"/>
           <p:cNvSpPr txBox="1"/>
           <p:nvPr/>
         </p:nvSpPr>
@@ -14662,7 +14663,7 @@
                 </a:solidFill>
                 <a:latin typeface="Arial"/>
               </a:rPr>
-              <a:t>15 / 17</a:t>
+              <a:t>16 / 18</a:t>
             </a:r>
           </a:p>
         </p:txBody>
@@ -15800,6 +15801,1662 @@
                 <a:latin typeface="Arial"/>
               </a:rPr>
               <a:t>Prototype: implemented in this repository. Emerging: today’s guide reused as-is, not yet validated with this audience. Proposed: not built. Only developer onboarding exists today.</a:t>
+            </a:r>
+          </a:p>
+        </p:txBody>
+      </p:sp>
+    </p:spTree>
+  </p:cSld>
+  <p:clrMapOvr>
+    <a:masterClrMapping/>
+  </p:clrMapOvr>
+</p:sld>
+</file>
+
+<file path=ppt/slides/slide18.xml><?xml version="1.0" encoding="utf-8"?>
+<p:sld xmlns:a="http://schemas.openxmlformats.org/drawingml/2006/main" xmlns:p="http://schemas.openxmlformats.org/presentationml/2006/main" xmlns:r="http://schemas.openxmlformats.org/officeDocument/2006/relationships">
+  <p:cSld>
+    <p:bg>
+      <p:bgPr>
+        <a:solidFill>
+          <a:srgbClr val="FFFFFF"/>
+        </a:solidFill>
+        <a:effectLst/>
+      </p:bgPr>
+    </p:bg>
+    <p:spTree>
+      <p:nvGrpSpPr>
+        <p:cNvPr id="1" name=""/>
+        <p:cNvGrpSpPr/>
+        <p:nvPr/>
+      </p:nvGrpSpPr>
+      <p:grpSpPr/>
+      <p:sp>
+        <p:nvSpPr>
+          <p:cNvPr id="2" name="Delegate more. Review where it matters."/>
+          <p:cNvSpPr txBox="1"/>
+          <p:nvPr/>
+        </p:nvSpPr>
+        <p:spPr>
+          <a:xfrm>
+            <a:off x="594360" y="502920"/>
+            <a:ext cx="10972800" cy="1005840"/>
+          </a:xfrm>
+          <a:prstGeom prst="rect">
+            <a:avLst/>
+          </a:prstGeom>
+          <a:noFill/>
+        </p:spPr>
+        <p:txBody>
+          <a:bodyPr wrap="square" lIns="0" rIns="0" tIns="0" bIns="0">
+            <a:spAutoFit/>
+          </a:bodyPr>
+          <a:lstStyle/>
+          <a:p>
+            <a:pPr>
+              <a:lnSpc>
+                <a:spcPct val="107000"/>
+              </a:lnSpc>
+              <a:spcAft>
+                <a:spcPts val="500"/>
+              </a:spcAft>
+            </a:pPr>
+            <a:r>
+              <a:rPr sz="3200" b="1">
+                <a:solidFill>
+                  <a:srgbClr val="101411"/>
+                </a:solidFill>
+                <a:latin typeface="Mona Sans"/>
+              </a:rPr>
+              <a:t>Delegate more. Review where it matters.</a:t>
+            </a:r>
+          </a:p>
+        </p:txBody>
+      </p:sp>
+      <p:sp>
+        <p:nvSpPr>
+          <p:cNvPr id="3" name="Rectangle 2"/>
+          <p:cNvSpPr/>
+          <p:nvPr/>
+        </p:nvSpPr>
+        <p:spPr>
+          <a:xfrm>
+            <a:off x="594360" y="6327648"/>
+            <a:ext cx="10972800" cy="10972"/>
+          </a:xfrm>
+          <a:prstGeom prst="rect">
+            <a:avLst/>
+          </a:prstGeom>
+          <a:solidFill>
+            <a:srgbClr val="E4EBE6"/>
+          </a:solidFill>
+          <a:ln>
+            <a:noFill/>
+          </a:ln>
+        </p:spPr>
+        <p:style>
+          <a:lnRef idx="1">
+            <a:schemeClr val="accent1"/>
+          </a:lnRef>
+          <a:fillRef idx="3">
+            <a:schemeClr val="accent1"/>
+          </a:fillRef>
+          <a:effectRef idx="2">
+            <a:schemeClr val="accent1"/>
+          </a:effectRef>
+          <a:fontRef idx="minor">
+            <a:schemeClr val="lt1"/>
+          </a:fontRef>
+        </p:style>
+        <p:txBody>
+          <a:bodyPr rtlCol="0" anchor="ctr"/>
+          <a:lstStyle/>
+          <a:p>
+            <a:pPr algn="ctr"/>
+          </a:p>
+        </p:txBody>
+      </p:sp>
+      <p:sp>
+        <p:nvSpPr>
+          <p:cNvPr id="4" name="GitHub mark" descr="GitHub logo"/>
+          <p:cNvSpPr/>
+          <p:nvPr/>
+        </p:nvSpPr>
+        <p:spPr>
+          <a:xfrm>
+            <a:off x="594360" y="6419088"/>
+            <a:ext cx="182880" cy="182880"/>
+          </a:xfrm>
+          <a:custGeom>
+            <a:avLst/>
+            <a:gdLst/>
+            <a:ahLst/>
+            <a:cxnLst/>
+            <a:rect l="0" t="0" r="r" b="b"/>
+            <a:pathLst>
+              <a:path w="16000" h="16000">
+                <a:moveTo>
+                  <a:pt x="8000" y="0"/>
+                </a:moveTo>
+                <a:cubicBezTo>
+                  <a:pt x="3580" y="0"/>
+                  <a:pt x="0" y="3580"/>
+                  <a:pt x="0" y="8000"/>
+                </a:cubicBezTo>
+                <a:cubicBezTo>
+                  <a:pt x="0" y="11540"/>
+                  <a:pt x="2290" y="14530"/>
+                  <a:pt x="5470" y="15590"/>
+                </a:cubicBezTo>
+                <a:cubicBezTo>
+                  <a:pt x="5870" y="15660"/>
+                  <a:pt x="6020" y="15420"/>
+                  <a:pt x="6020" y="15210"/>
+                </a:cubicBezTo>
+                <a:cubicBezTo>
+                  <a:pt x="6020" y="15020"/>
+                  <a:pt x="6010" y="14390"/>
+                  <a:pt x="6010" y="13720"/>
+                </a:cubicBezTo>
+                <a:cubicBezTo>
+                  <a:pt x="4000" y="14090"/>
+                  <a:pt x="3480" y="13230"/>
+                  <a:pt x="3320" y="12780"/>
+                </a:cubicBezTo>
+                <a:cubicBezTo>
+                  <a:pt x="3230" y="12550"/>
+                  <a:pt x="2840" y="11840"/>
+                  <a:pt x="2500" y="11650"/>
+                </a:cubicBezTo>
+                <a:cubicBezTo>
+                  <a:pt x="2220" y="11500"/>
+                  <a:pt x="1820" y="11130"/>
+                  <a:pt x="2490" y="11120"/>
+                </a:cubicBezTo>
+                <a:cubicBezTo>
+                  <a:pt x="3120" y="11110"/>
+                  <a:pt x="3570" y="11700"/>
+                  <a:pt x="3720" y="11940"/>
+                </a:cubicBezTo>
+                <a:cubicBezTo>
+                  <a:pt x="4440" y="13150"/>
+                  <a:pt x="5590" y="12810"/>
+                  <a:pt x="6050" y="12600"/>
+                </a:cubicBezTo>
+                <a:cubicBezTo>
+                  <a:pt x="6120" y="12080"/>
+                  <a:pt x="6330" y="11730"/>
+                  <a:pt x="6560" y="11530"/>
+                </a:cubicBezTo>
+                <a:cubicBezTo>
+                  <a:pt x="4780" y="11330"/>
+                  <a:pt x="2920" y="10640"/>
+                  <a:pt x="2920" y="7580"/>
+                </a:cubicBezTo>
+                <a:cubicBezTo>
+                  <a:pt x="2920" y="6710"/>
+                  <a:pt x="3230" y="5990"/>
+                  <a:pt x="3740" y="5430"/>
+                </a:cubicBezTo>
+                <a:cubicBezTo>
+                  <a:pt x="3660" y="5230"/>
+                  <a:pt x="3380" y="4410"/>
+                  <a:pt x="3820" y="3310"/>
+                </a:cubicBezTo>
+                <a:cubicBezTo>
+                  <a:pt x="3820" y="3310"/>
+                  <a:pt x="4490" y="3100"/>
+                  <a:pt x="6020" y="4130"/>
+                </a:cubicBezTo>
+                <a:cubicBezTo>
+                  <a:pt x="6660" y="3950"/>
+                  <a:pt x="7340" y="3860"/>
+                  <a:pt x="8020" y="3860"/>
+                </a:cubicBezTo>
+                <a:cubicBezTo>
+                  <a:pt x="8700" y="3860"/>
+                  <a:pt x="9380" y="3950"/>
+                  <a:pt x="10020" y="4130"/>
+                </a:cubicBezTo>
+                <a:cubicBezTo>
+                  <a:pt x="11550" y="3090"/>
+                  <a:pt x="12220" y="3310"/>
+                  <a:pt x="12220" y="3310"/>
+                </a:cubicBezTo>
+                <a:cubicBezTo>
+                  <a:pt x="12660" y="4410"/>
+                  <a:pt x="12380" y="5230"/>
+                  <a:pt x="12300" y="5430"/>
+                </a:cubicBezTo>
+                <a:cubicBezTo>
+                  <a:pt x="12810" y="5990"/>
+                  <a:pt x="13120" y="6700"/>
+                  <a:pt x="13120" y="7580"/>
+                </a:cubicBezTo>
+                <a:cubicBezTo>
+                  <a:pt x="13120" y="10650"/>
+                  <a:pt x="11250" y="11330"/>
+                  <a:pt x="9470" y="11530"/>
+                </a:cubicBezTo>
+                <a:cubicBezTo>
+                  <a:pt x="9760" y="11780"/>
+                  <a:pt x="10010" y="12260"/>
+                  <a:pt x="10010" y="13010"/>
+                </a:cubicBezTo>
+                <a:cubicBezTo>
+                  <a:pt x="10010" y="14080"/>
+                  <a:pt x="10000" y="14940"/>
+                  <a:pt x="10000" y="15210"/>
+                </a:cubicBezTo>
+                <a:cubicBezTo>
+                  <a:pt x="10000" y="15420"/>
+                  <a:pt x="10150" y="15670"/>
+                  <a:pt x="10550" y="15590"/>
+                </a:cubicBezTo>
+                <a:cubicBezTo>
+                  <a:pt x="11604" y="15234"/>
+                  <a:pt x="12572" y="14663"/>
+                  <a:pt x="13394" y="13912"/>
+                </a:cubicBezTo>
+                <a:cubicBezTo>
+                  <a:pt x="14215" y="13162"/>
+                  <a:pt x="14870" y="12248"/>
+                  <a:pt x="15319" y="11231"/>
+                </a:cubicBezTo>
+                <a:cubicBezTo>
+                  <a:pt x="15768" y="10213"/>
+                  <a:pt x="16000" y="9112"/>
+                  <a:pt x="16000" y="8000"/>
+                </a:cubicBezTo>
+                <a:cubicBezTo>
+                  <a:pt x="16000" y="3580"/>
+                  <a:pt x="12420" y="0"/>
+                  <a:pt x="8000" y="0"/>
+                </a:cubicBezTo>
+                <a:close/>
+              </a:path>
+            </a:pathLst>
+          </a:custGeom>
+          <a:solidFill>
+            <a:srgbClr val="101411"/>
+          </a:solidFill>
+          <a:ln>
+            <a:noFill/>
+          </a:ln>
+        </p:spPr>
+        <p:style>
+          <a:lnRef idx="1">
+            <a:schemeClr val="accent1"/>
+          </a:lnRef>
+          <a:fillRef idx="3">
+            <a:schemeClr val="accent1"/>
+          </a:fillRef>
+          <a:effectRef idx="2">
+            <a:schemeClr val="accent1"/>
+          </a:effectRef>
+          <a:fontRef idx="minor">
+            <a:schemeClr val="lt1"/>
+          </a:fontRef>
+        </p:style>
+        <p:txBody>
+          <a:bodyPr rtlCol="0" anchor="ctr"/>
+          <a:lstStyle/>
+          <a:p>
+            <a:pPr algn="ctr"/>
+          </a:p>
+        </p:txBody>
+      </p:sp>
+      <p:sp>
+        <p:nvSpPr>
+          <p:cNvPr id="5" name="Bearing  |  GitHub Copilot App workflow"/>
+          <p:cNvSpPr txBox="1"/>
+          <p:nvPr/>
+        </p:nvSpPr>
+        <p:spPr>
+          <a:xfrm>
+            <a:off x="914400" y="6428232"/>
+            <a:ext cx="7726679" cy="201168"/>
+          </a:xfrm>
+          <a:prstGeom prst="rect">
+            <a:avLst/>
+          </a:prstGeom>
+          <a:noFill/>
+        </p:spPr>
+        <p:txBody>
+          <a:bodyPr wrap="square" lIns="0" rIns="0" tIns="0" bIns="0">
+            <a:spAutoFit/>
+          </a:bodyPr>
+          <a:lstStyle/>
+          <a:p>
+            <a:pPr>
+              <a:lnSpc>
+                <a:spcPct val="107000"/>
+              </a:lnSpc>
+              <a:spcAft>
+                <a:spcPts val="500"/>
+              </a:spcAft>
+            </a:pPr>
+            <a:r>
+              <a:rPr sz="1000" b="0">
+                <a:solidFill>
+                  <a:srgbClr val="232925"/>
+                </a:solidFill>
+                <a:latin typeface="Arial"/>
+              </a:rPr>
+              <a:t>Bearing  |  GitHub Copilot App workflow</a:t>
+            </a:r>
+          </a:p>
+        </p:txBody>
+      </p:sp>
+      <p:sp>
+        <p:nvSpPr>
+          <p:cNvPr id="6" name="04 / 18"/>
+          <p:cNvSpPr txBox="1"/>
+          <p:nvPr/>
+        </p:nvSpPr>
+        <p:spPr>
+          <a:xfrm>
+            <a:off x="10744200" y="6428232"/>
+            <a:ext cx="822960" cy="201168"/>
+          </a:xfrm>
+          <a:prstGeom prst="rect">
+            <a:avLst/>
+          </a:prstGeom>
+          <a:noFill/>
+        </p:spPr>
+        <p:txBody>
+          <a:bodyPr wrap="square" lIns="0" rIns="0" tIns="0" bIns="0">
+            <a:spAutoFit/>
+          </a:bodyPr>
+          <a:lstStyle/>
+          <a:p>
+            <a:pPr>
+              <a:lnSpc>
+                <a:spcPct val="107000"/>
+              </a:lnSpc>
+              <a:spcAft>
+                <a:spcPts val="500"/>
+              </a:spcAft>
+            </a:pPr>
+            <a:r>
+              <a:rPr sz="1000" b="0">
+                <a:solidFill>
+                  <a:srgbClr val="232925"/>
+                </a:solidFill>
+                <a:latin typeface="Arial"/>
+              </a:rPr>
+              <a:t>04 / 18</a:t>
+            </a:r>
+          </a:p>
+        </p:txBody>
+      </p:sp>
+      <p:sp>
+        <p:nvSpPr>
+          <p:cNvPr id="7" name="Rectangle 6"/>
+          <p:cNvSpPr/>
+          <p:nvPr/>
+        </p:nvSpPr>
+        <p:spPr>
+          <a:xfrm>
+            <a:off x="594360" y="1627632"/>
+            <a:ext cx="10972800" cy="548640"/>
+          </a:xfrm>
+          <a:prstGeom prst="rect">
+            <a:avLst/>
+          </a:prstGeom>
+          <a:solidFill>
+            <a:srgbClr val="101411"/>
+          </a:solidFill>
+          <a:ln>
+            <a:noFill/>
+          </a:ln>
+        </p:spPr>
+        <p:style>
+          <a:lnRef idx="1">
+            <a:schemeClr val="accent1"/>
+          </a:lnRef>
+          <a:fillRef idx="3">
+            <a:schemeClr val="accent1"/>
+          </a:fillRef>
+          <a:effectRef idx="2">
+            <a:schemeClr val="accent1"/>
+          </a:effectRef>
+          <a:fontRef idx="minor">
+            <a:schemeClr val="lt1"/>
+          </a:fontRef>
+        </p:style>
+        <p:txBody>
+          <a:bodyPr rtlCol="0" anchor="ctr"/>
+          <a:lstStyle/>
+          <a:p>
+            <a:pPr algn="ctr"/>
+          </a:p>
+        </p:txBody>
+      </p:sp>
+      <p:sp>
+        <p:nvSpPr>
+          <p:cNvPr id="8" name="Stage"/>
+          <p:cNvSpPr txBox="1"/>
+          <p:nvPr/>
+        </p:nvSpPr>
+        <p:spPr>
+          <a:xfrm>
+            <a:off x="704088" y="1755648"/>
+            <a:ext cx="1280160" cy="320040"/>
+          </a:xfrm>
+          <a:prstGeom prst="rect">
+            <a:avLst/>
+          </a:prstGeom>
+          <a:noFill/>
+        </p:spPr>
+        <p:txBody>
+          <a:bodyPr wrap="square" lIns="0" rIns="0" tIns="0" bIns="0">
+            <a:spAutoFit/>
+          </a:bodyPr>
+          <a:lstStyle/>
+          <a:p>
+            <a:pPr>
+              <a:lnSpc>
+                <a:spcPct val="107000"/>
+              </a:lnSpc>
+              <a:spcAft>
+                <a:spcPts val="500"/>
+              </a:spcAft>
+            </a:pPr>
+            <a:r>
+              <a:rPr sz="1700" b="1">
+                <a:solidFill>
+                  <a:srgbClr val="FFFFFF"/>
+                </a:solidFill>
+                <a:latin typeface="Arial"/>
+              </a:rPr>
+              <a:t>Stage</a:t>
+            </a:r>
+          </a:p>
+        </p:txBody>
+      </p:sp>
+      <p:sp>
+        <p:nvSpPr>
+          <p:cNvPr id="9" name="Delegated to Copilot"/>
+          <p:cNvSpPr txBox="1"/>
+          <p:nvPr/>
+        </p:nvSpPr>
+        <p:spPr>
+          <a:xfrm>
+            <a:off x="2148840" y="1755648"/>
+            <a:ext cx="3840480" cy="320040"/>
+          </a:xfrm>
+          <a:prstGeom prst="rect">
+            <a:avLst/>
+          </a:prstGeom>
+          <a:noFill/>
+        </p:spPr>
+        <p:txBody>
+          <a:bodyPr wrap="square" lIns="0" rIns="0" tIns="0" bIns="0">
+            <a:spAutoFit/>
+          </a:bodyPr>
+          <a:lstStyle/>
+          <a:p>
+            <a:pPr>
+              <a:lnSpc>
+                <a:spcPct val="107000"/>
+              </a:lnSpc>
+              <a:spcAft>
+                <a:spcPts val="500"/>
+              </a:spcAft>
+            </a:pPr>
+            <a:r>
+              <a:rPr sz="1700" b="1">
+                <a:solidFill>
+                  <a:srgbClr val="FFFFFF"/>
+                </a:solidFill>
+                <a:latin typeface="Arial"/>
+              </a:rPr>
+              <a:t>Delegated to Copilot</a:t>
+            </a:r>
+          </a:p>
+        </p:txBody>
+      </p:sp>
+      <p:sp>
+        <p:nvSpPr>
+          <p:cNvPr id="10" name="Human review gate"/>
+          <p:cNvSpPr txBox="1"/>
+          <p:nvPr/>
+        </p:nvSpPr>
+        <p:spPr>
+          <a:xfrm>
+            <a:off x="6903720" y="1755648"/>
+            <a:ext cx="4846320" cy="320040"/>
+          </a:xfrm>
+          <a:prstGeom prst="rect">
+            <a:avLst/>
+          </a:prstGeom>
+          <a:noFill/>
+        </p:spPr>
+        <p:txBody>
+          <a:bodyPr wrap="square" lIns="0" rIns="0" tIns="0" bIns="0">
+            <a:spAutoFit/>
+          </a:bodyPr>
+          <a:lstStyle/>
+          <a:p>
+            <a:pPr>
+              <a:lnSpc>
+                <a:spcPct val="107000"/>
+              </a:lnSpc>
+              <a:spcAft>
+                <a:spcPts val="500"/>
+              </a:spcAft>
+            </a:pPr>
+            <a:r>
+              <a:rPr sz="1700" b="1">
+                <a:solidFill>
+                  <a:srgbClr val="FFFFFF"/>
+                </a:solidFill>
+                <a:latin typeface="Arial"/>
+              </a:rPr>
+              <a:t>Human review gate</a:t>
+            </a:r>
+          </a:p>
+        </p:txBody>
+      </p:sp>
+      <p:sp>
+        <p:nvSpPr>
+          <p:cNvPr id="11" name="Plan"/>
+          <p:cNvSpPr txBox="1"/>
+          <p:nvPr/>
+        </p:nvSpPr>
+        <p:spPr>
+          <a:xfrm>
+            <a:off x="704088" y="2258288"/>
+            <a:ext cx="1280160" cy="548640"/>
+          </a:xfrm>
+          <a:prstGeom prst="rect">
+            <a:avLst/>
+          </a:prstGeom>
+          <a:noFill/>
+        </p:spPr>
+        <p:txBody>
+          <a:bodyPr wrap="square" lIns="0" rIns="0" tIns="0" bIns="0">
+            <a:spAutoFit/>
+          </a:bodyPr>
+          <a:lstStyle/>
+          <a:p>
+            <a:pPr>
+              <a:lnSpc>
+                <a:spcPct val="107000"/>
+              </a:lnSpc>
+              <a:spcAft>
+                <a:spcPts val="500"/>
+              </a:spcAft>
+            </a:pPr>
+            <a:r>
+              <a:rPr sz="1400" b="1">
+                <a:solidFill>
+                  <a:srgbClr val="101411"/>
+                </a:solidFill>
+                <a:latin typeface="Arial"/>
+              </a:rPr>
+              <a:t>Plan</a:t>
+            </a:r>
+          </a:p>
+        </p:txBody>
+      </p:sp>
+      <p:sp>
+        <p:nvSpPr>
+          <p:cNvPr id="12" name="Developer starts /onboard-repo"/>
+          <p:cNvSpPr txBox="1"/>
+          <p:nvPr/>
+        </p:nvSpPr>
+        <p:spPr>
+          <a:xfrm>
+            <a:off x="2148840" y="2258288"/>
+            <a:ext cx="3840480" cy="548640"/>
+          </a:xfrm>
+          <a:prstGeom prst="rect">
+            <a:avLst/>
+          </a:prstGeom>
+          <a:noFill/>
+        </p:spPr>
+        <p:txBody>
+          <a:bodyPr wrap="square" lIns="0" rIns="0" tIns="0" bIns="0">
+            <a:spAutoFit/>
+          </a:bodyPr>
+          <a:lstStyle/>
+          <a:p>
+            <a:pPr>
+              <a:lnSpc>
+                <a:spcPct val="107000"/>
+              </a:lnSpc>
+              <a:spcAft>
+                <a:spcPts val="500"/>
+              </a:spcAft>
+            </a:pPr>
+            <a:r>
+              <a:rPr sz="1400" b="0">
+                <a:solidFill>
+                  <a:srgbClr val="232925"/>
+                </a:solidFill>
+                <a:latin typeface="Arial"/>
+              </a:rPr>
+              <a:t>Developer starts /onboard-repo and chooses reuse or refresh.</a:t>
+            </a:r>
+          </a:p>
+        </p:txBody>
+      </p:sp>
+      <p:sp>
+        <p:nvSpPr>
+          <p:cNvPr id="13" name="Repository selection"/>
+          <p:cNvSpPr txBox="1"/>
+          <p:nvPr/>
+        </p:nvSpPr>
+        <p:spPr>
+          <a:xfrm>
+            <a:off x="6903720" y="2258288"/>
+            <a:ext cx="4480560" cy="548640"/>
+          </a:xfrm>
+          <a:prstGeom prst="rect">
+            <a:avLst/>
+          </a:prstGeom>
+          <a:noFill/>
+        </p:spPr>
+        <p:txBody>
+          <a:bodyPr wrap="square" lIns="0" rIns="0" tIns="0" bIns="0">
+            <a:spAutoFit/>
+          </a:bodyPr>
+          <a:lstStyle/>
+          <a:p>
+            <a:pPr>
+              <a:lnSpc>
+                <a:spcPct val="107000"/>
+              </a:lnSpc>
+              <a:spcAft>
+                <a:spcPts val="500"/>
+              </a:spcAft>
+            </a:pPr>
+            <a:r>
+              <a:rPr sz="1400" b="1">
+                <a:solidFill>
+                  <a:srgbClr val="101411"/>
+                </a:solidFill>
+                <a:latin typeface="Arial"/>
+              </a:rPr>
+              <a:t>Repository selection</a:t>
+            </a:r>
+          </a:p>
+        </p:txBody>
+      </p:sp>
+      <p:sp>
+        <p:nvSpPr>
+          <p:cNvPr id="14" name="Human review gate"/>
+          <p:cNvSpPr/>
+          <p:nvPr/>
+        </p:nvSpPr>
+        <p:spPr>
+          <a:xfrm>
+            <a:off x="6537960" y="2276576"/>
+            <a:ext cx="201168" cy="201168"/>
+          </a:xfrm>
+          <a:prstGeom prst="diamond">
+            <a:avLst/>
+          </a:prstGeom>
+          <a:solidFill>
+            <a:srgbClr val="101411"/>
+          </a:solidFill>
+          <a:ln>
+            <a:noFill/>
+          </a:ln>
+        </p:spPr>
+        <p:style>
+          <a:lnRef idx="1">
+            <a:schemeClr val="accent1"/>
+          </a:lnRef>
+          <a:fillRef idx="3">
+            <a:schemeClr val="accent1"/>
+          </a:fillRef>
+          <a:effectRef idx="2">
+            <a:schemeClr val="accent1"/>
+          </a:effectRef>
+          <a:fontRef idx="minor">
+            <a:schemeClr val="lt1"/>
+          </a:fontRef>
+        </p:style>
+        <p:txBody>
+          <a:bodyPr rtlCol="0" anchor="ctr"/>
+          <a:lstStyle/>
+          <a:p>
+            <a:pPr algn="ctr"/>
+          </a:p>
+        </p:txBody>
+      </p:sp>
+      <p:sp>
+        <p:nvSpPr>
+          <p:cNvPr id="15" name="Rectangle 11"/>
+          <p:cNvSpPr/>
+          <p:nvPr/>
+        </p:nvSpPr>
+        <p:spPr>
+          <a:xfrm>
+            <a:off x="594360" y="2834360"/>
+            <a:ext cx="10972800" cy="10972"/>
+          </a:xfrm>
+          <a:prstGeom prst="rect">
+            <a:avLst/>
+          </a:prstGeom>
+          <a:solidFill>
+            <a:srgbClr val="E4EBE6"/>
+          </a:solidFill>
+          <a:ln>
+            <a:noFill/>
+          </a:ln>
+        </p:spPr>
+        <p:style>
+          <a:lnRef idx="1">
+            <a:schemeClr val="accent1"/>
+          </a:lnRef>
+          <a:fillRef idx="3">
+            <a:schemeClr val="accent1"/>
+          </a:fillRef>
+          <a:effectRef idx="2">
+            <a:schemeClr val="accent1"/>
+          </a:effectRef>
+          <a:fontRef idx="minor">
+            <a:schemeClr val="lt1"/>
+          </a:fontRef>
+        </p:style>
+        <p:txBody>
+          <a:bodyPr rtlCol="0" anchor="ctr"/>
+          <a:lstStyle/>
+          <a:p>
+            <a:pPr algn="ctr"/>
+          </a:p>
+        </p:txBody>
+      </p:sp>
+      <p:sp>
+        <p:nvSpPr>
+          <p:cNvPr id="16" name="Delegate"/>
+          <p:cNvSpPr txBox="1"/>
+          <p:nvPr/>
+        </p:nvSpPr>
+        <p:spPr>
+          <a:xfrm>
+            <a:off x="704088" y="2898368"/>
+            <a:ext cx="1280160" cy="548640"/>
+          </a:xfrm>
+          <a:prstGeom prst="rect">
+            <a:avLst/>
+          </a:prstGeom>
+          <a:noFill/>
+        </p:spPr>
+        <p:txBody>
+          <a:bodyPr wrap="square" lIns="0" rIns="0" tIns="0" bIns="0">
+            <a:spAutoFit/>
+          </a:bodyPr>
+          <a:lstStyle/>
+          <a:p>
+            <a:pPr>
+              <a:lnSpc>
+                <a:spcPct val="107000"/>
+              </a:lnSpc>
+              <a:spcAft>
+                <a:spcPts val="500"/>
+              </a:spcAft>
+            </a:pPr>
+            <a:r>
+              <a:rPr sz="1400" b="1">
+                <a:solidFill>
+                  <a:srgbClr val="101411"/>
+                </a:solidFill>
+                <a:latin typeface="Arial"/>
+              </a:rPr>
+              <a:t>Delegate</a:t>
+            </a:r>
+          </a:p>
+        </p:txBody>
+      </p:sp>
+      <p:sp>
+        <p:nvSpPr>
+          <p:cNvPr id="17" name="Two parallel specialists resea"/>
+          <p:cNvSpPr txBox="1"/>
+          <p:nvPr/>
+        </p:nvSpPr>
+        <p:spPr>
+          <a:xfrm>
+            <a:off x="2148840" y="2898368"/>
+            <a:ext cx="3840480" cy="548640"/>
+          </a:xfrm>
+          <a:prstGeom prst="rect">
+            <a:avLst/>
+          </a:prstGeom>
+          <a:noFill/>
+        </p:spPr>
+        <p:txBody>
+          <a:bodyPr wrap="square" lIns="0" rIns="0" tIns="0" bIns="0">
+            <a:spAutoFit/>
+          </a:bodyPr>
+          <a:lstStyle/>
+          <a:p>
+            <a:pPr>
+              <a:lnSpc>
+                <a:spcPct val="107000"/>
+              </a:lnSpc>
+              <a:spcAft>
+                <a:spcPts val="500"/>
+              </a:spcAft>
+            </a:pPr>
+            <a:r>
+              <a:rPr sz="1400" b="0">
+                <a:solidFill>
+                  <a:srgbClr val="232925"/>
+                </a:solidFill>
+                <a:latin typeface="Arial"/>
+              </a:rPr>
+              <a:t>Two parallel specialists research the repo map and merged-PR history.</a:t>
+            </a:r>
+          </a:p>
+        </p:txBody>
+      </p:sp>
+      <p:sp>
+        <p:nvSpPr>
+          <p:cNvPr id="18" name="Read-only tools, no shell, set"/>
+          <p:cNvSpPr txBox="1"/>
+          <p:nvPr/>
+        </p:nvSpPr>
+        <p:spPr>
+          <a:xfrm>
+            <a:off x="6903720" y="2898368"/>
+            <a:ext cx="4480560" cy="548640"/>
+          </a:xfrm>
+          <a:prstGeom prst="rect">
+            <a:avLst/>
+          </a:prstGeom>
+          <a:noFill/>
+        </p:spPr>
+        <p:txBody>
+          <a:bodyPr wrap="square" lIns="0" rIns="0" tIns="0" bIns="0">
+            <a:spAutoFit/>
+          </a:bodyPr>
+          <a:lstStyle/>
+          <a:p>
+            <a:pPr>
+              <a:lnSpc>
+                <a:spcPct val="107000"/>
+              </a:lnSpc>
+              <a:spcAft>
+                <a:spcPts val="500"/>
+              </a:spcAft>
+            </a:pPr>
+            <a:r>
+              <a:rPr sz="1400" b="1">
+                <a:solidFill>
+                  <a:srgbClr val="101411"/>
+                </a:solidFill>
+                <a:latin typeface="Arial"/>
+              </a:rPr>
+              <a:t>Read-only tools, no shell, set before work starts</a:t>
+            </a:r>
+          </a:p>
+        </p:txBody>
+      </p:sp>
+      <p:sp>
+        <p:nvSpPr>
+          <p:cNvPr id="19" name="Human review gate"/>
+          <p:cNvSpPr/>
+          <p:nvPr/>
+        </p:nvSpPr>
+        <p:spPr>
+          <a:xfrm>
+            <a:off x="6537960" y="2916656"/>
+            <a:ext cx="201168" cy="201168"/>
+          </a:xfrm>
+          <a:prstGeom prst="diamond">
+            <a:avLst/>
+          </a:prstGeom>
+          <a:solidFill>
+            <a:srgbClr val="101411"/>
+          </a:solidFill>
+          <a:ln>
+            <a:noFill/>
+          </a:ln>
+        </p:spPr>
+        <p:style>
+          <a:lnRef idx="1">
+            <a:schemeClr val="accent1"/>
+          </a:lnRef>
+          <a:fillRef idx="3">
+            <a:schemeClr val="accent1"/>
+          </a:fillRef>
+          <a:effectRef idx="2">
+            <a:schemeClr val="accent1"/>
+          </a:effectRef>
+          <a:fontRef idx="minor">
+            <a:schemeClr val="lt1"/>
+          </a:fontRef>
+        </p:style>
+        <p:txBody>
+          <a:bodyPr rtlCol="0" anchor="ctr"/>
+          <a:lstStyle/>
+          <a:p>
+            <a:pPr algn="ctr"/>
+          </a:p>
+        </p:txBody>
+      </p:sp>
+      <p:sp>
+        <p:nvSpPr>
+          <p:cNvPr id="20" name="Rectangle 11"/>
+          <p:cNvSpPr/>
+          <p:nvPr/>
+        </p:nvSpPr>
+        <p:spPr>
+          <a:xfrm>
+            <a:off x="594360" y="3474440"/>
+            <a:ext cx="10972800" cy="10972"/>
+          </a:xfrm>
+          <a:prstGeom prst="rect">
+            <a:avLst/>
+          </a:prstGeom>
+          <a:solidFill>
+            <a:srgbClr val="E4EBE6"/>
+          </a:solidFill>
+          <a:ln>
+            <a:noFill/>
+          </a:ln>
+        </p:spPr>
+        <p:style>
+          <a:lnRef idx="1">
+            <a:schemeClr val="accent1"/>
+          </a:lnRef>
+          <a:fillRef idx="3">
+            <a:schemeClr val="accent1"/>
+          </a:fillRef>
+          <a:effectRef idx="2">
+            <a:schemeClr val="accent1"/>
+          </a:effectRef>
+          <a:fontRef idx="minor">
+            <a:schemeClr val="lt1"/>
+          </a:fontRef>
+        </p:style>
+        <p:txBody>
+          <a:bodyPr rtlCol="0" anchor="ctr"/>
+          <a:lstStyle/>
+          <a:p>
+            <a:pPr algn="ctr"/>
+          </a:p>
+        </p:txBody>
+      </p:sp>
+      <p:sp>
+        <p:nvSpPr>
+          <p:cNvPr id="21" name="Validate"/>
+          <p:cNvSpPr txBox="1"/>
+          <p:nvPr/>
+        </p:nvSpPr>
+        <p:spPr>
+          <a:xfrm>
+            <a:off x="704088" y="3538448"/>
+            <a:ext cx="1280160" cy="548640"/>
+          </a:xfrm>
+          <a:prstGeom prst="rect">
+            <a:avLst/>
+          </a:prstGeom>
+          <a:noFill/>
+        </p:spPr>
+        <p:txBody>
+          <a:bodyPr wrap="square" lIns="0" rIns="0" tIns="0" bIns="0">
+            <a:spAutoFit/>
+          </a:bodyPr>
+          <a:lstStyle/>
+          <a:p>
+            <a:pPr>
+              <a:lnSpc>
+                <a:spcPct val="107000"/>
+              </a:lnSpc>
+              <a:spcAft>
+                <a:spcPts val="500"/>
+              </a:spcAft>
+            </a:pPr>
+            <a:r>
+              <a:rPr sz="1400" b="1">
+                <a:solidFill>
+                  <a:srgbClr val="101411"/>
+                </a:solidFill>
+                <a:latin typeface="Arial"/>
+              </a:rPr>
+              <a:t>Validate</a:t>
+            </a:r>
+          </a:p>
+        </p:txBody>
+      </p:sp>
+      <p:sp>
+        <p:nvSpPr>
+          <p:cNvPr id="22" name="Tools check file paths and lin"/>
+          <p:cNvSpPr txBox="1"/>
+          <p:nvPr/>
+        </p:nvSpPr>
+        <p:spPr>
+          <a:xfrm>
+            <a:off x="2148840" y="3538448"/>
+            <a:ext cx="3840480" cy="548640"/>
+          </a:xfrm>
+          <a:prstGeom prst="rect">
+            <a:avLst/>
+          </a:prstGeom>
+          <a:noFill/>
+        </p:spPr>
+        <p:txBody>
+          <a:bodyPr wrap="square" lIns="0" rIns="0" tIns="0" bIns="0">
+            <a:spAutoFit/>
+          </a:bodyPr>
+          <a:lstStyle/>
+          <a:p>
+            <a:pPr>
+              <a:lnSpc>
+                <a:spcPct val="107000"/>
+              </a:lnSpc>
+              <a:spcAft>
+                <a:spcPts val="500"/>
+              </a:spcAft>
+            </a:pPr>
+            <a:r>
+              <a:rPr sz="1400" b="0">
+                <a:solidFill>
+                  <a:srgbClr val="232925"/>
+                </a:solidFill>
+                <a:latin typeface="Arial"/>
+              </a:rPr>
+              <a:t>Tools check file paths and line ranges. Gaps stay unavailable. Commands are never run.</a:t>
+            </a:r>
+          </a:p>
+        </p:txBody>
+      </p:sp>
+      <p:sp>
+        <p:nvSpPr>
+          <p:cNvPr id="23" name="Service owner inspects the cit"/>
+          <p:cNvSpPr txBox="1"/>
+          <p:nvPr/>
+        </p:nvSpPr>
+        <p:spPr>
+          <a:xfrm>
+            <a:off x="6903720" y="3538448"/>
+            <a:ext cx="4480560" cy="548640"/>
+          </a:xfrm>
+          <a:prstGeom prst="rect">
+            <a:avLst/>
+          </a:prstGeom>
+          <a:noFill/>
+        </p:spPr>
+        <p:txBody>
+          <a:bodyPr wrap="square" lIns="0" rIns="0" tIns="0" bIns="0">
+            <a:spAutoFit/>
+          </a:bodyPr>
+          <a:lstStyle/>
+          <a:p>
+            <a:pPr>
+              <a:lnSpc>
+                <a:spcPct val="107000"/>
+              </a:lnSpc>
+              <a:spcAft>
+                <a:spcPts val="500"/>
+              </a:spcAft>
+            </a:pPr>
+            <a:r>
+              <a:rPr sz="1400" b="1">
+                <a:solidFill>
+                  <a:srgbClr val="101411"/>
+                </a:solidFill>
+                <a:latin typeface="Arial"/>
+              </a:rPr>
+              <a:t>Service owner inspects the cited files</a:t>
+            </a:r>
+          </a:p>
+        </p:txBody>
+      </p:sp>
+      <p:sp>
+        <p:nvSpPr>
+          <p:cNvPr id="24" name="Human review gate"/>
+          <p:cNvSpPr/>
+          <p:nvPr/>
+        </p:nvSpPr>
+        <p:spPr>
+          <a:xfrm>
+            <a:off x="6537960" y="3556736"/>
+            <a:ext cx="201168" cy="201168"/>
+          </a:xfrm>
+          <a:prstGeom prst="diamond">
+            <a:avLst/>
+          </a:prstGeom>
+          <a:solidFill>
+            <a:srgbClr val="101411"/>
+          </a:solidFill>
+          <a:ln>
+            <a:noFill/>
+          </a:ln>
+        </p:spPr>
+        <p:style>
+          <a:lnRef idx="1">
+            <a:schemeClr val="accent1"/>
+          </a:lnRef>
+          <a:fillRef idx="3">
+            <a:schemeClr val="accent1"/>
+          </a:fillRef>
+          <a:effectRef idx="2">
+            <a:schemeClr val="accent1"/>
+          </a:effectRef>
+          <a:fontRef idx="minor">
+            <a:schemeClr val="lt1"/>
+          </a:fontRef>
+        </p:style>
+        <p:txBody>
+          <a:bodyPr rtlCol="0" anchor="ctr"/>
+          <a:lstStyle/>
+          <a:p>
+            <a:pPr algn="ctr"/>
+          </a:p>
+        </p:txBody>
+      </p:sp>
+      <p:sp>
+        <p:nvSpPr>
+          <p:cNvPr id="25" name="Rectangle 11"/>
+          <p:cNvSpPr/>
+          <p:nvPr/>
+        </p:nvSpPr>
+        <p:spPr>
+          <a:xfrm>
+            <a:off x="594360" y="4114520"/>
+            <a:ext cx="10972800" cy="10972"/>
+          </a:xfrm>
+          <a:prstGeom prst="rect">
+            <a:avLst/>
+          </a:prstGeom>
+          <a:solidFill>
+            <a:srgbClr val="E4EBE6"/>
+          </a:solidFill>
+          <a:ln>
+            <a:noFill/>
+          </a:ln>
+        </p:spPr>
+        <p:style>
+          <a:lnRef idx="1">
+            <a:schemeClr val="accent1"/>
+          </a:lnRef>
+          <a:fillRef idx="3">
+            <a:schemeClr val="accent1"/>
+          </a:fillRef>
+          <a:effectRef idx="2">
+            <a:schemeClr val="accent1"/>
+          </a:effectRef>
+          <a:fontRef idx="minor">
+            <a:schemeClr val="lt1"/>
+          </a:fontRef>
+        </p:style>
+        <p:txBody>
+          <a:bodyPr rtlCol="0" anchor="ctr"/>
+          <a:lstStyle/>
+          <a:p>
+            <a:pPr algn="ctr"/>
+          </a:p>
+        </p:txBody>
+      </p:sp>
+      <p:sp>
+        <p:nvSpPr>
+          <p:cNvPr id="26" name="Review"/>
+          <p:cNvSpPr txBox="1"/>
+          <p:nvPr/>
+        </p:nvSpPr>
+        <p:spPr>
+          <a:xfrm>
+            <a:off x="704088" y="4178528"/>
+            <a:ext cx="1280160" cy="548640"/>
+          </a:xfrm>
+          <a:prstGeom prst="rect">
+            <a:avLst/>
+          </a:prstGeom>
+          <a:noFill/>
+        </p:spPr>
+        <p:txBody>
+          <a:bodyPr wrap="square" lIns="0" rIns="0" tIns="0" bIns="0">
+            <a:spAutoFit/>
+          </a:bodyPr>
+          <a:lstStyle/>
+          <a:p>
+            <a:pPr>
+              <a:lnSpc>
+                <a:spcPct val="107000"/>
+              </a:lnSpc>
+              <a:spcAft>
+                <a:spcPts val="500"/>
+              </a:spcAft>
+            </a:pPr>
+            <a:r>
+              <a:rPr sz="1400" b="1">
+                <a:solidFill>
+                  <a:srgbClr val="101411"/>
+                </a:solidFill>
+                <a:latin typeface="Arial"/>
+              </a:rPr>
+              <a:t>Review</a:t>
+            </a:r>
+          </a:p>
+        </p:txBody>
+      </p:sp>
+      <p:sp>
+        <p:nvSpPr>
+          <p:cNvPr id="27" name="Grounded follow-up questions, "/>
+          <p:cNvSpPr txBox="1"/>
+          <p:nvPr/>
+        </p:nvSpPr>
+        <p:spPr>
+          <a:xfrm>
+            <a:off x="2148840" y="4178528"/>
+            <a:ext cx="3840480" cy="548640"/>
+          </a:xfrm>
+          <a:prstGeom prst="rect">
+            <a:avLst/>
+          </a:prstGeom>
+          <a:noFill/>
+        </p:spPr>
+        <p:txBody>
+          <a:bodyPr wrap="square" lIns="0" rIns="0" tIns="0" bIns="0">
+            <a:spAutoFit/>
+          </a:bodyPr>
+          <a:lstStyle/>
+          <a:p>
+            <a:pPr>
+              <a:lnSpc>
+                <a:spcPct val="107000"/>
+              </a:lnSpc>
+              <a:spcAft>
+                <a:spcPts val="500"/>
+              </a:spcAft>
+            </a:pPr>
+            <a:r>
+              <a:rPr sz="1400" b="0">
+                <a:solidFill>
+                  <a:srgbClr val="232925"/>
+                </a:solidFill>
+                <a:latin typeface="Arial"/>
+              </a:rPr>
+              <a:t>Grounded follow-up questions, answered in the same Copilot session.</a:t>
+            </a:r>
+          </a:p>
+        </p:txBody>
+      </p:sp>
+      <p:sp>
+        <p:nvSpPr>
+          <p:cNvPr id="28" name="Developer questions the eviden"/>
+          <p:cNvSpPr txBox="1"/>
+          <p:nvPr/>
+        </p:nvSpPr>
+        <p:spPr>
+          <a:xfrm>
+            <a:off x="6903720" y="4178528"/>
+            <a:ext cx="4480560" cy="548640"/>
+          </a:xfrm>
+          <a:prstGeom prst="rect">
+            <a:avLst/>
+          </a:prstGeom>
+          <a:noFill/>
+        </p:spPr>
+        <p:txBody>
+          <a:bodyPr wrap="square" lIns="0" rIns="0" tIns="0" bIns="0">
+            <a:spAutoFit/>
+          </a:bodyPr>
+          <a:lstStyle/>
+          <a:p>
+            <a:pPr>
+              <a:lnSpc>
+                <a:spcPct val="107000"/>
+              </a:lnSpc>
+              <a:spcAft>
+                <a:spcPts val="500"/>
+              </a:spcAft>
+            </a:pPr>
+            <a:r>
+              <a:rPr sz="1400" b="1">
+                <a:solidFill>
+                  <a:srgbClr val="101411"/>
+                </a:solidFill>
+                <a:latin typeface="Arial"/>
+              </a:rPr>
+              <a:t>Developer questions the evidence</a:t>
+            </a:r>
+          </a:p>
+        </p:txBody>
+      </p:sp>
+      <p:sp>
+        <p:nvSpPr>
+          <p:cNvPr id="29" name="Human review gate"/>
+          <p:cNvSpPr/>
+          <p:nvPr/>
+        </p:nvSpPr>
+        <p:spPr>
+          <a:xfrm>
+            <a:off x="6537960" y="4196816"/>
+            <a:ext cx="201168" cy="201168"/>
+          </a:xfrm>
+          <a:prstGeom prst="diamond">
+            <a:avLst/>
+          </a:prstGeom>
+          <a:solidFill>
+            <a:srgbClr val="101411"/>
+          </a:solidFill>
+          <a:ln>
+            <a:noFill/>
+          </a:ln>
+        </p:spPr>
+        <p:style>
+          <a:lnRef idx="1">
+            <a:schemeClr val="accent1"/>
+          </a:lnRef>
+          <a:fillRef idx="3">
+            <a:schemeClr val="accent1"/>
+          </a:fillRef>
+          <a:effectRef idx="2">
+            <a:schemeClr val="accent1"/>
+          </a:effectRef>
+          <a:fontRef idx="minor">
+            <a:schemeClr val="lt1"/>
+          </a:fontRef>
+        </p:style>
+        <p:txBody>
+          <a:bodyPr rtlCol="0" anchor="ctr"/>
+          <a:lstStyle/>
+          <a:p>
+            <a:pPr algn="ctr"/>
+          </a:p>
+        </p:txBody>
+      </p:sp>
+      <p:sp>
+        <p:nvSpPr>
+          <p:cNvPr id="30" name="Rectangle 11"/>
+          <p:cNvSpPr/>
+          <p:nvPr/>
+        </p:nvSpPr>
+        <p:spPr>
+          <a:xfrm>
+            <a:off x="594360" y="4754600"/>
+            <a:ext cx="10972800" cy="10972"/>
+          </a:xfrm>
+          <a:prstGeom prst="rect">
+            <a:avLst/>
+          </a:prstGeom>
+          <a:solidFill>
+            <a:srgbClr val="E4EBE6"/>
+          </a:solidFill>
+          <a:ln>
+            <a:noFill/>
+          </a:ln>
+        </p:spPr>
+        <p:style>
+          <a:lnRef idx="1">
+            <a:schemeClr val="accent1"/>
+          </a:lnRef>
+          <a:fillRef idx="3">
+            <a:schemeClr val="accent1"/>
+          </a:fillRef>
+          <a:effectRef idx="2">
+            <a:schemeClr val="accent1"/>
+          </a:effectRef>
+          <a:fontRef idx="minor">
+            <a:schemeClr val="lt1"/>
+          </a:fontRef>
+        </p:style>
+        <p:txBody>
+          <a:bodyPr rtlCol="0" anchor="ctr"/>
+          <a:lstStyle/>
+          <a:p>
+            <a:pPr algn="ctr"/>
+          </a:p>
+        </p:txBody>
+      </p:sp>
+      <p:sp>
+        <p:nvSpPr>
+          <p:cNvPr id="31" name="Ship"/>
+          <p:cNvSpPr txBox="1"/>
+          <p:nvPr/>
+        </p:nvSpPr>
+        <p:spPr>
+          <a:xfrm>
+            <a:off x="704088" y="4818608"/>
+            <a:ext cx="1280160" cy="548640"/>
+          </a:xfrm>
+          <a:prstGeom prst="rect">
+            <a:avLst/>
+          </a:prstGeom>
+          <a:noFill/>
+        </p:spPr>
+        <p:txBody>
+          <a:bodyPr wrap="square" lIns="0" rIns="0" tIns="0" bIns="0">
+            <a:spAutoFit/>
+          </a:bodyPr>
+          <a:lstStyle/>
+          <a:p>
+            <a:pPr>
+              <a:lnSpc>
+                <a:spcPct val="107000"/>
+              </a:lnSpc>
+              <a:spcAft>
+                <a:spcPts val="500"/>
+              </a:spcAft>
+            </a:pPr>
+            <a:r>
+              <a:rPr sz="1400" b="1">
+                <a:solidFill>
+                  <a:srgbClr val="101411"/>
+                </a:solidFill>
+                <a:latin typeface="Arial"/>
+              </a:rPr>
+              <a:t>Ship</a:t>
+            </a:r>
+          </a:p>
+        </p:txBody>
+      </p:sp>
+      <p:sp>
+        <p:nvSpPr>
+          <p:cNvPr id="32" name="First-steps checklist handed o"/>
+          <p:cNvSpPr txBox="1"/>
+          <p:nvPr/>
+        </p:nvSpPr>
+        <p:spPr>
+          <a:xfrm>
+            <a:off x="2148840" y="4818608"/>
+            <a:ext cx="3840480" cy="548640"/>
+          </a:xfrm>
+          <a:prstGeom prst="rect">
+            <a:avLst/>
+          </a:prstGeom>
+          <a:noFill/>
+        </p:spPr>
+        <p:txBody>
+          <a:bodyPr wrap="square" lIns="0" rIns="0" tIns="0" bIns="0">
+            <a:spAutoFit/>
+          </a:bodyPr>
+          <a:lstStyle/>
+          <a:p>
+            <a:pPr>
+              <a:lnSpc>
+                <a:spcPct val="107000"/>
+              </a:lnSpc>
+              <a:spcAft>
+                <a:spcPts val="500"/>
+              </a:spcAft>
+            </a:pPr>
+            <a:r>
+              <a:rPr sz="1400" b="0">
+                <a:solidFill>
+                  <a:srgbClr val="232925"/>
+                </a:solidFill>
+                <a:latin typeface="Arial"/>
+              </a:rPr>
+              <a:t>First-steps checklist handed over. Bearing stops before implementation.</a:t>
+            </a:r>
+          </a:p>
+        </p:txBody>
+      </p:sp>
+      <p:sp>
+        <p:nvSpPr>
+          <p:cNvPr id="33" name="A person decides whether and w"/>
+          <p:cNvSpPr txBox="1"/>
+          <p:nvPr/>
+        </p:nvSpPr>
+        <p:spPr>
+          <a:xfrm>
+            <a:off x="6903720" y="4818608"/>
+            <a:ext cx="4480560" cy="548640"/>
+          </a:xfrm>
+          <a:prstGeom prst="rect">
+            <a:avLst/>
+          </a:prstGeom>
+          <a:noFill/>
+        </p:spPr>
+        <p:txBody>
+          <a:bodyPr wrap="square" lIns="0" rIns="0" tIns="0" bIns="0">
+            <a:spAutoFit/>
+          </a:bodyPr>
+          <a:lstStyle/>
+          <a:p>
+            <a:pPr>
+              <a:lnSpc>
+                <a:spcPct val="107000"/>
+              </a:lnSpc>
+              <a:spcAft>
+                <a:spcPts val="500"/>
+              </a:spcAft>
+            </a:pPr>
+            <a:r>
+              <a:rPr sz="1400" b="1">
+                <a:solidFill>
+                  <a:srgbClr val="101411"/>
+                </a:solidFill>
+                <a:latin typeface="Arial"/>
+              </a:rPr>
+              <a:t>A person decides whether and what to implement</a:t>
+            </a:r>
+          </a:p>
+        </p:txBody>
+      </p:sp>
+      <p:sp>
+        <p:nvSpPr>
+          <p:cNvPr id="34" name="Human review gate"/>
+          <p:cNvSpPr/>
+          <p:nvPr/>
+        </p:nvSpPr>
+        <p:spPr>
+          <a:xfrm>
+            <a:off x="6537960" y="4836896"/>
+            <a:ext cx="201168" cy="201168"/>
+          </a:xfrm>
+          <a:prstGeom prst="diamond">
+            <a:avLst/>
+          </a:prstGeom>
+          <a:solidFill>
+            <a:srgbClr val="101411"/>
+          </a:solidFill>
+          <a:ln>
+            <a:noFill/>
+          </a:ln>
+        </p:spPr>
+        <p:style>
+          <a:lnRef idx="1">
+            <a:schemeClr val="accent1"/>
+          </a:lnRef>
+          <a:fillRef idx="3">
+            <a:schemeClr val="accent1"/>
+          </a:fillRef>
+          <a:effectRef idx="2">
+            <a:schemeClr val="accent1"/>
+          </a:effectRef>
+          <a:fontRef idx="minor">
+            <a:schemeClr val="lt1"/>
+          </a:fontRef>
+        </p:style>
+        <p:txBody>
+          <a:bodyPr rtlCol="0" anchor="ctr"/>
+          <a:lstStyle/>
+          <a:p>
+            <a:pPr algn="ctr"/>
+          </a:p>
+        </p:txBody>
+      </p:sp>
+      <p:sp>
+        <p:nvSpPr>
+          <p:cNvPr id="35" name="Rectangle 11"/>
+          <p:cNvSpPr/>
+          <p:nvPr/>
+        </p:nvSpPr>
+        <p:spPr>
+          <a:xfrm>
+            <a:off x="594360" y="5394680"/>
+            <a:ext cx="10972800" cy="10972"/>
+          </a:xfrm>
+          <a:prstGeom prst="rect">
+            <a:avLst/>
+          </a:prstGeom>
+          <a:solidFill>
+            <a:srgbClr val="E4EBE6"/>
+          </a:solidFill>
+          <a:ln>
+            <a:noFill/>
+          </a:ln>
+        </p:spPr>
+        <p:style>
+          <a:lnRef idx="1">
+            <a:schemeClr val="accent1"/>
+          </a:lnRef>
+          <a:fillRef idx="3">
+            <a:schemeClr val="accent1"/>
+          </a:fillRef>
+          <a:effectRef idx="2">
+            <a:schemeClr val="accent1"/>
+          </a:effectRef>
+          <a:fontRef idx="minor">
+            <a:schemeClr val="lt1"/>
+          </a:fontRef>
+        </p:style>
+        <p:txBody>
+          <a:bodyPr rtlCol="0" anchor="ctr"/>
+          <a:lstStyle/>
+          <a:p>
+            <a:pPr algn="ctr"/>
+          </a:p>
+        </p:txBody>
+      </p:sp>
+      <p:sp>
+        <p:nvSpPr>
+          <p:cNvPr id="36" name="Footnote"/>
+          <p:cNvSpPr txBox="1"/>
+          <p:nvPr/>
+        </p:nvSpPr>
+        <p:spPr>
+          <a:xfrm>
+            <a:off x="594360" y="5733288"/>
+            <a:ext cx="10972800" cy="457200"/>
+          </a:xfrm>
+          <a:prstGeom prst="rect">
+            <a:avLst/>
+          </a:prstGeom>
+          <a:noFill/>
+        </p:spPr>
+        <p:txBody>
+          <a:bodyPr wrap="square" lIns="0" rIns="0" tIns="0" bIns="0">
+            <a:spAutoFit/>
+          </a:bodyPr>
+          <a:lstStyle/>
+          <a:p>
+            <a:pPr>
+              <a:lnSpc>
+                <a:spcPct val="107000"/>
+              </a:lnSpc>
+              <a:spcAft>
+                <a:spcPts val="500"/>
+              </a:spcAft>
+            </a:pPr>
+            <a:r>
+              <a:rPr sz="1400" b="0">
+                <a:solidFill>
+                  <a:srgbClr val="232925"/>
+                </a:solidFill>
+                <a:latin typeface="Arial"/>
+              </a:rPr>
+              <a:t>Prototype: all five stages are implemented in this repository. Diamonds mark human review gates. Path and line checks validate references, not semantic correctness.</a:t>
             </a:r>
           </a:p>
         </p:txBody>
@@ -16149,7 +17806,7 @@
       </p:sp>
       <p:sp>
         <p:nvSpPr>
-          <p:cNvPr id="6" name="02 / 17"/>
+          <p:cNvPr id="6" name="02 / 18"/>
           <p:cNvSpPr txBox="1"/>
           <p:nvPr/>
         </p:nvSpPr>
@@ -16184,7 +17841,7 @@
                 </a:solidFill>
                 <a:latin typeface="Arial"/>
               </a:rPr>
-              <a:t>02 / 17</a:t>
+              <a:t>02 / 18</a:t>
             </a:r>
           </a:p>
         </p:txBody>
@@ -17509,7 +19166,7 @@
       </p:sp>
       <p:sp>
         <p:nvSpPr>
-          <p:cNvPr id="6" name="03 / 17"/>
+          <p:cNvPr id="6" name="03 / 18"/>
           <p:cNvSpPr txBox="1"/>
           <p:nvPr/>
         </p:nvSpPr>
@@ -17544,7 +19201,7 @@
                 </a:solidFill>
                 <a:latin typeface="Arial"/>
               </a:rPr>
-              <a:t>03 / 17</a:t>
+              <a:t>03 / 18</a:t>
             </a:r>
           </a:p>
         </p:txBody>
@@ -18999,7 +20656,7 @@
       </p:sp>
       <p:sp>
         <p:nvSpPr>
-          <p:cNvPr id="6" name="04 / 17"/>
+          <p:cNvPr id="6" name="05 / 18"/>
           <p:cNvSpPr txBox="1"/>
           <p:nvPr/>
         </p:nvSpPr>
@@ -19034,7 +20691,7 @@
                 </a:solidFill>
                 <a:latin typeface="Arial"/>
               </a:rPr>
-              <a:t>04 / 17</a:t>
+              <a:t>05 / 18</a:t>
             </a:r>
           </a:p>
         </p:txBody>
@@ -28392,7 +30049,7 @@
       </p:sp>
       <p:sp>
         <p:nvSpPr>
-          <p:cNvPr id="6" name="05 / 17"/>
+          <p:cNvPr id="6" name="06 / 18"/>
           <p:cNvSpPr txBox="1"/>
           <p:nvPr/>
         </p:nvSpPr>
@@ -28427,7 +30084,7 @@
                 </a:solidFill>
                 <a:latin typeface="Arial"/>
               </a:rPr>
-              <a:t>05 / 17</a:t>
+              <a:t>06 / 18</a:t>
             </a:r>
           </a:p>
         </p:txBody>
@@ -29246,7 +30903,7 @@
       </p:sp>
       <p:sp>
         <p:nvSpPr>
-          <p:cNvPr id="6" name="06 / 17"/>
+          <p:cNvPr id="6" name="07 / 18"/>
           <p:cNvSpPr txBox="1"/>
           <p:nvPr/>
         </p:nvSpPr>
@@ -29281,7 +30938,7 @@
                 </a:solidFill>
                 <a:latin typeface="Arial"/>
               </a:rPr>
-              <a:t>06 / 17</a:t>
+              <a:t>07 / 18</a:t>
             </a:r>
           </a:p>
         </p:txBody>
@@ -30628,7 +32285,7 @@
       </p:sp>
       <p:sp>
         <p:nvSpPr>
-          <p:cNvPr id="6" name="07 / 17"/>
+          <p:cNvPr id="6" name="08 / 18"/>
           <p:cNvSpPr txBox="1"/>
           <p:nvPr/>
         </p:nvSpPr>
@@ -30663,7 +32320,7 @@
                 </a:solidFill>
                 <a:latin typeface="Arial"/>
               </a:rPr>
-              <a:t>07 / 17</a:t>
+              <a:t>08 / 18</a:t>
             </a:r>
           </a:p>
         </p:txBody>
@@ -32332,7 +33989,7 @@
       </p:sp>
       <p:sp>
         <p:nvSpPr>
-          <p:cNvPr id="6" name="08 / 17"/>
+          <p:cNvPr id="6" name="09 / 18"/>
           <p:cNvSpPr txBox="1"/>
           <p:nvPr/>
         </p:nvSpPr>
@@ -32367,7 +34024,7 @@
                 </a:solidFill>
                 <a:latin typeface="Arial"/>
               </a:rPr>
-              <a:t>08 / 17</a:t>
+              <a:t>09 / 18</a:t>
             </a:r>
           </a:p>
         </p:txBody>
@@ -34307,7 +35964,7 @@
       </p:sp>
       <p:sp>
         <p:nvSpPr>
-          <p:cNvPr id="6" name="09 / 17"/>
+          <p:cNvPr id="6" name="10 / 18"/>
           <p:cNvSpPr txBox="1"/>
           <p:nvPr/>
         </p:nvSpPr>
@@ -34342,7 +35999,7 @@
                 </a:solidFill>
                 <a:latin typeface="Arial"/>
               </a:rPr>
-              <a:t>09 / 17</a:t>
+              <a:t>10 / 18</a:t>
             </a:r>
           </a:p>
         </p:txBody>

</xml_diff>

<commit_message>
Reposition Bearing as a light forward-deployed engineer
Story-only change; plugin behaviour is untouched.

- Deck: add slide 5 "Input: a repository. Output: what to optimize." with
  Prototype / Emerging / Proposed tags and a human review gate; light edits
  to slides 1, 3, 14-19; footers now N / 19; speaker notes restate the
  honesty rules on every changed slide.
- submission/README.md: light-FDE summary (126 words), 19-slide deck
  description, plan/delegate/validate/review/ship wording, fixed deck link.
- README.md: short light-FDE positioning paragraph.

Co-authored-by: Copilot App <223556219+Copilot@users.noreply.github.com>
Copilot-Session: 1677b0d3-6dfb-4f8e-886a-6ed024fd4bc2
</commit_message>
<xml_diff>
--- a/submission/bearing-enterprise-deck.pptx
+++ b/submission/bearing-enterprise-deck.pptx
@@ -9,6 +9,7 @@
     <p:sldId id="257" r:id="rId9"/>
     <p:sldId id="258" r:id="rId10"/>
     <p:sldId id="273" r:id="rId99"/>
+    <p:sldId id="274" r:id="rId100"/>
     <p:sldId id="259" r:id="rId11"/>
     <p:sldId id="260" r:id="rId12"/>
     <p:sldId id="261" r:id="rId13"/>
@@ -519,7 +520,7 @@
           <a:lstStyle/>
           <a:p>
             <a:r>
-              <a:t>Open with the trust problem, then show the answer: findings that cite sources and stop at a human decision. Bearing is a prototype GitHub Copilot App plugin that orients a developer in an unfamiliar repository. Legacy modernization is a proposed extension of the same discipline, not shipped functionality. We are not proposing a rewrite because a service is old; we are proposing a bounded assessment of what makes the next change expensive or risky. This is not an official GitHub service or endorsement.</a:t>
+              <a:t>Open with the trust problem, then show the answer: findings that cite sources and stop at a human decision. Positioning: Bearing is a light forward-deployed engineer for any team. Input: a repository. Output: what is worth optimizing, with evidence. A forward-deployed engineer embeds with a team, explores its codebase and comes back with a cited picture and a short list of where to improve; Bearing packages that first pass as a repeatable GitHub Copilot App workflow (plan, delegate, validate, review, ship) with a human review gate at each stage. Prototype (built today): read-only exploration that produces a cited map, conventions (documented vs observed), workflow, merged-PR history, first steps and explicit unavailable sections; agents are read-only with no shell, and it stops before implementation. Emerging: the evidence gaps it already surfaces are the first optimization signals. Proposed, not built: ranked optimization candidates with cited evidence, a confidence level and a delegable task brief behind a human review gate. Light means first-pass exploration; it does not replace a real forward-deployed engineer or the service owner. No measured results, time savings, customer validation or telemetry are claimed. This is not an official GitHub service or endorsement.</a:t>
             </a:r>
           </a:p>
         </p:txBody>
@@ -729,6 +730,11 @@
           <a:lstStyle/>
           <a:p>
             <a:r>
+              <a:t>Prototype (left) is what exists: read-only exploration of a repository that returns a cited picture. Proposed (right) is not built: ranked optimization candidates, coverage and CI data, runtime measurement, support-lifecycle assessment, task briefs and project setup. Bearing does not find optimizations today, and no measured results are claimed.</a:t>
+            </a:r>
+          </a:p>
+          <a:p>
+            <a:r>
               <a:t>Current behavior is verified against README.md and plugins/bearing/skills/onboard-repo/SKILL.md, the repo-cartographer and pr-historian agent instructions, and section-validation code. Path/line checks are reference validation, not semantic correctness certification. The prototype targets small repositories on github.com, not production monorepo/large-estate analysis or GitHub Enterprise Server. Production rollout still needs approved data/model handling, access, retention, auditability, quality criteria and operational ownership.</a:t>
             </a:r>
           </a:p>
@@ -802,6 +808,11 @@
               <a:t>A self-assessment, not a score. Prototype = implemented in this repository (README.md, submission/README.md and plugins/bearing/). Emerging = partly supported, not validated. Proposed = described in this deck or the companion brief but not built. Governed means the prototype’s own controls: read-only agents with role-scoped tool lists, workspace state kept outside the analyzed repository, and a loopback-only canvas with a per-instance token. Production rollout still needs approved data and model handling, access, retention, auditability and an owner.</a:t>
             </a:r>
           </a:p>
+          <a:p>
+            <a:r>
+              <a:t>Emerging, useful beyond developers: field teams could run the same read-only light FDE pass, but this has not been validated with non-developer users. Proposed, ranks what to optimize: ranked candidates with cited evidence, a confidence level and a task brief are described in this deck and not built; Bearing does not find optimizations today. Light means first-pass exploration; it does not replace a real forward-deployed engineer or the service owner.</a:t>
+            </a:r>
+          </a:p>
         </p:txBody>
       </p:sp>
       <p:sp>
@@ -869,7 +880,7 @@
           <a:lstStyle/>
           <a:p>
             <a:r>
-              <a:t>Only repository onboarding exists. Every other row is a proposal that would need its own analyzers, tool permissions, evaluation and human review gates; none inherits Bearing’s current controls automatically. The shared pattern is a design intent, not an implemented cross-workflow contract.</a:t>
+              <a:t>Only repository exploration exists (/onboard-repo, the light FDE pass). Every other row is a proposal that would need its own analyzers, tool permissions, evaluation and human review gates; none inherits Bearing’s current controls automatically. The optimization assessment row is the proposed ranked-candidates half and is not built. The shared pattern is a design intent, not an implemented cross-workflow contract.</a:t>
             </a:r>
           </a:p>
         </p:txBody>
@@ -939,6 +950,11 @@
           <a:lstStyle/>
           <a:p>
             <a:r>
+              <a:t>Step one is the light FDE pass: the read-only exploration that exists today (Prototype). Proving an improvement is the proposed pilot (Proposed): Bearing does not rank or find optimizations today, so the journey, owner and baseline are agreed by people, not produced by Bearing.</a:t>
+            </a:r>
+          </a:p>
+          <a:p>
+            <a:r>
               <a:t>Ask the customer to nominate the service, journey and accountable owner. Agree measurement and review gates before selecting the intervention. Track comparable CI/test-stage performance, failure behavior and confidence for the named journey. For assessment value, record evidence completeness, time to owner-approved first meaningful PR and repeated orientation questions. All targets are customer-agreed pilot hypotheses, not claimed Bearing outcomes.</a:t>
             </a:r>
           </a:p>
@@ -1052,6 +1068,11 @@
               <a:t>The Kyndryl 2025 survey dates are June 20–August 15, 2025. The 2024 announcement was October 16, 2024. Vendor research describes its stated populations, not the customer's estate. The four-week schedule and all backlog examples are illustrative. Artifacts use the official neutral/green palette with a restrained Copilot Purple accent: green marks what exists today, purple marks illustrative or proposed content. Mona Sans is used for display type and Arial for body text so the files stay portable. They do not imply GitHub endorsement of Bearing.</a:t>
             </a:r>
           </a:p>
+          <a:p>
+            <a:r>
+              <a:t>Ranked optimization candidates are Proposed and not built; no measured results, time savings, customer validation or telemetry are claimed.</a:t>
+            </a:r>
+          </a:p>
         </p:txBody>
       </p:sp>
       <p:sp>
@@ -1119,7 +1140,77 @@
           <a:lstStyle/>
           <a:p>
             <a:r>
-              <a:t>Only developer onboarding is implemented today. The other three rows are reuse patterns of the same guide format and review discipline. Emerging: today’s guide could be reused as-is but has not been validated with that audience. Proposed: the workflow is not built. No adoption, telemetry, time-saving or customer-validation results are claimed. Any field use still needs repository eligibility, owner review and a human decision before action. Slide 14 lists workflows; this slide lists who would use the pattern.</a:t>
+              <a:t>Only developer repository exploration is implemented today (Prototype). The other three rows are reuse patterns of the same guide format and review discipline: each audience runs a light FDE pass, a first-pass, read-only exploration of a repo before a deep-dive. Emerging: today’s guide could be reused as-is but has not been validated with that audience. Proposed: the workflow is not built. No adoption, telemetry, time-saving or customer-validation results are claimed. Light does not mean replacing a real forward-deployed engineer or the service owner. Any field use still needs repository eligibility, owner review and a human decision before action. Slide 16 lists workflows; this slide lists who would use the pattern.</a:t>
+            </a:r>
+          </a:p>
+        </p:txBody>
+      </p:sp>
+      <p:sp>
+        <p:nvSpPr>
+          <p:cNvPr id="4" name="Slide Number Placeholder 3"/>
+          <p:cNvSpPr>
+            <a:spLocks noGrp="1"/>
+          </p:cNvSpPr>
+          <p:nvPr>
+            <p:ph type="sldNum" idx="5" sz="quarter"/>
+          </p:nvPr>
+        </p:nvSpPr>
+        <p:spPr/>
+      </p:sp>
+    </p:spTree>
+  </p:cSld>
+  <p:clrMapOvr>
+    <a:masterClrMapping/>
+  </p:clrMapOvr>
+</p:notes>
+</file>
+
+<file path=ppt/notesSlides/notesSlide18.xml><?xml version="1.0" encoding="utf-8"?>
+<p:notes xmlns:a="http://schemas.openxmlformats.org/drawingml/2006/main" xmlns:p="http://schemas.openxmlformats.org/presentationml/2006/main" xmlns:r="http://schemas.openxmlformats.org/officeDocument/2006/relationships">
+  <p:cSld>
+    <p:spTree>
+      <p:nvGrpSpPr>
+        <p:cNvPr id="1" name=""/>
+        <p:cNvGrpSpPr/>
+        <p:nvPr/>
+      </p:nvGrpSpPr>
+      <p:grpSpPr>
+        <a:xfrm>
+          <a:off x="0" y="0"/>
+          <a:ext cx="0" cy="0"/>
+          <a:chOff x="0" y="0"/>
+          <a:chExt cx="0" cy="0"/>
+        </a:xfrm>
+      </p:grpSpPr>
+      <p:sp>
+        <p:nvSpPr>
+          <p:cNvPr id="2" name="Slide Image Placeholder 1"/>
+          <p:cNvSpPr>
+            <a:spLocks noGrp="1"/>
+          </p:cNvSpPr>
+          <p:nvPr>
+            <p:ph type="sldImg" idx="2"/>
+          </p:nvPr>
+        </p:nvSpPr>
+        <p:spPr/>
+      </p:sp>
+      <p:sp>
+        <p:nvSpPr>
+          <p:cNvPr id="3" name="Notes Placeholder 2"/>
+          <p:cNvSpPr>
+            <a:spLocks noGrp="1"/>
+          </p:cNvSpPr>
+          <p:nvPr>
+            <p:ph type="body" idx="3" sz="quarter"/>
+          </p:nvPr>
+        </p:nvSpPr>
+        <p:spPr/>
+        <p:txBody>
+          <a:bodyPr/>
+          <a:lstStyle/>
+          <a:p>
+            <a:r>
+              <a:t>Input: a repository. Output: what is worth optimizing, with evidence. This is the light forward-deployed engineer idea in one slide: embed read-only, explore, and come back with a cited picture and a short list of where to improve. The exploration uses the five stages from the previous slide (plan, delegate, validate, review, ship), each with a human review gate. Prototype (built today): the cited picture, meaning a map, conventions marked documented or observed, workflow, merged-PR history and first steps, plus explicit unavailable sections; every claim cites file and line; agents are read-only with no shell; Bearing stops before implementation. Emerging: the evidence gaps /onboard-repo already surfaces (unavailable sections, conventions that are only observed and not documented, missing docs) are the first optimization signals a team can act on today. This is not a ranked output. Proposed, not built: ranked optimization candidates (for example test confidence, delivery friction, supportability, ownership and documentation risk), each with cited evidence, a confidence level and a delegable task brief for Copilot behind a human review gate; the modernization assessment slides that follow describe that half. Bearing does not find optimizations today. No measured results, time savings, customer validation or telemetry are claimed, and it does not run builds or tests or measure coverage or CI. Path and line checks validate references, not semantic correctness. Light means first-pass exploration; it does not replace a real forward-deployed engineer or the service owner.</a:t>
             </a:r>
           </a:p>
         </p:txBody>
@@ -1260,6 +1351,11 @@
           <a:p>
             <a:r>
               <a:t>Right-hand claims are verified against the repo: plugins/bearing/agents/repo-cartographer.agent.md (every claim from a file read with view; documented vs observed conventions; unavailable sections with a reason), plugins/bearing/skills/onboard-repo/SKILL.md (no repository changes, no build, install or test commands, no implementation work) and the extension section validation (referenced files must exist; line ranges are checked). The left-hand column characterizes ad-hoc prompting in general, not any named product. Bearing does not verify that an explanation is semantically correct; the developer reviews the cited evidence. The diamond marks the human review gate.</a:t>
+            </a:r>
+          </a:p>
+          <a:p>
+            <a:r>
+              <a:t>Bottom line: today Bearing explores a repository read-only and cites its evidence (Prototype). Applying the same review discipline to ranked optimization candidates is Proposed and not built.</a:t>
             </a:r>
           </a:p>
         </p:txBody>
@@ -5022,7 +5118,7 @@
       </p:sp>
       <p:sp>
         <p:nvSpPr>
-          <p:cNvPr id="6" name="01 / 18"/>
+          <p:cNvPr id="6" name="01 / 19"/>
           <p:cNvSpPr txBox="1"/>
           <p:nvPr/>
         </p:nvSpPr>
@@ -5057,7 +5153,7 @@
                 </a:solidFill>
                 <a:latin typeface="Arial"/>
               </a:rPr>
-              <a:t>01 / 18</a:t>
+              <a:t>01 / 19</a:t>
             </a:r>
           </a:p>
         </p:txBody>
@@ -5423,7 +5519,7 @@
       </p:sp>
       <p:sp>
         <p:nvSpPr>
-          <p:cNvPr id="12" name="Repository onboarding today."/>
+          <p:cNvPr id="12" name="A light forward-deployed engineer"/>
           <p:cNvSpPr txBox="1"/>
           <p:nvPr/>
         </p:nvSpPr>
@@ -5458,7 +5554,7 @@
                 </a:solidFill>
                 <a:latin typeface="Arial"/>
               </a:rPr>
-              <a:t>Repository onboarding today.</a:t>
+              <a:t>A light forward-deployed engineer</a:t>
             </a:r>
           </a:p>
           <a:p>
@@ -5477,7 +5573,7 @@
                 </a:solidFill>
                 <a:latin typeface="Arial"/>
               </a:rPr>
-              <a:t>Legacy modernization next.</a:t>
+              <a:t>for any team.</a:t>
             </a:r>
           </a:p>
         </p:txBody>
@@ -5588,7 +5684,7 @@
       </p:sp>
       <p:sp>
         <p:nvSpPr>
-          <p:cNvPr id="15" name="Unfamiliar code"/>
+          <p:cNvPr id="15" name="A repository"/>
           <p:cNvSpPr txBox="1"/>
           <p:nvPr/>
         </p:nvSpPr>
@@ -5623,7 +5719,7 @@
                 </a:solidFill>
                 <a:latin typeface="Arial"/>
               </a:rPr>
-              <a:t>Unfamiliar code</a:t>
+              <a:t>A repository</a:t>
             </a:r>
           </a:p>
         </p:txBody>
@@ -5964,7 +6060,7 @@
                 </a:solidFill>
                 <a:latin typeface="Arial"/>
               </a:rPr>
-              <a:t>Independent Bearing prototype. Content marked Illustrative or Proposed is not implemented.</a:t>
+              <a:t>Independent Bearing prototype. “Light” = first-pass, read-only exploration. Content marked Illustrative or Proposed is not implemented.</a:t>
             </a:r>
           </a:p>
         </p:txBody>
@@ -6314,7 +6410,7 @@
       </p:sp>
       <p:sp>
         <p:nvSpPr>
-          <p:cNvPr id="6" name="11 / 18"/>
+          <p:cNvPr id="6" name="12 / 19"/>
           <p:cNvSpPr txBox="1"/>
           <p:nvPr/>
         </p:nvSpPr>
@@ -6349,7 +6445,7 @@
                 </a:solidFill>
                 <a:latin typeface="Arial"/>
               </a:rPr>
-              <a:t>11 / 18</a:t>
+              <a:t>12 / 19</a:t>
             </a:r>
           </a:p>
         </p:txBody>
@@ -7714,7 +7810,7 @@
       </p:sp>
       <p:sp>
         <p:nvSpPr>
-          <p:cNvPr id="6" name="12 / 18"/>
+          <p:cNvPr id="6" name="13 / 19"/>
           <p:cNvSpPr txBox="1"/>
           <p:nvPr/>
         </p:nvSpPr>
@@ -7749,7 +7845,7 @@
                 </a:solidFill>
                 <a:latin typeface="Arial"/>
               </a:rPr>
-              <a:t>12 / 18</a:t>
+              <a:t>13 / 19</a:t>
             </a:r>
           </a:p>
         </p:txBody>
@@ -8901,7 +8997,7 @@
       </p:sp>
       <p:sp>
         <p:nvSpPr>
-          <p:cNvPr id="6" name="13 / 18"/>
+          <p:cNvPr id="6" name="14 / 19"/>
           <p:cNvSpPr txBox="1"/>
           <p:nvPr/>
         </p:nvSpPr>
@@ -8936,7 +9032,7 @@
                 </a:solidFill>
                 <a:latin typeface="Arial"/>
               </a:rPr>
-              <a:t>13 / 18</a:t>
+              <a:t>14 / 19</a:t>
             </a:r>
           </a:p>
         </p:txBody>
@@ -8985,7 +9081,7 @@
       </p:sp>
       <p:sp>
         <p:nvSpPr>
-          <p:cNvPr id="8" name="Read-only repository orientation."/>
+          <p:cNvPr id="8" name="Read-only repository exploration."/>
           <p:cNvSpPr txBox="1"/>
           <p:nvPr/>
         </p:nvSpPr>
@@ -9020,7 +9116,7 @@
                 </a:solidFill>
                 <a:latin typeface="Arial"/>
               </a:rPr>
-              <a:t>Read-only repository orientation.</a:t>
+              <a:t>Read-only repository exploration.</a:t>
             </a:r>
           </a:p>
           <a:p>
@@ -9103,7 +9199,7 @@
       </p:sp>
       <p:sp>
         <p:nvSpPr>
-          <p:cNvPr id="9" name="Separate proposed assessment"/>
+          <p:cNvPr id="9" name="Proposed: what to optimize"/>
           <p:cNvSpPr txBox="1"/>
           <p:nvPr/>
         </p:nvSpPr>
@@ -9138,14 +9234,14 @@
                 </a:solidFill>
                 <a:latin typeface="Mona Sans"/>
               </a:rPr>
-              <a:t>Separate proposed assessment</a:t>
-            </a:r>
-          </a:p>
-        </p:txBody>
-      </p:sp>
-      <p:sp>
-        <p:nvSpPr>
-          <p:cNvPr id="10" name="Critical-journey and owner review."/>
+              <a:t>Proposed: what to optimize</a:t>
+            </a:r>
+          </a:p>
+        </p:txBody>
+      </p:sp>
+      <p:sp>
+        <p:nvSpPr>
+          <p:cNvPr id="10" name="Ranked optimization candidates."/>
           <p:cNvSpPr txBox="1"/>
           <p:nvPr/>
         </p:nvSpPr>
@@ -9180,7 +9276,7 @@
                 </a:solidFill>
                 <a:latin typeface="Arial"/>
               </a:rPr>
-              <a:t>Critical-journey and owner review.</a:t>
+              <a:t>Ranked optimization candidates.</a:t>
             </a:r>
           </a:p>
           <a:p>
@@ -9199,7 +9295,7 @@
                 </a:solidFill>
                 <a:latin typeface="Arial"/>
               </a:rPr>
-              <a:t>Coverage and CI data collection.</a:t>
+              <a:t>Critical-journey and owner review.</a:t>
             </a:r>
           </a:p>
           <a:p>
@@ -9218,7 +9314,7 @@
                 </a:solidFill>
                 <a:latin typeface="Arial"/>
               </a:rPr>
-              <a:t>Comparable runtime measurements.</a:t>
+              <a:t>Coverage, CI and runtime measurement.</a:t>
             </a:r>
           </a:p>
           <a:p>
@@ -9256,7 +9352,7 @@
                 </a:solidFill>
                 <a:latin typeface="Arial"/>
               </a:rPr>
-              <a:t>Prioritization and GitHub project setup.</a:t>
+              <a:t>Task briefs and GitHub project setup.</a:t>
             </a:r>
           </a:p>
         </p:txBody>
@@ -9427,7 +9523,7 @@
                 </a:solidFill>
                 <a:latin typeface="Arial"/>
               </a:rPr>
-              <a:t>Bearing does not run builds/tests, measure coverage or automatically create this project.</a:t>
+              <a:t>Bearing does not run builds/tests, measure coverage or rank optimizations.</a:t>
             </a:r>
           </a:p>
         </p:txBody>
@@ -9777,7 +9873,7 @@
       </p:sp>
       <p:sp>
         <p:nvSpPr>
-          <p:cNvPr id="6" name="14 / 18"/>
+          <p:cNvPr id="6" name="15 / 19"/>
           <p:cNvSpPr txBox="1"/>
           <p:nvPr/>
         </p:nvSpPr>
@@ -9812,7 +9908,7 @@
                 </a:solidFill>
                 <a:latin typeface="Arial"/>
               </a:rPr>
-              <a:t>14 / 18</a:t>
+              <a:t>15 / 19</a:t>
             </a:r>
           </a:p>
         </p:txBody>
@@ -10697,7 +10793,7 @@
                 </a:solidFill>
                 <a:latin typeface="Arial"/>
               </a:rPr>
-              <a:t>Enablement teams can reuse one guide format. Not yet validated with non-developer users.</a:t>
+              <a:t>Field teams can reuse it as a light FDE pass. Not yet validated with non-developer users.</a:t>
             </a:r>
           </a:p>
         </p:txBody>
@@ -10747,7 +10843,7 @@
       </p:sp>
       <p:sp>
         <p:nvSpPr>
-          <p:cNvPr id="28" name="Reaches beyond onboarding"/>
+          <p:cNvPr id="28" name="Ranks what to optimize"/>
           <p:cNvSpPr txBox="1"/>
           <p:nvPr/>
         </p:nvSpPr>
@@ -10782,7 +10878,7 @@
                 </a:solidFill>
                 <a:latin typeface="Arial"/>
               </a:rPr>
-              <a:t>Reaches beyond onboarding</a:t>
+              <a:t>Ranks what to optimize</a:t>
             </a:r>
           </a:p>
         </p:txBody>
@@ -10876,7 +10972,7 @@
                 </a:solidFill>
                 <a:latin typeface="Arial"/>
               </a:rPr>
-              <a:t>The legacy modernization assessment in this deck. No such workflow is implemented.</a:t>
+              <a:t>Ranked candidates with evidence and task briefs, as proposed in this deck. Not implemented.</a:t>
             </a:r>
           </a:p>
         </p:txBody>
@@ -11226,7 +11322,7 @@
       </p:sp>
       <p:sp>
         <p:nvSpPr>
-          <p:cNvPr id="6" name="15 / 18"/>
+          <p:cNvPr id="6" name="16 / 19"/>
           <p:cNvSpPr txBox="1"/>
           <p:nvPr/>
         </p:nvSpPr>
@@ -11261,7 +11357,7 @@
                 </a:solidFill>
                 <a:latin typeface="Arial"/>
               </a:rPr>
-              <a:t>15 / 18</a:t>
+              <a:t>16 / 19</a:t>
             </a:r>
           </a:p>
         </p:txBody>
@@ -11522,7 +11618,7 @@
       </p:sp>
       <p:sp>
         <p:nvSpPr>
-          <p:cNvPr id="13" name="Repository onboarding"/>
+          <p:cNvPr id="13" name="Repository exploration"/>
           <p:cNvSpPr txBox="1"/>
           <p:nvPr/>
         </p:nvSpPr>
@@ -11557,7 +11653,7 @@
                 </a:solidFill>
                 <a:latin typeface="Arial"/>
               </a:rPr>
-              <a:t>Repository onboarding</a:t>
+              <a:t>Repository exploration</a:t>
             </a:r>
           </a:p>
         </p:txBody>
@@ -11606,7 +11702,7 @@
       </p:sp>
       <p:sp>
         <p:nvSpPr>
-          <p:cNvPr id="15" name="An evidence-backed guide inside the Copilot App."/>
+          <p:cNvPr id="15" name="A light FDE pass: an evidence-backed guide inside the Copilot App."/>
           <p:cNvSpPr txBox="1"/>
           <p:nvPr/>
         </p:nvSpPr>
@@ -11641,7 +11737,7 @@
                 </a:solidFill>
                 <a:latin typeface="Arial"/>
               </a:rPr>
-              <a:t>An evidence-backed guide inside the Copilot App.</a:t>
+              <a:t>A light FDE pass: an evidence-backed guide inside the Copilot App.</a:t>
             </a:r>
           </a:p>
         </p:txBody>
@@ -11743,7 +11839,7 @@
       </p:sp>
       <p:sp>
         <p:nvSpPr>
-          <p:cNvPr id="18" name="Legacy modernization assessment"/>
+          <p:cNvPr id="18" name="Optimization assessment"/>
           <p:cNvSpPr txBox="1"/>
           <p:nvPr/>
         </p:nvSpPr>
@@ -11778,7 +11874,7 @@
                 </a:solidFill>
                 <a:latin typeface="Arial"/>
               </a:rPr>
-              <a:t>Legacy modernization assessment</a:t>
+              <a:t>Optimization assessment</a:t>
             </a:r>
           </a:p>
         </p:txBody>
@@ -11827,7 +11923,7 @@
       </p:sp>
       <p:sp>
         <p:nvSpPr>
-          <p:cNvPr id="20" name="Locate the real constraint. Build a backlog of hypotheses."/>
+          <p:cNvPr id="20" name="Locate the real constraint. Rank candidates with evidence and task briefs."/>
           <p:cNvSpPr txBox="1"/>
           <p:nvPr/>
         </p:nvSpPr>
@@ -11862,7 +11958,7 @@
                 </a:solidFill>
                 <a:latin typeface="Arial"/>
               </a:rPr>
-              <a:t>Locate the real constraint. Build a backlog of hypotheses.</a:t>
+              <a:t>Locate the real constraint. Rank candidates with evidence and task briefs.</a:t>
             </a:r>
           </a:p>
         </p:txBody>
@@ -12969,7 +13065,7 @@
       </p:sp>
       <p:sp>
         <p:nvSpPr>
-          <p:cNvPr id="6" name="17 / 18"/>
+          <p:cNvPr id="6" name="18 / 19"/>
           <p:cNvSpPr txBox="1"/>
           <p:nvPr/>
         </p:nvSpPr>
@@ -13004,14 +13100,14 @@
                 </a:solidFill>
                 <a:latin typeface="Arial"/>
               </a:rPr>
-              <a:t>17 / 18</a:t>
-            </a:r>
-          </a:p>
-        </p:txBody>
-      </p:sp>
-      <p:sp>
-        <p:nvSpPr>
-          <p:cNvPr id="7" name="Prove one justified improvement."/>
+              <a:t>18 / 19</a:t>
+            </a:r>
+          </a:p>
+        </p:txBody>
+      </p:sp>
+      <p:sp>
+        <p:nvSpPr>
+          <p:cNvPr id="7" name="Light FDE pass, then one improvement."/>
           <p:cNvSpPr txBox="1"/>
           <p:nvPr/>
         </p:nvSpPr>
@@ -13046,7 +13142,7 @@
                 </a:solidFill>
                 <a:latin typeface="Mona Sans"/>
               </a:rPr>
-              <a:t>Prove one justified improvement.</a:t>
+              <a:t>Light FDE pass, then one improvement.</a:t>
             </a:r>
           </a:p>
         </p:txBody>
@@ -13766,7 +13862,7 @@
       </p:sp>
       <p:sp>
         <p:nvSpPr>
-          <p:cNvPr id="6" name="18 / 18"/>
+          <p:cNvPr id="6" name="19 / 19"/>
           <p:cNvSpPr txBox="1"/>
           <p:nvPr/>
         </p:nvSpPr>
@@ -13801,7 +13897,7 @@
                 </a:solidFill>
                 <a:latin typeface="Arial"/>
               </a:rPr>
-              <a:t>18 / 18</a:t>
+              <a:t>19 / 19</a:t>
             </a:r>
           </a:p>
         </p:txBody>
@@ -14278,7 +14374,7 @@
                 </a:solidFill>
                 <a:latin typeface="Arial"/>
               </a:rPr>
-              <a:t>Checked October 5, 2026. No customer ROI or shipped modernization capability is claimed.</a:t>
+              <a:t>Checked October 5, 2026. No customer ROI, ranked optimization or shipped modernization capability is claimed.</a:t>
             </a:r>
           </a:p>
         </p:txBody>
@@ -14628,7 +14724,7 @@
       </p:sp>
       <p:sp>
         <p:nvSpPr>
-          <p:cNvPr id="6" name="16 / 18"/>
+          <p:cNvPr id="6" name="17 / 19"/>
           <p:cNvSpPr txBox="1"/>
           <p:nvPr/>
         </p:nvSpPr>
@@ -14663,7 +14759,7 @@
                 </a:solidFill>
                 <a:latin typeface="Arial"/>
               </a:rPr>
-              <a:t>16 / 18</a:t>
+              <a:t>17 / 19</a:t>
             </a:r>
           </a:p>
         </p:txBody>
@@ -14966,7 +15062,7 @@
       </p:sp>
       <p:sp>
         <p:nvSpPr>
-          <p:cNvPr id="14" name="Frame a one-service pilot with the customer: agree the service, owner and review gate."/>
+          <p:cNvPr id="14" name="Run a light FDE pass on one service; agree owner and review gate."/>
           <p:cNvSpPr txBox="1"/>
           <p:nvPr/>
         </p:nvSpPr>
@@ -15001,7 +15097,7 @@
                 </a:solidFill>
                 <a:latin typeface="Arial"/>
               </a:rPr>
-              <a:t>Frame a one-service pilot with the customer: agree the service, owner and review gate.</a:t>
+              <a:t>Run a light FDE pass on one service; agree owner and review gate.</a:t>
             </a:r>
           </a:p>
         </p:txBody>
@@ -15187,7 +15283,7 @@
       </p:sp>
       <p:sp>
         <p:nvSpPr>
-          <p:cNvPr id="19" name="Run today’s guide with the service owner; log gaps and unavailable sections."/>
+          <p:cNvPr id="19" name="Run a light FDE pass with the service owner; log gaps and unavailable sections."/>
           <p:cNvSpPr txBox="1"/>
           <p:nvPr/>
         </p:nvSpPr>
@@ -15222,7 +15318,7 @@
                 </a:solidFill>
                 <a:latin typeface="Arial"/>
               </a:rPr>
-              <a:t>Run today’s guide with the service owner; log gaps and unavailable sections.</a:t>
+              <a:t>Run a light FDE pass with the service owner; log gaps and unavailable sections.</a:t>
             </a:r>
           </a:p>
         </p:txBody>
@@ -15408,7 +15504,7 @@
       </p:sp>
       <p:sp>
         <p:nvSpPr>
-          <p:cNvPr id="24" name="Build a cited map of a customer service before the technical deep-dive."/>
+          <p:cNvPr id="24" name="Run a light FDE pass for a cited map before the technical deep-dive."/>
           <p:cNvSpPr txBox="1"/>
           <p:nvPr/>
         </p:nvSpPr>
@@ -15443,7 +15539,7 @@
                 </a:solidFill>
                 <a:latin typeface="Arial"/>
               </a:rPr>
-              <a:t>Build a cited map of a customer service before the technical deep-dive.</a:t>
+              <a:t>Run a light FDE pass for a cited map before the technical deep-dive.</a:t>
             </a:r>
           </a:p>
         </p:txBody>
@@ -15629,7 +15725,7 @@
       </p:sp>
       <p:sp>
         <p:nvSpPr>
-          <p:cNvPr id="29" name="Run /onboard-repo, inspect the cited files, then decide the first task."/>
+          <p:cNvPr id="29" name="Run /onboard-repo as the light FDE pass, then inspect the cited files."/>
           <p:cNvSpPr txBox="1"/>
           <p:nvPr/>
         </p:nvSpPr>
@@ -15664,7 +15760,7 @@
                 </a:solidFill>
                 <a:latin typeface="Arial"/>
               </a:rPr>
-              <a:t>Run /onboard-repo, inspect the cited files, then decide the first task.</a:t>
+              <a:t>Run /onboard-repo as the light FDE pass, then inspect the cited files.</a:t>
             </a:r>
           </a:p>
         </p:txBody>
@@ -15765,7 +15861,7 @@
       </p:sp>
       <p:sp>
         <p:nvSpPr>
-          <p:cNvPr id="37" name="Prototype: implemented in this repository. Emerging: today’s guide reused as-is, not yet validated with this audience. Proposed: not built. Only developer onboarding exists today."/>
+          <p:cNvPr id="37" name="Prototype: implemented in this repository. Emerging: today’s guide reused as-is, not yet validated with this audience. Proposed: not built. Only developer repository exploration exists today."/>
           <p:cNvSpPr txBox="1"/>
           <p:nvPr/>
         </p:nvSpPr>
@@ -15800,7 +15896,7 @@
                 </a:solidFill>
                 <a:latin typeface="Arial"/>
               </a:rPr>
-              <a:t>Prototype: implemented in this repository. Emerging: today’s guide reused as-is, not yet validated with this audience. Proposed: not built. Only developer onboarding exists today.</a:t>
+              <a:t>Prototype: implemented in this repository. Emerging: today’s guide reused as-is, not yet validated with this audience. Proposed: not built. Only developer repository exploration exists today.</a:t>
             </a:r>
           </a:p>
         </p:txBody>
@@ -16150,7 +16246,7 @@
       </p:sp>
       <p:sp>
         <p:nvSpPr>
-          <p:cNvPr id="6" name="04 / 18"/>
+          <p:cNvPr id="6" name="04 / 19"/>
           <p:cNvSpPr txBox="1"/>
           <p:nvPr/>
         </p:nvSpPr>
@@ -16185,7 +16281,7 @@
                 </a:solidFill>
                 <a:latin typeface="Arial"/>
               </a:rPr>
-              <a:t>04 / 18</a:t>
+              <a:t>04 / 19</a:t>
             </a:r>
           </a:p>
         </p:txBody>
@@ -17457,6 +17553,1707 @@
                 <a:latin typeface="Arial"/>
               </a:rPr>
               <a:t>Prototype: all five stages are implemented in this repository. Diamonds mark human review gates. Path and line checks validate references, not semantic correctness.</a:t>
+            </a:r>
+          </a:p>
+        </p:txBody>
+      </p:sp>
+    </p:spTree>
+  </p:cSld>
+  <p:clrMapOvr>
+    <a:masterClrMapping/>
+  </p:clrMapOvr>
+</p:sld>
+</file>
+
+<file path=ppt/slides/slide19.xml><?xml version="1.0" encoding="utf-8"?>
+<p:sld xmlns:a="http://schemas.openxmlformats.org/drawingml/2006/main" xmlns:p="http://schemas.openxmlformats.org/presentationml/2006/main" xmlns:r="http://schemas.openxmlformats.org/officeDocument/2006/relationships">
+  <p:cSld>
+    <p:bg>
+      <p:bgPr>
+        <a:solidFill>
+          <a:srgbClr val="FFFFFF"/>
+        </a:solidFill>
+        <a:effectLst/>
+      </p:bgPr>
+    </p:bg>
+    <p:spTree>
+      <p:nvGrpSpPr>
+        <p:cNvPr id="1" name=""/>
+        <p:cNvGrpSpPr/>
+        <p:nvPr/>
+      </p:nvGrpSpPr>
+      <p:grpSpPr/>
+      <p:sp>
+        <p:nvSpPr>
+          <p:cNvPr id="2" name="Input: a repository. Output: what to optimize."/>
+          <p:cNvSpPr txBox="1"/>
+          <p:nvPr/>
+        </p:nvSpPr>
+        <p:spPr>
+          <a:xfrm>
+            <a:off x="594360" y="502920"/>
+            <a:ext cx="10972800" cy="1005840"/>
+          </a:xfrm>
+          <a:prstGeom prst="rect">
+            <a:avLst/>
+          </a:prstGeom>
+          <a:noFill/>
+        </p:spPr>
+        <p:txBody>
+          <a:bodyPr wrap="square" lIns="0" rIns="0" tIns="0" bIns="0">
+            <a:spAutoFit/>
+          </a:bodyPr>
+          <a:lstStyle/>
+          <a:p>
+            <a:pPr>
+              <a:lnSpc>
+                <a:spcPct val="107000"/>
+              </a:lnSpc>
+              <a:spcAft>
+                <a:spcPts val="500"/>
+              </a:spcAft>
+            </a:pPr>
+            <a:r>
+              <a:rPr sz="3200" b="1">
+                <a:solidFill>
+                  <a:srgbClr val="101411"/>
+                </a:solidFill>
+                <a:latin typeface="Mona Sans"/>
+              </a:rPr>
+              <a:t>Input: a repository. Output: what to optimize.</a:t>
+            </a:r>
+          </a:p>
+        </p:txBody>
+      </p:sp>
+      <p:sp>
+        <p:nvSpPr>
+          <p:cNvPr id="3" name="Rectangle 2"/>
+          <p:cNvSpPr/>
+          <p:nvPr/>
+        </p:nvSpPr>
+        <p:spPr>
+          <a:xfrm>
+            <a:off x="594360" y="6327648"/>
+            <a:ext cx="10972800" cy="10972"/>
+          </a:xfrm>
+          <a:prstGeom prst="rect">
+            <a:avLst/>
+          </a:prstGeom>
+          <a:solidFill>
+            <a:srgbClr val="E4EBE6"/>
+          </a:solidFill>
+          <a:ln>
+            <a:noFill/>
+          </a:ln>
+        </p:spPr>
+        <p:style>
+          <a:lnRef idx="1">
+            <a:schemeClr val="accent1"/>
+          </a:lnRef>
+          <a:fillRef idx="3">
+            <a:schemeClr val="accent1"/>
+          </a:fillRef>
+          <a:effectRef idx="2">
+            <a:schemeClr val="accent1"/>
+          </a:effectRef>
+          <a:fontRef idx="minor">
+            <a:schemeClr val="lt1"/>
+          </a:fontRef>
+        </p:style>
+        <p:txBody>
+          <a:bodyPr rtlCol="0" anchor="ctr"/>
+          <a:lstStyle/>
+          <a:p>
+            <a:pPr algn="ctr"/>
+          </a:p>
+        </p:txBody>
+      </p:sp>
+      <p:sp>
+        <p:nvSpPr>
+          <p:cNvPr id="4" name="GitHub mark" descr="GitHub logo"/>
+          <p:cNvSpPr/>
+          <p:nvPr/>
+        </p:nvSpPr>
+        <p:spPr>
+          <a:xfrm>
+            <a:off x="594360" y="6419088"/>
+            <a:ext cx="182880" cy="182880"/>
+          </a:xfrm>
+          <a:custGeom>
+            <a:avLst/>
+            <a:gdLst/>
+            <a:ahLst/>
+            <a:cxnLst/>
+            <a:rect l="0" t="0" r="r" b="b"/>
+            <a:pathLst>
+              <a:path w="16000" h="16000">
+                <a:moveTo>
+                  <a:pt x="8000" y="0"/>
+                </a:moveTo>
+                <a:cubicBezTo>
+                  <a:pt x="3580" y="0"/>
+                  <a:pt x="0" y="3580"/>
+                  <a:pt x="0" y="8000"/>
+                </a:cubicBezTo>
+                <a:cubicBezTo>
+                  <a:pt x="0" y="11540"/>
+                  <a:pt x="2290" y="14530"/>
+                  <a:pt x="5470" y="15590"/>
+                </a:cubicBezTo>
+                <a:cubicBezTo>
+                  <a:pt x="5870" y="15660"/>
+                  <a:pt x="6020" y="15420"/>
+                  <a:pt x="6020" y="15210"/>
+                </a:cubicBezTo>
+                <a:cubicBezTo>
+                  <a:pt x="6020" y="15020"/>
+                  <a:pt x="6010" y="14390"/>
+                  <a:pt x="6010" y="13720"/>
+                </a:cubicBezTo>
+                <a:cubicBezTo>
+                  <a:pt x="4000" y="14090"/>
+                  <a:pt x="3480" y="13230"/>
+                  <a:pt x="3320" y="12780"/>
+                </a:cubicBezTo>
+                <a:cubicBezTo>
+                  <a:pt x="3230" y="12550"/>
+                  <a:pt x="2840" y="11840"/>
+                  <a:pt x="2500" y="11650"/>
+                </a:cubicBezTo>
+                <a:cubicBezTo>
+                  <a:pt x="2220" y="11500"/>
+                  <a:pt x="1820" y="11130"/>
+                  <a:pt x="2490" y="11120"/>
+                </a:cubicBezTo>
+                <a:cubicBezTo>
+                  <a:pt x="3120" y="11110"/>
+                  <a:pt x="3570" y="11700"/>
+                  <a:pt x="3720" y="11940"/>
+                </a:cubicBezTo>
+                <a:cubicBezTo>
+                  <a:pt x="4440" y="13150"/>
+                  <a:pt x="5590" y="12810"/>
+                  <a:pt x="6050" y="12600"/>
+                </a:cubicBezTo>
+                <a:cubicBezTo>
+                  <a:pt x="6120" y="12080"/>
+                  <a:pt x="6330" y="11730"/>
+                  <a:pt x="6560" y="11530"/>
+                </a:cubicBezTo>
+                <a:cubicBezTo>
+                  <a:pt x="4780" y="11330"/>
+                  <a:pt x="2920" y="10640"/>
+                  <a:pt x="2920" y="7580"/>
+                </a:cubicBezTo>
+                <a:cubicBezTo>
+                  <a:pt x="2920" y="6710"/>
+                  <a:pt x="3230" y="5990"/>
+                  <a:pt x="3740" y="5430"/>
+                </a:cubicBezTo>
+                <a:cubicBezTo>
+                  <a:pt x="3660" y="5230"/>
+                  <a:pt x="3380" y="4410"/>
+                  <a:pt x="3820" y="3310"/>
+                </a:cubicBezTo>
+                <a:cubicBezTo>
+                  <a:pt x="3820" y="3310"/>
+                  <a:pt x="4490" y="3100"/>
+                  <a:pt x="6020" y="4130"/>
+                </a:cubicBezTo>
+                <a:cubicBezTo>
+                  <a:pt x="6660" y="3950"/>
+                  <a:pt x="7340" y="3860"/>
+                  <a:pt x="8020" y="3860"/>
+                </a:cubicBezTo>
+                <a:cubicBezTo>
+                  <a:pt x="8700" y="3860"/>
+                  <a:pt x="9380" y="3950"/>
+                  <a:pt x="10020" y="4130"/>
+                </a:cubicBezTo>
+                <a:cubicBezTo>
+                  <a:pt x="11550" y="3090"/>
+                  <a:pt x="12220" y="3310"/>
+                  <a:pt x="12220" y="3310"/>
+                </a:cubicBezTo>
+                <a:cubicBezTo>
+                  <a:pt x="12660" y="4410"/>
+                  <a:pt x="12380" y="5230"/>
+                  <a:pt x="12300" y="5430"/>
+                </a:cubicBezTo>
+                <a:cubicBezTo>
+                  <a:pt x="12810" y="5990"/>
+                  <a:pt x="13120" y="6700"/>
+                  <a:pt x="13120" y="7580"/>
+                </a:cubicBezTo>
+                <a:cubicBezTo>
+                  <a:pt x="13120" y="10650"/>
+                  <a:pt x="11250" y="11330"/>
+                  <a:pt x="9470" y="11530"/>
+                </a:cubicBezTo>
+                <a:cubicBezTo>
+                  <a:pt x="9760" y="11780"/>
+                  <a:pt x="10010" y="12260"/>
+                  <a:pt x="10010" y="13010"/>
+                </a:cubicBezTo>
+                <a:cubicBezTo>
+                  <a:pt x="10010" y="14080"/>
+                  <a:pt x="10000" y="14940"/>
+                  <a:pt x="10000" y="15210"/>
+                </a:cubicBezTo>
+                <a:cubicBezTo>
+                  <a:pt x="10000" y="15420"/>
+                  <a:pt x="10150" y="15670"/>
+                  <a:pt x="10550" y="15590"/>
+                </a:cubicBezTo>
+                <a:cubicBezTo>
+                  <a:pt x="11604" y="15234"/>
+                  <a:pt x="12572" y="14663"/>
+                  <a:pt x="13394" y="13912"/>
+                </a:cubicBezTo>
+                <a:cubicBezTo>
+                  <a:pt x="14215" y="13162"/>
+                  <a:pt x="14870" y="12248"/>
+                  <a:pt x="15319" y="11231"/>
+                </a:cubicBezTo>
+                <a:cubicBezTo>
+                  <a:pt x="15768" y="10213"/>
+                  <a:pt x="16000" y="9112"/>
+                  <a:pt x="16000" y="8000"/>
+                </a:cubicBezTo>
+                <a:cubicBezTo>
+                  <a:pt x="16000" y="3580"/>
+                  <a:pt x="12420" y="0"/>
+                  <a:pt x="8000" y="0"/>
+                </a:cubicBezTo>
+                <a:close/>
+              </a:path>
+            </a:pathLst>
+          </a:custGeom>
+          <a:solidFill>
+            <a:srgbClr val="101411"/>
+          </a:solidFill>
+          <a:ln>
+            <a:noFill/>
+          </a:ln>
+        </p:spPr>
+        <p:style>
+          <a:lnRef idx="1">
+            <a:schemeClr val="accent1"/>
+          </a:lnRef>
+          <a:fillRef idx="3">
+            <a:schemeClr val="accent1"/>
+          </a:fillRef>
+          <a:effectRef idx="2">
+            <a:schemeClr val="accent1"/>
+          </a:effectRef>
+          <a:fontRef idx="minor">
+            <a:schemeClr val="lt1"/>
+          </a:fontRef>
+        </p:style>
+        <p:txBody>
+          <a:bodyPr rtlCol="0" anchor="ctr"/>
+          <a:lstStyle/>
+          <a:p>
+            <a:pPr algn="ctr"/>
+          </a:p>
+        </p:txBody>
+      </p:sp>
+      <p:sp>
+        <p:nvSpPr>
+          <p:cNvPr id="5" name="Bearing  |  GitHub Copilot App workflow"/>
+          <p:cNvSpPr txBox="1"/>
+          <p:nvPr/>
+        </p:nvSpPr>
+        <p:spPr>
+          <a:xfrm>
+            <a:off x="914400" y="6428232"/>
+            <a:ext cx="7726679" cy="201168"/>
+          </a:xfrm>
+          <a:prstGeom prst="rect">
+            <a:avLst/>
+          </a:prstGeom>
+          <a:noFill/>
+        </p:spPr>
+        <p:txBody>
+          <a:bodyPr wrap="square" lIns="0" rIns="0" tIns="0" bIns="0">
+            <a:spAutoFit/>
+          </a:bodyPr>
+          <a:lstStyle/>
+          <a:p>
+            <a:pPr>
+              <a:lnSpc>
+                <a:spcPct val="107000"/>
+              </a:lnSpc>
+              <a:spcAft>
+                <a:spcPts val="500"/>
+              </a:spcAft>
+            </a:pPr>
+            <a:r>
+              <a:rPr sz="1000" b="0">
+                <a:solidFill>
+                  <a:srgbClr val="232925"/>
+                </a:solidFill>
+                <a:latin typeface="Arial"/>
+              </a:rPr>
+              <a:t>Bearing  |  GitHub Copilot App workflow</a:t>
+            </a:r>
+          </a:p>
+        </p:txBody>
+      </p:sp>
+      <p:sp>
+        <p:nvSpPr>
+          <p:cNvPr id="6" name="05 / 19"/>
+          <p:cNvSpPr txBox="1"/>
+          <p:nvPr/>
+        </p:nvSpPr>
+        <p:spPr>
+          <a:xfrm>
+            <a:off x="10744200" y="6428232"/>
+            <a:ext cx="822960" cy="201168"/>
+          </a:xfrm>
+          <a:prstGeom prst="rect">
+            <a:avLst/>
+          </a:prstGeom>
+          <a:noFill/>
+        </p:spPr>
+        <p:txBody>
+          <a:bodyPr wrap="square" lIns="0" rIns="0" tIns="0" bIns="0">
+            <a:spAutoFit/>
+          </a:bodyPr>
+          <a:lstStyle/>
+          <a:p>
+            <a:pPr>
+              <a:lnSpc>
+                <a:spcPct val="107000"/>
+              </a:lnSpc>
+              <a:spcAft>
+                <a:spcPts val="500"/>
+              </a:spcAft>
+            </a:pPr>
+            <a:r>
+              <a:rPr sz="1000" b="0">
+                <a:solidFill>
+                  <a:srgbClr val="232925"/>
+                </a:solidFill>
+                <a:latin typeface="Arial"/>
+              </a:rPr>
+              <a:t>05 / 19</a:t>
+            </a:r>
+          </a:p>
+        </p:txBody>
+      </p:sp>
+      <p:sp>
+        <p:nvSpPr>
+          <p:cNvPr id="7" name="Input box"/>
+          <p:cNvSpPr/>
+          <p:nvPr/>
+        </p:nvSpPr>
+        <p:spPr>
+          <a:xfrm>
+            <a:off x="594360" y="1627632"/>
+            <a:ext cx="2286000" cy="777240"/>
+          </a:xfrm>
+          <a:prstGeom prst="rect">
+            <a:avLst/>
+          </a:prstGeom>
+          <a:solidFill>
+            <a:srgbClr val="F2F5F3"/>
+          </a:solidFill>
+          <a:ln>
+            <a:noFill/>
+          </a:ln>
+        </p:spPr>
+        <p:style>
+          <a:lnRef idx="1">
+            <a:schemeClr val="accent1"/>
+          </a:lnRef>
+          <a:fillRef idx="3">
+            <a:schemeClr val="accent1"/>
+          </a:fillRef>
+          <a:effectRef idx="2">
+            <a:schemeClr val="accent1"/>
+          </a:effectRef>
+          <a:fontRef idx="minor">
+            <a:schemeClr val="lt1"/>
+          </a:fontRef>
+        </p:style>
+        <p:txBody>
+          <a:bodyPr rtlCol="0" anchor="ctr"/>
+          <a:lstStyle/>
+          <a:p>
+            <a:pPr algn="ctr"/>
+          </a:p>
+        </p:txBody>
+      </p:sp>
+      <p:sp>
+        <p:nvSpPr>
+          <p:cNvPr id="8" name="A repository"/>
+          <p:cNvSpPr txBox="1"/>
+          <p:nvPr/>
+        </p:nvSpPr>
+        <p:spPr>
+          <a:xfrm>
+            <a:off x="777240" y="1737360"/>
+            <a:ext cx="2011680" cy="548640"/>
+          </a:xfrm>
+          <a:prstGeom prst="rect">
+            <a:avLst/>
+          </a:prstGeom>
+          <a:noFill/>
+        </p:spPr>
+        <p:txBody>
+          <a:bodyPr wrap="square" lIns="0" rIns="0" tIns="0" bIns="0">
+            <a:spAutoFit/>
+          </a:bodyPr>
+          <a:lstStyle/>
+          <a:p>
+            <a:pPr>
+              <a:lnSpc>
+                <a:spcPct val="107000"/>
+              </a:lnSpc>
+              <a:spcAft>
+                <a:spcPts val="500"/>
+              </a:spcAft>
+            </a:pPr>
+            <a:r>
+              <a:rPr sz="1700" b="1">
+                <a:solidFill>
+                  <a:srgbClr val="101411"/>
+                </a:solidFill>
+                <a:latin typeface="Arial"/>
+              </a:rPr>
+              <a:t>A repository</a:t>
+            </a:r>
+          </a:p>
+          <a:p>
+            <a:pPr>
+              <a:lnSpc>
+                <a:spcPct val="107000"/>
+              </a:lnSpc>
+              <a:spcAft>
+                <a:spcPts val="500"/>
+              </a:spcAft>
+            </a:pPr>
+            <a:r>
+              <a:rPr sz="1300" b="0">
+                <a:solidFill>
+                  <a:srgbClr val="232925"/>
+                </a:solidFill>
+                <a:latin typeface="Arial"/>
+              </a:rPr>
+              <a:t>One service first</a:t>
+            </a:r>
+          </a:p>
+        </p:txBody>
+      </p:sp>
+      <p:sp>
+        <p:nvSpPr>
+          <p:cNvPr id="9" name="Arrow 1"/>
+          <p:cNvSpPr/>
+          <p:nvPr/>
+        </p:nvSpPr>
+        <p:spPr>
+          <a:xfrm>
+            <a:off x="2926080" y="1879092"/>
+            <a:ext cx="365760" cy="274320"/>
+          </a:xfrm>
+          <a:prstGeom prst="rightArrow">
+            <a:avLst/>
+          </a:prstGeom>
+          <a:solidFill>
+            <a:srgbClr val="08872B"/>
+          </a:solidFill>
+          <a:ln>
+            <a:noFill/>
+          </a:ln>
+        </p:spPr>
+        <p:style>
+          <a:lnRef idx="1">
+            <a:schemeClr val="accent1"/>
+          </a:lnRef>
+          <a:fillRef idx="3">
+            <a:schemeClr val="accent1"/>
+          </a:fillRef>
+          <a:effectRef idx="2">
+            <a:schemeClr val="accent1"/>
+          </a:effectRef>
+          <a:fontRef idx="minor">
+            <a:schemeClr val="lt1"/>
+          </a:fontRef>
+        </p:style>
+        <p:txBody>
+          <a:bodyPr rtlCol="0" anchor="ctr"/>
+          <a:lstStyle/>
+          <a:p>
+            <a:pPr algn="ctr"/>
+          </a:p>
+        </p:txBody>
+      </p:sp>
+      <p:sp>
+        <p:nvSpPr>
+          <p:cNvPr id="10" name="Exploration box"/>
+          <p:cNvSpPr/>
+          <p:nvPr/>
+        </p:nvSpPr>
+        <p:spPr>
+          <a:xfrm>
+            <a:off x="3337560" y="1627632"/>
+            <a:ext cx="5212080" cy="777240"/>
+          </a:xfrm>
+          <a:prstGeom prst="rect">
+            <a:avLst/>
+          </a:prstGeom>
+          <a:solidFill>
+            <a:srgbClr val="101411"/>
+          </a:solidFill>
+          <a:ln>
+            <a:noFill/>
+          </a:ln>
+        </p:spPr>
+        <p:style>
+          <a:lnRef idx="1">
+            <a:schemeClr val="accent1"/>
+          </a:lnRef>
+          <a:fillRef idx="3">
+            <a:schemeClr val="accent1"/>
+          </a:fillRef>
+          <a:effectRef idx="2">
+            <a:schemeClr val="accent1"/>
+          </a:effectRef>
+          <a:fontRef idx="minor">
+            <a:schemeClr val="lt1"/>
+          </a:fontRef>
+        </p:style>
+        <p:txBody>
+          <a:bodyPr rtlCol="0" anchor="ctr"/>
+          <a:lstStyle/>
+          <a:p>
+            <a:pPr algn="ctr"/>
+          </a:p>
+        </p:txBody>
+      </p:sp>
+      <p:sp>
+        <p:nvSpPr>
+          <p:cNvPr id="11" name="Light FDE pass"/>
+          <p:cNvSpPr txBox="1"/>
+          <p:nvPr/>
+        </p:nvSpPr>
+        <p:spPr>
+          <a:xfrm>
+            <a:off x="3520440" y="1737360"/>
+            <a:ext cx="4846320" cy="548640"/>
+          </a:xfrm>
+          <a:prstGeom prst="rect">
+            <a:avLst/>
+          </a:prstGeom>
+          <a:noFill/>
+        </p:spPr>
+        <p:txBody>
+          <a:bodyPr wrap="square" lIns="0" rIns="0" tIns="0" bIns="0">
+            <a:spAutoFit/>
+          </a:bodyPr>
+          <a:lstStyle/>
+          <a:p>
+            <a:pPr>
+              <a:lnSpc>
+                <a:spcPct val="107000"/>
+              </a:lnSpc>
+              <a:spcAft>
+                <a:spcPts val="500"/>
+              </a:spcAft>
+            </a:pPr>
+            <a:r>
+              <a:rPr sz="1700" b="1">
+                <a:solidFill>
+                  <a:srgbClr val="FFFFFF"/>
+                </a:solidFill>
+                <a:latin typeface="Arial"/>
+              </a:rPr>
+              <a:t>Light FDE pass: read-only exploration</a:t>
+            </a:r>
+          </a:p>
+          <a:p>
+            <a:pPr>
+              <a:lnSpc>
+                <a:spcPct val="107000"/>
+              </a:lnSpc>
+              <a:spcAft>
+                <a:spcPts val="500"/>
+              </a:spcAft>
+            </a:pPr>
+            <a:r>
+              <a:rPr sz="1300" b="0">
+                <a:solidFill>
+                  <a:srgbClr val="B6BFB8"/>
+                </a:solidFill>
+                <a:latin typeface="Arial"/>
+              </a:rPr>
+              <a:t>Plan → Delegate → Validate → Review → Ship</a:t>
+            </a:r>
+          </a:p>
+        </p:txBody>
+      </p:sp>
+      <p:sp>
+        <p:nvSpPr>
+          <p:cNvPr id="12" name="Arrow 2"/>
+          <p:cNvSpPr/>
+          <p:nvPr/>
+        </p:nvSpPr>
+        <p:spPr>
+          <a:xfrm>
+            <a:off x="8595360" y="1879092"/>
+            <a:ext cx="365760" cy="274320"/>
+          </a:xfrm>
+          <a:prstGeom prst="rightArrow">
+            <a:avLst/>
+          </a:prstGeom>
+          <a:solidFill>
+            <a:srgbClr val="08872B"/>
+          </a:solidFill>
+          <a:ln>
+            <a:noFill/>
+          </a:ln>
+        </p:spPr>
+        <p:style>
+          <a:lnRef idx="1">
+            <a:schemeClr val="accent1"/>
+          </a:lnRef>
+          <a:fillRef idx="3">
+            <a:schemeClr val="accent1"/>
+          </a:fillRef>
+          <a:effectRef idx="2">
+            <a:schemeClr val="accent1"/>
+          </a:effectRef>
+          <a:fontRef idx="minor">
+            <a:schemeClr val="lt1"/>
+          </a:fontRef>
+        </p:style>
+        <p:txBody>
+          <a:bodyPr rtlCol="0" anchor="ctr"/>
+          <a:lstStyle/>
+          <a:p>
+            <a:pPr algn="ctr"/>
+          </a:p>
+        </p:txBody>
+      </p:sp>
+      <p:sp>
+        <p:nvSpPr>
+          <p:cNvPr id="13" name="Output box"/>
+          <p:cNvSpPr/>
+          <p:nvPr/>
+        </p:nvSpPr>
+        <p:spPr>
+          <a:xfrm>
+            <a:off x="9006840" y="1627632"/>
+            <a:ext cx="2560320" cy="777240"/>
+          </a:xfrm>
+          <a:prstGeom prst="rect">
+            <a:avLst/>
+          </a:prstGeom>
+          <a:solidFill>
+            <a:srgbClr val="F2F5F3"/>
+          </a:solidFill>
+          <a:ln>
+            <a:noFill/>
+          </a:ln>
+        </p:spPr>
+        <p:style>
+          <a:lnRef idx="1">
+            <a:schemeClr val="accent1"/>
+          </a:lnRef>
+          <a:fillRef idx="3">
+            <a:schemeClr val="accent1"/>
+          </a:fillRef>
+          <a:effectRef idx="2">
+            <a:schemeClr val="accent1"/>
+          </a:effectRef>
+          <a:fontRef idx="minor">
+            <a:schemeClr val="lt1"/>
+          </a:fontRef>
+        </p:style>
+        <p:txBody>
+          <a:bodyPr rtlCol="0" anchor="ctr"/>
+          <a:lstStyle/>
+          <a:p>
+            <a:pPr algn="ctr"/>
+          </a:p>
+        </p:txBody>
+      </p:sp>
+      <p:sp>
+        <p:nvSpPr>
+          <p:cNvPr id="14" name="What to optimize"/>
+          <p:cNvSpPr txBox="1"/>
+          <p:nvPr/>
+        </p:nvSpPr>
+        <p:spPr>
+          <a:xfrm>
+            <a:off x="9189720" y="1737360"/>
+            <a:ext cx="2194560" cy="548640"/>
+          </a:xfrm>
+          <a:prstGeom prst="rect">
+            <a:avLst/>
+          </a:prstGeom>
+          <a:noFill/>
+        </p:spPr>
+        <p:txBody>
+          <a:bodyPr wrap="square" lIns="0" rIns="0" tIns="0" bIns="0">
+            <a:spAutoFit/>
+          </a:bodyPr>
+          <a:lstStyle/>
+          <a:p>
+            <a:pPr>
+              <a:lnSpc>
+                <a:spcPct val="107000"/>
+              </a:lnSpc>
+              <a:spcAft>
+                <a:spcPts val="500"/>
+              </a:spcAft>
+            </a:pPr>
+            <a:r>
+              <a:rPr sz="1700" b="1">
+                <a:solidFill>
+                  <a:srgbClr val="101411"/>
+                </a:solidFill>
+                <a:latin typeface="Arial"/>
+              </a:rPr>
+              <a:t>What to optimize</a:t>
+            </a:r>
+          </a:p>
+          <a:p>
+            <a:pPr>
+              <a:lnSpc>
+                <a:spcPct val="107000"/>
+              </a:lnSpc>
+              <a:spcAft>
+                <a:spcPts val="500"/>
+              </a:spcAft>
+            </a:pPr>
+            <a:r>
+              <a:rPr sz="1300" b="0">
+                <a:solidFill>
+                  <a:srgbClr val="232925"/>
+                </a:solidFill>
+                <a:latin typeface="Arial"/>
+              </a:rPr>
+              <a:t>With cited evidence</a:t>
+            </a:r>
+          </a:p>
+        </p:txBody>
+      </p:sp>
+      <p:sp>
+        <p:nvSpPr>
+          <p:cNvPr id="15" name="Table header"/>
+          <p:cNvSpPr/>
+          <p:nvPr/>
+        </p:nvSpPr>
+        <p:spPr>
+          <a:xfrm>
+            <a:off x="594360" y="2560320"/>
+            <a:ext cx="10972800" cy="457200"/>
+          </a:xfrm>
+          <a:prstGeom prst="rect">
+            <a:avLst/>
+          </a:prstGeom>
+          <a:solidFill>
+            <a:srgbClr val="101411"/>
+          </a:solidFill>
+          <a:ln>
+            <a:noFill/>
+          </a:ln>
+        </p:spPr>
+        <p:style>
+          <a:lnRef idx="1">
+            <a:schemeClr val="accent1"/>
+          </a:lnRef>
+          <a:fillRef idx="3">
+            <a:schemeClr val="accent1"/>
+          </a:fillRef>
+          <a:effectRef idx="2">
+            <a:schemeClr val="accent1"/>
+          </a:effectRef>
+          <a:fontRef idx="minor">
+            <a:schemeClr val="lt1"/>
+          </a:fontRef>
+        </p:style>
+        <p:txBody>
+          <a:bodyPr rtlCol="0" anchor="ctr"/>
+          <a:lstStyle/>
+          <a:p>
+            <a:pPr algn="ctr"/>
+          </a:p>
+        </p:txBody>
+      </p:sp>
+      <p:sp>
+        <p:nvSpPr>
+          <p:cNvPr id="16" name="Output"/>
+          <p:cNvSpPr txBox="1"/>
+          <p:nvPr/>
+        </p:nvSpPr>
+        <p:spPr>
+          <a:xfrm>
+            <a:off x="704088" y="2651760"/>
+            <a:ext cx="2743200" cy="274320"/>
+          </a:xfrm>
+          <a:prstGeom prst="rect">
+            <a:avLst/>
+          </a:prstGeom>
+          <a:noFill/>
+        </p:spPr>
+        <p:txBody>
+          <a:bodyPr wrap="square" lIns="0" rIns="0" tIns="0" bIns="0">
+            <a:spAutoFit/>
+          </a:bodyPr>
+          <a:lstStyle/>
+          <a:p>
+            <a:pPr>
+              <a:lnSpc>
+                <a:spcPct val="107000"/>
+              </a:lnSpc>
+              <a:spcAft>
+                <a:spcPts val="500"/>
+              </a:spcAft>
+            </a:pPr>
+            <a:r>
+              <a:rPr sz="1700" b="1">
+                <a:solidFill>
+                  <a:srgbClr val="FFFFFF"/>
+                </a:solidFill>
+                <a:latin typeface="Arial"/>
+              </a:rPr>
+              <a:t>Output</a:t>
+            </a:r>
+          </a:p>
+        </p:txBody>
+      </p:sp>
+      <p:sp>
+        <p:nvSpPr>
+          <p:cNvPr id="17" name="What comes back"/>
+          <p:cNvSpPr txBox="1"/>
+          <p:nvPr/>
+        </p:nvSpPr>
+        <p:spPr>
+          <a:xfrm>
+            <a:off x="3611880" y="2651760"/>
+            <a:ext cx="6400800" cy="274320"/>
+          </a:xfrm>
+          <a:prstGeom prst="rect">
+            <a:avLst/>
+          </a:prstGeom>
+          <a:noFill/>
+        </p:spPr>
+        <p:txBody>
+          <a:bodyPr wrap="square" lIns="0" rIns="0" tIns="0" bIns="0">
+            <a:spAutoFit/>
+          </a:bodyPr>
+          <a:lstStyle/>
+          <a:p>
+            <a:pPr>
+              <a:lnSpc>
+                <a:spcPct val="107000"/>
+              </a:lnSpc>
+              <a:spcAft>
+                <a:spcPts val="500"/>
+              </a:spcAft>
+            </a:pPr>
+            <a:r>
+              <a:rPr sz="1700" b="1">
+                <a:solidFill>
+                  <a:srgbClr val="FFFFFF"/>
+                </a:solidFill>
+                <a:latin typeface="Arial"/>
+              </a:rPr>
+              <a:t>What comes back</a:t>
+            </a:r>
+          </a:p>
+        </p:txBody>
+      </p:sp>
+      <p:sp>
+        <p:nvSpPr>
+          <p:cNvPr id="18" name="Status"/>
+          <p:cNvSpPr txBox="1"/>
+          <p:nvPr/>
+        </p:nvSpPr>
+        <p:spPr>
+          <a:xfrm>
+            <a:off x="10579608" y="2651760"/>
+            <a:ext cx="877824" cy="274320"/>
+          </a:xfrm>
+          <a:prstGeom prst="rect">
+            <a:avLst/>
+          </a:prstGeom>
+          <a:noFill/>
+        </p:spPr>
+        <p:txBody>
+          <a:bodyPr wrap="square" lIns="0" rIns="0" tIns="0" bIns="0">
+            <a:spAutoFit/>
+          </a:bodyPr>
+          <a:lstStyle/>
+          <a:p>
+            <a:pPr>
+              <a:lnSpc>
+                <a:spcPct val="107000"/>
+              </a:lnSpc>
+              <a:spcAft>
+                <a:spcPts val="500"/>
+              </a:spcAft>
+            </a:pPr>
+            <a:r>
+              <a:rPr sz="1700" b="1">
+                <a:solidFill>
+                  <a:srgbClr val="FFFFFF"/>
+                </a:solidFill>
+                <a:latin typeface="Arial"/>
+              </a:rPr>
+              <a:t>Status</a:t>
+            </a:r>
+          </a:p>
+        </p:txBody>
+      </p:sp>
+      <p:sp>
+        <p:nvSpPr>
+          <p:cNvPr id="19" name="Cited picture"/>
+          <p:cNvSpPr txBox="1"/>
+          <p:nvPr/>
+        </p:nvSpPr>
+        <p:spPr>
+          <a:xfrm>
+            <a:off x="704088" y="3163824"/>
+            <a:ext cx="2834640" cy="274320"/>
+          </a:xfrm>
+          <a:prstGeom prst="rect">
+            <a:avLst/>
+          </a:prstGeom>
+          <a:noFill/>
+        </p:spPr>
+        <p:txBody>
+          <a:bodyPr wrap="square" lIns="0" rIns="0" tIns="0" bIns="0">
+            <a:spAutoFit/>
+          </a:bodyPr>
+          <a:lstStyle/>
+          <a:p>
+            <a:pPr>
+              <a:lnSpc>
+                <a:spcPct val="107000"/>
+              </a:lnSpc>
+              <a:spcAft>
+                <a:spcPts val="500"/>
+              </a:spcAft>
+            </a:pPr>
+            <a:r>
+              <a:rPr sz="1500" b="1">
+                <a:solidFill>
+                  <a:srgbClr val="101411"/>
+                </a:solidFill>
+                <a:latin typeface="Arial"/>
+              </a:rPr>
+              <a:t>Cited picture</a:t>
+            </a:r>
+          </a:p>
+        </p:txBody>
+      </p:sp>
+      <p:sp>
+        <p:nvSpPr>
+          <p:cNvPr id="20" name="Cited picture: detail"/>
+          <p:cNvSpPr txBox="1"/>
+          <p:nvPr/>
+        </p:nvSpPr>
+        <p:spPr>
+          <a:xfrm>
+            <a:off x="3611880" y="3163824"/>
+            <a:ext cx="6766560" cy="502920"/>
+          </a:xfrm>
+          <a:prstGeom prst="rect">
+            <a:avLst/>
+          </a:prstGeom>
+          <a:noFill/>
+        </p:spPr>
+        <p:txBody>
+          <a:bodyPr wrap="square" lIns="0" rIns="0" tIns="0" bIns="0">
+            <a:spAutoFit/>
+          </a:bodyPr>
+          <a:lstStyle/>
+          <a:p>
+            <a:pPr>
+              <a:lnSpc>
+                <a:spcPct val="107000"/>
+              </a:lnSpc>
+              <a:spcAft>
+                <a:spcPts val="500"/>
+              </a:spcAft>
+            </a:pPr>
+            <a:r>
+              <a:rPr sz="1400" b="0">
+                <a:solidFill>
+                  <a:srgbClr val="232925"/>
+                </a:solidFill>
+                <a:latin typeface="Arial"/>
+              </a:rPr>
+              <a:t>Map, conventions (documented vs observed), workflow, merged-PR history and first steps. Every claim cites file and line.</a:t>
+            </a:r>
+          </a:p>
+        </p:txBody>
+      </p:sp>
+      <p:sp>
+        <p:nvSpPr>
+          <p:cNvPr id="21" name="Chip: Prototype"/>
+          <p:cNvSpPr/>
+          <p:nvPr/>
+        </p:nvSpPr>
+        <p:spPr>
+          <a:xfrm>
+            <a:off x="10579608" y="3182112"/>
+            <a:ext cx="822960" cy="274320"/>
+          </a:xfrm>
+          <a:prstGeom prst="roundRect">
+            <a:avLst/>
+          </a:prstGeom>
+          <a:solidFill>
+            <a:srgbClr val="08872B"/>
+          </a:solidFill>
+          <a:ln>
+            <a:noFill/>
+          </a:ln>
+        </p:spPr>
+        <p:style>
+          <a:lnRef idx="1">
+            <a:schemeClr val="accent1"/>
+          </a:lnRef>
+          <a:fillRef idx="3">
+            <a:schemeClr val="accent1"/>
+          </a:fillRef>
+          <a:effectRef idx="2">
+            <a:schemeClr val="accent1"/>
+          </a:effectRef>
+          <a:fontRef idx="minor">
+            <a:schemeClr val="lt1"/>
+          </a:fontRef>
+        </p:style>
+        <p:txBody>
+          <a:bodyPr rtlCol="0" anchor="ctr" lIns="36576" rIns="36576" tIns="0" bIns="0" wrap="square"/>
+          <a:lstStyle/>
+          <a:p>
+            <a:pPr algn="ctr"/>
+            <a:r>
+              <a:rPr sz="1200" b="1">
+                <a:solidFill>
+                  <a:srgbClr val="FFFFFF"/>
+                </a:solidFill>
+                <a:latin typeface="Arial"/>
+              </a:rPr>
+              <a:t>Prototype</a:t>
+            </a:r>
+          </a:p>
+        </p:txBody>
+      </p:sp>
+      <p:sp>
+        <p:nvSpPr>
+          <p:cNvPr id="22" name="Rule"/>
+          <p:cNvSpPr/>
+          <p:nvPr/>
+        </p:nvSpPr>
+        <p:spPr>
+          <a:xfrm>
+            <a:off x="594360" y="3749040"/>
+            <a:ext cx="10972800" cy="10973"/>
+          </a:xfrm>
+          <a:prstGeom prst="rect">
+            <a:avLst/>
+          </a:prstGeom>
+          <a:solidFill>
+            <a:srgbClr val="E4EBE6"/>
+          </a:solidFill>
+          <a:ln>
+            <a:noFill/>
+          </a:ln>
+        </p:spPr>
+        <p:style>
+          <a:lnRef idx="1">
+            <a:schemeClr val="accent1"/>
+          </a:lnRef>
+          <a:fillRef idx="3">
+            <a:schemeClr val="accent1"/>
+          </a:fillRef>
+          <a:effectRef idx="2">
+            <a:schemeClr val="accent1"/>
+          </a:effectRef>
+          <a:fontRef idx="minor">
+            <a:schemeClr val="lt1"/>
+          </a:fontRef>
+        </p:style>
+        <p:txBody>
+          <a:bodyPr rtlCol="0" anchor="ctr"/>
+          <a:lstStyle/>
+          <a:p>
+            <a:pPr algn="ctr"/>
+          </a:p>
+        </p:txBody>
+      </p:sp>
+      <p:sp>
+        <p:nvSpPr>
+          <p:cNvPr id="23" name="Evidence gaps"/>
+          <p:cNvSpPr txBox="1"/>
+          <p:nvPr/>
+        </p:nvSpPr>
+        <p:spPr>
+          <a:xfrm>
+            <a:off x="704088" y="3840480"/>
+            <a:ext cx="2834640" cy="274320"/>
+          </a:xfrm>
+          <a:prstGeom prst="rect">
+            <a:avLst/>
+          </a:prstGeom>
+          <a:noFill/>
+        </p:spPr>
+        <p:txBody>
+          <a:bodyPr wrap="square" lIns="0" rIns="0" tIns="0" bIns="0">
+            <a:spAutoFit/>
+          </a:bodyPr>
+          <a:lstStyle/>
+          <a:p>
+            <a:pPr>
+              <a:lnSpc>
+                <a:spcPct val="107000"/>
+              </a:lnSpc>
+              <a:spcAft>
+                <a:spcPts val="500"/>
+              </a:spcAft>
+            </a:pPr>
+            <a:r>
+              <a:rPr sz="1500" b="1">
+                <a:solidFill>
+                  <a:srgbClr val="101411"/>
+                </a:solidFill>
+                <a:latin typeface="Arial"/>
+              </a:rPr>
+              <a:t>Evidence gaps</a:t>
+            </a:r>
+          </a:p>
+        </p:txBody>
+      </p:sp>
+      <p:sp>
+        <p:nvSpPr>
+          <p:cNvPr id="24" name="Evidence gaps: detail"/>
+          <p:cNvSpPr txBox="1"/>
+          <p:nvPr/>
+        </p:nvSpPr>
+        <p:spPr>
+          <a:xfrm>
+            <a:off x="3611880" y="3840480"/>
+            <a:ext cx="6766560" cy="502920"/>
+          </a:xfrm>
+          <a:prstGeom prst="rect">
+            <a:avLst/>
+          </a:prstGeom>
+          <a:noFill/>
+        </p:spPr>
+        <p:txBody>
+          <a:bodyPr wrap="square" lIns="0" rIns="0" tIns="0" bIns="0">
+            <a:spAutoFit/>
+          </a:bodyPr>
+          <a:lstStyle/>
+          <a:p>
+            <a:pPr>
+              <a:lnSpc>
+                <a:spcPct val="107000"/>
+              </a:lnSpc>
+              <a:spcAft>
+                <a:spcPts val="500"/>
+              </a:spcAft>
+            </a:pPr>
+            <a:r>
+              <a:rPr sz="1400" b="0">
+                <a:solidFill>
+                  <a:srgbClr val="232925"/>
+                </a:solidFill>
+                <a:latin typeface="Arial"/>
+              </a:rPr>
+              <a:t>Unavailable sections, observed-only conventions and missing docs: the first optimization signals. Not a ranked output.</a:t>
+            </a:r>
+          </a:p>
+        </p:txBody>
+      </p:sp>
+      <p:sp>
+        <p:nvSpPr>
+          <p:cNvPr id="25" name="Chip: Emerging"/>
+          <p:cNvSpPr/>
+          <p:nvPr/>
+        </p:nvSpPr>
+        <p:spPr>
+          <a:xfrm>
+            <a:off x="10579608" y="3858768"/>
+            <a:ext cx="822960" cy="274320"/>
+          </a:xfrm>
+          <a:prstGeom prst="roundRect">
+            <a:avLst/>
+          </a:prstGeom>
+          <a:solidFill>
+            <a:srgbClr val="101411"/>
+          </a:solidFill>
+          <a:ln>
+            <a:noFill/>
+          </a:ln>
+        </p:spPr>
+        <p:style>
+          <a:lnRef idx="1">
+            <a:schemeClr val="accent1"/>
+          </a:lnRef>
+          <a:fillRef idx="3">
+            <a:schemeClr val="accent1"/>
+          </a:fillRef>
+          <a:effectRef idx="2">
+            <a:schemeClr val="accent1"/>
+          </a:effectRef>
+          <a:fontRef idx="minor">
+            <a:schemeClr val="lt1"/>
+          </a:fontRef>
+        </p:style>
+        <p:txBody>
+          <a:bodyPr rtlCol="0" anchor="ctr" lIns="36576" rIns="36576" tIns="0" bIns="0" wrap="square"/>
+          <a:lstStyle/>
+          <a:p>
+            <a:pPr algn="ctr"/>
+            <a:r>
+              <a:rPr sz="1200" b="1">
+                <a:solidFill>
+                  <a:srgbClr val="FFFFFF"/>
+                </a:solidFill>
+                <a:latin typeface="Arial"/>
+              </a:rPr>
+              <a:t>Emerging</a:t>
+            </a:r>
+          </a:p>
+        </p:txBody>
+      </p:sp>
+      <p:sp>
+        <p:nvSpPr>
+          <p:cNvPr id="26" name="Rule"/>
+          <p:cNvSpPr/>
+          <p:nvPr/>
+        </p:nvSpPr>
+        <p:spPr>
+          <a:xfrm>
+            <a:off x="594360" y="4425696"/>
+            <a:ext cx="10972800" cy="10973"/>
+          </a:xfrm>
+          <a:prstGeom prst="rect">
+            <a:avLst/>
+          </a:prstGeom>
+          <a:solidFill>
+            <a:srgbClr val="E4EBE6"/>
+          </a:solidFill>
+          <a:ln>
+            <a:noFill/>
+          </a:ln>
+        </p:spPr>
+        <p:style>
+          <a:lnRef idx="1">
+            <a:schemeClr val="accent1"/>
+          </a:lnRef>
+          <a:fillRef idx="3">
+            <a:schemeClr val="accent1"/>
+          </a:fillRef>
+          <a:effectRef idx="2">
+            <a:schemeClr val="accent1"/>
+          </a:effectRef>
+          <a:fontRef idx="minor">
+            <a:schemeClr val="lt1"/>
+          </a:fontRef>
+        </p:style>
+        <p:txBody>
+          <a:bodyPr rtlCol="0" anchor="ctr"/>
+          <a:lstStyle/>
+          <a:p>
+            <a:pPr algn="ctr"/>
+          </a:p>
+        </p:txBody>
+      </p:sp>
+      <p:sp>
+        <p:nvSpPr>
+          <p:cNvPr id="27" name="Optimization candidates"/>
+          <p:cNvSpPr txBox="1"/>
+          <p:nvPr/>
+        </p:nvSpPr>
+        <p:spPr>
+          <a:xfrm>
+            <a:off x="704088" y="4517136"/>
+            <a:ext cx="2834640" cy="274320"/>
+          </a:xfrm>
+          <a:prstGeom prst="rect">
+            <a:avLst/>
+          </a:prstGeom>
+          <a:noFill/>
+        </p:spPr>
+        <p:txBody>
+          <a:bodyPr wrap="square" lIns="0" rIns="0" tIns="0" bIns="0">
+            <a:spAutoFit/>
+          </a:bodyPr>
+          <a:lstStyle/>
+          <a:p>
+            <a:pPr>
+              <a:lnSpc>
+                <a:spcPct val="107000"/>
+              </a:lnSpc>
+              <a:spcAft>
+                <a:spcPts val="500"/>
+              </a:spcAft>
+            </a:pPr>
+            <a:r>
+              <a:rPr sz="1500" b="1">
+                <a:solidFill>
+                  <a:srgbClr val="101411"/>
+                </a:solidFill>
+                <a:latin typeface="Arial"/>
+              </a:rPr>
+              <a:t>Optimization candidates</a:t>
+            </a:r>
+          </a:p>
+        </p:txBody>
+      </p:sp>
+      <p:sp>
+        <p:nvSpPr>
+          <p:cNvPr id="28" name="Optimization candidates: detail"/>
+          <p:cNvSpPr txBox="1"/>
+          <p:nvPr/>
+        </p:nvSpPr>
+        <p:spPr>
+          <a:xfrm>
+            <a:off x="3611880" y="4517136"/>
+            <a:ext cx="6766560" cy="502920"/>
+          </a:xfrm>
+          <a:prstGeom prst="rect">
+            <a:avLst/>
+          </a:prstGeom>
+          <a:noFill/>
+        </p:spPr>
+        <p:txBody>
+          <a:bodyPr wrap="square" lIns="0" rIns="0" tIns="0" bIns="0">
+            <a:spAutoFit/>
+          </a:bodyPr>
+          <a:lstStyle/>
+          <a:p>
+            <a:pPr>
+              <a:lnSpc>
+                <a:spcPct val="107000"/>
+              </a:lnSpc>
+              <a:spcAft>
+                <a:spcPts val="500"/>
+              </a:spcAft>
+            </a:pPr>
+            <a:r>
+              <a:rPr sz="1400" b="0">
+                <a:solidFill>
+                  <a:srgbClr val="232925"/>
+                </a:solidFill>
+                <a:latin typeface="Arial"/>
+              </a:rPr>
+              <a:t>Ranked by test confidence, delivery friction, supportability, ownership risk; each with evidence, confidence and a Copilot task brief.</a:t>
+            </a:r>
+          </a:p>
+        </p:txBody>
+      </p:sp>
+      <p:sp>
+        <p:nvSpPr>
+          <p:cNvPr id="29" name="Chip: Proposed"/>
+          <p:cNvSpPr/>
+          <p:nvPr/>
+        </p:nvSpPr>
+        <p:spPr>
+          <a:xfrm>
+            <a:off x="10579608" y="4535424"/>
+            <a:ext cx="822960" cy="274320"/>
+          </a:xfrm>
+          <a:prstGeom prst="roundRect">
+            <a:avLst/>
+          </a:prstGeom>
+          <a:solidFill>
+            <a:srgbClr val="8534F3"/>
+          </a:solidFill>
+          <a:ln>
+            <a:noFill/>
+          </a:ln>
+        </p:spPr>
+        <p:style>
+          <a:lnRef idx="1">
+            <a:schemeClr val="accent1"/>
+          </a:lnRef>
+          <a:fillRef idx="3">
+            <a:schemeClr val="accent1"/>
+          </a:fillRef>
+          <a:effectRef idx="2">
+            <a:schemeClr val="accent1"/>
+          </a:effectRef>
+          <a:fontRef idx="minor">
+            <a:schemeClr val="lt1"/>
+          </a:fontRef>
+        </p:style>
+        <p:txBody>
+          <a:bodyPr rtlCol="0" anchor="ctr" lIns="36576" rIns="36576" tIns="0" bIns="0" wrap="square"/>
+          <a:lstStyle/>
+          <a:p>
+            <a:pPr algn="ctr"/>
+            <a:r>
+              <a:rPr sz="1200" b="1">
+                <a:solidFill>
+                  <a:srgbClr val="FFFFFF"/>
+                </a:solidFill>
+                <a:latin typeface="Arial"/>
+              </a:rPr>
+              <a:t>Proposed</a:t>
+            </a:r>
+          </a:p>
+        </p:txBody>
+      </p:sp>
+      <p:sp>
+        <p:nvSpPr>
+          <p:cNvPr id="30" name="Rule"/>
+          <p:cNvSpPr/>
+          <p:nvPr/>
+        </p:nvSpPr>
+        <p:spPr>
+          <a:xfrm>
+            <a:off x="594360" y="5102352"/>
+            <a:ext cx="10972800" cy="10973"/>
+          </a:xfrm>
+          <a:prstGeom prst="rect">
+            <a:avLst/>
+          </a:prstGeom>
+          <a:solidFill>
+            <a:srgbClr val="E4EBE6"/>
+          </a:solidFill>
+          <a:ln>
+            <a:noFill/>
+          </a:ln>
+        </p:spPr>
+        <p:style>
+          <a:lnRef idx="1">
+            <a:schemeClr val="accent1"/>
+          </a:lnRef>
+          <a:fillRef idx="3">
+            <a:schemeClr val="accent1"/>
+          </a:fillRef>
+          <a:effectRef idx="2">
+            <a:schemeClr val="accent1"/>
+          </a:effectRef>
+          <a:fontRef idx="minor">
+            <a:schemeClr val="lt1"/>
+          </a:fontRef>
+        </p:style>
+        <p:txBody>
+          <a:bodyPr rtlCol="0" anchor="ctr"/>
+          <a:lstStyle/>
+          <a:p>
+            <a:pPr algn="ctr"/>
+          </a:p>
+        </p:txBody>
+      </p:sp>
+      <p:sp>
+        <p:nvSpPr>
+          <p:cNvPr id="31" name="Human review gate"/>
+          <p:cNvSpPr/>
+          <p:nvPr/>
+        </p:nvSpPr>
+        <p:spPr>
+          <a:xfrm>
+            <a:off x="704088" y="5212080"/>
+            <a:ext cx="201168" cy="201168"/>
+          </a:xfrm>
+          <a:prstGeom prst="diamond">
+            <a:avLst/>
+          </a:prstGeom>
+          <a:solidFill>
+            <a:srgbClr val="101411"/>
+          </a:solidFill>
+          <a:ln>
+            <a:noFill/>
+          </a:ln>
+        </p:spPr>
+        <p:style>
+          <a:lnRef idx="1">
+            <a:schemeClr val="accent1"/>
+          </a:lnRef>
+          <a:fillRef idx="3">
+            <a:schemeClr val="accent1"/>
+          </a:fillRef>
+          <a:effectRef idx="2">
+            <a:schemeClr val="accent1"/>
+          </a:effectRef>
+          <a:fontRef idx="minor">
+            <a:schemeClr val="lt1"/>
+          </a:fontRef>
+        </p:style>
+        <p:txBody>
+          <a:bodyPr rtlCol="0" anchor="ctr"/>
+          <a:lstStyle/>
+          <a:p>
+            <a:pPr algn="ctr"/>
+          </a:p>
+        </p:txBody>
+      </p:sp>
+      <p:sp>
+        <p:nvSpPr>
+          <p:cNvPr id="32" name="Human review gate label"/>
+          <p:cNvSpPr txBox="1"/>
+          <p:nvPr/>
+        </p:nvSpPr>
+        <p:spPr>
+          <a:xfrm>
+            <a:off x="1005840" y="5193792"/>
+            <a:ext cx="2468880" cy="274320"/>
+          </a:xfrm>
+          <a:prstGeom prst="rect">
+            <a:avLst/>
+          </a:prstGeom>
+          <a:noFill/>
+        </p:spPr>
+        <p:txBody>
+          <a:bodyPr wrap="square" lIns="0" rIns="0" tIns="0" bIns="0">
+            <a:spAutoFit/>
+          </a:bodyPr>
+          <a:lstStyle/>
+          <a:p>
+            <a:pPr>
+              <a:lnSpc>
+                <a:spcPct val="107000"/>
+              </a:lnSpc>
+              <a:spcAft>
+                <a:spcPts val="500"/>
+              </a:spcAft>
+            </a:pPr>
+            <a:r>
+              <a:rPr sz="1500" b="1">
+                <a:solidFill>
+                  <a:srgbClr val="101411"/>
+                </a:solidFill>
+                <a:latin typeface="Arial"/>
+              </a:rPr>
+              <a:t>Human review gate</a:t>
+            </a:r>
+          </a:p>
+        </p:txBody>
+      </p:sp>
+      <p:sp>
+        <p:nvSpPr>
+          <p:cNvPr id="33" name="Human review gate: detail"/>
+          <p:cNvSpPr txBox="1"/>
+          <p:nvPr/>
+        </p:nvSpPr>
+        <p:spPr>
+          <a:xfrm>
+            <a:off x="3611880" y="5193792"/>
+            <a:ext cx="6766560" cy="457200"/>
+          </a:xfrm>
+          <a:prstGeom prst="rect">
+            <a:avLst/>
+          </a:prstGeom>
+          <a:noFill/>
+        </p:spPr>
+        <p:txBody>
+          <a:bodyPr wrap="square" lIns="0" rIns="0" tIns="0" bIns="0">
+            <a:spAutoFit/>
+          </a:bodyPr>
+          <a:lstStyle/>
+          <a:p>
+            <a:pPr>
+              <a:lnSpc>
+                <a:spcPct val="107000"/>
+              </a:lnSpc>
+              <a:spcAft>
+                <a:spcPts val="500"/>
+              </a:spcAft>
+            </a:pPr>
+            <a:r>
+              <a:rPr sz="1400" b="0">
+                <a:solidFill>
+                  <a:srgbClr val="232925"/>
+                </a:solidFill>
+                <a:latin typeface="Arial"/>
+              </a:rPr>
+              <a:t>The service owner reviews the cited evidence before any task is delegated onward.</a:t>
+            </a:r>
+          </a:p>
+        </p:txBody>
+      </p:sp>
+      <p:sp>
+        <p:nvSpPr>
+          <p:cNvPr id="34" name="Rule"/>
+          <p:cNvSpPr/>
+          <p:nvPr/>
+        </p:nvSpPr>
+        <p:spPr>
+          <a:xfrm>
+            <a:off x="594360" y="5687568"/>
+            <a:ext cx="10972800" cy="10973"/>
+          </a:xfrm>
+          <a:prstGeom prst="rect">
+            <a:avLst/>
+          </a:prstGeom>
+          <a:solidFill>
+            <a:srgbClr val="E4EBE6"/>
+          </a:solidFill>
+          <a:ln>
+            <a:noFill/>
+          </a:ln>
+        </p:spPr>
+        <p:style>
+          <a:lnRef idx="1">
+            <a:schemeClr val="accent1"/>
+          </a:lnRef>
+          <a:fillRef idx="3">
+            <a:schemeClr val="accent1"/>
+          </a:fillRef>
+          <a:effectRef idx="2">
+            <a:schemeClr val="accent1"/>
+          </a:effectRef>
+          <a:fontRef idx="minor">
+            <a:schemeClr val="lt1"/>
+          </a:fontRef>
+        </p:style>
+        <p:txBody>
+          <a:bodyPr rtlCol="0" anchor="ctr"/>
+          <a:lstStyle/>
+          <a:p>
+            <a:pPr algn="ctr"/>
+          </a:p>
+        </p:txBody>
+      </p:sp>
+      <p:sp>
+        <p:nvSpPr>
+          <p:cNvPr id="35" name="Footnote"/>
+          <p:cNvSpPr txBox="1"/>
+          <p:nvPr/>
+        </p:nvSpPr>
+        <p:spPr>
+          <a:xfrm>
+            <a:off x="594360" y="5760720"/>
+            <a:ext cx="10972800" cy="457200"/>
+          </a:xfrm>
+          <a:prstGeom prst="rect">
+            <a:avLst/>
+          </a:prstGeom>
+          <a:noFill/>
+        </p:spPr>
+        <p:txBody>
+          <a:bodyPr wrap="square" lIns="0" rIns="0" tIns="0" bIns="0">
+            <a:spAutoFit/>
+          </a:bodyPr>
+          <a:lstStyle/>
+          <a:p>
+            <a:pPr>
+              <a:lnSpc>
+                <a:spcPct val="107000"/>
+              </a:lnSpc>
+              <a:spcAft>
+                <a:spcPts val="500"/>
+              </a:spcAft>
+            </a:pPr>
+            <a:r>
+              <a:rPr sz="1400" b="0">
+                <a:solidFill>
+                  <a:srgbClr val="232925"/>
+                </a:solidFill>
+                <a:latin typeface="Arial"/>
+              </a:rPr>
+              <a:t>Prototype: built today. Emerging: surfaced today, not a ranked output. Proposed: not built. Path and line checks validate references, not semantic correctness.</a:t>
             </a:r>
           </a:p>
         </p:txBody>
@@ -17806,7 +19603,7 @@
       </p:sp>
       <p:sp>
         <p:nvSpPr>
-          <p:cNvPr id="6" name="02 / 18"/>
+          <p:cNvPr id="6" name="02 / 19"/>
           <p:cNvSpPr txBox="1"/>
           <p:nvPr/>
         </p:nvSpPr>
@@ -17841,7 +19638,7 @@
                 </a:solidFill>
                 <a:latin typeface="Arial"/>
               </a:rPr>
-              <a:t>02 / 18</a:t>
+              <a:t>02 / 19</a:t>
             </a:r>
           </a:p>
         </p:txBody>
@@ -19166,7 +20963,7 @@
       </p:sp>
       <p:sp>
         <p:nvSpPr>
-          <p:cNvPr id="6" name="03 / 18"/>
+          <p:cNvPr id="6" name="03 / 19"/>
           <p:cNvSpPr txBox="1"/>
           <p:nvPr/>
         </p:nvSpPr>
@@ -19201,7 +20998,7 @@
                 </a:solidFill>
                 <a:latin typeface="Arial"/>
               </a:rPr>
-              <a:t>03 / 18</a:t>
+              <a:t>03 / 19</a:t>
             </a:r>
           </a:p>
         </p:txBody>
@@ -20271,7 +22068,7 @@
       </p:sp>
       <p:sp>
         <p:nvSpPr>
-          <p:cNvPr id="32" name="Built for onboarding today. The same review discipline is pr"/>
+          <p:cNvPr id="32" name="Built today for read-only repo exploration. Ranking what to optimize is proposed next."/>
           <p:cNvSpPr txBox="1"/>
           <p:nvPr/>
         </p:nvSpPr>
@@ -20306,7 +22103,7 @@
                 </a:solidFill>
                 <a:latin typeface="Arial"/>
               </a:rPr>
-              <a:t>Built for onboarding today. The same review discipline is proposed for legacy code next.</a:t>
+              <a:t>Built today for read-only repo exploration. Ranking what to optimize is proposed next.</a:t>
             </a:r>
           </a:p>
         </p:txBody>
@@ -20656,7 +22453,7 @@
       </p:sp>
       <p:sp>
         <p:nvSpPr>
-          <p:cNvPr id="6" name="05 / 18"/>
+          <p:cNvPr id="6" name="06 / 19"/>
           <p:cNvSpPr txBox="1"/>
           <p:nvPr/>
         </p:nvSpPr>
@@ -20691,7 +22488,7 @@
                 </a:solidFill>
                 <a:latin typeface="Arial"/>
               </a:rPr>
-              <a:t>05 / 18</a:t>
+              <a:t>06 / 19</a:t>
             </a:r>
           </a:p>
         </p:txBody>
@@ -30049,7 +31846,7 @@
       </p:sp>
       <p:sp>
         <p:nvSpPr>
-          <p:cNvPr id="6" name="06 / 18"/>
+          <p:cNvPr id="6" name="07 / 19"/>
           <p:cNvSpPr txBox="1"/>
           <p:nvPr/>
         </p:nvSpPr>
@@ -30084,7 +31881,7 @@
                 </a:solidFill>
                 <a:latin typeface="Arial"/>
               </a:rPr>
-              <a:t>06 / 18</a:t>
+              <a:t>07 / 19</a:t>
             </a:r>
           </a:p>
         </p:txBody>
@@ -30903,7 +32700,7 @@
       </p:sp>
       <p:sp>
         <p:nvSpPr>
-          <p:cNvPr id="6" name="07 / 18"/>
+          <p:cNvPr id="6" name="08 / 19"/>
           <p:cNvSpPr txBox="1"/>
           <p:nvPr/>
         </p:nvSpPr>
@@ -30938,7 +32735,7 @@
                 </a:solidFill>
                 <a:latin typeface="Arial"/>
               </a:rPr>
-              <a:t>07 / 18</a:t>
+              <a:t>08 / 19</a:t>
             </a:r>
           </a:p>
         </p:txBody>
@@ -32285,7 +34082,7 @@
       </p:sp>
       <p:sp>
         <p:nvSpPr>
-          <p:cNvPr id="6" name="08 / 18"/>
+          <p:cNvPr id="6" name="09 / 19"/>
           <p:cNvSpPr txBox="1"/>
           <p:nvPr/>
         </p:nvSpPr>
@@ -32320,7 +34117,7 @@
                 </a:solidFill>
                 <a:latin typeface="Arial"/>
               </a:rPr>
-              <a:t>08 / 18</a:t>
+              <a:t>09 / 19</a:t>
             </a:r>
           </a:p>
         </p:txBody>
@@ -33989,7 +35786,7 @@
       </p:sp>
       <p:sp>
         <p:nvSpPr>
-          <p:cNvPr id="6" name="09 / 18"/>
+          <p:cNvPr id="6" name="10 / 19"/>
           <p:cNvSpPr txBox="1"/>
           <p:nvPr/>
         </p:nvSpPr>
@@ -34024,7 +35821,7 @@
                 </a:solidFill>
                 <a:latin typeface="Arial"/>
               </a:rPr>
-              <a:t>09 / 18</a:t>
+              <a:t>10 / 19</a:t>
             </a:r>
           </a:p>
         </p:txBody>
@@ -35964,7 +37761,7 @@
       </p:sp>
       <p:sp>
         <p:nvSpPr>
-          <p:cNvPr id="6" name="10 / 18"/>
+          <p:cNvPr id="6" name="11 / 19"/>
           <p:cNvSpPr txBox="1"/>
           <p:nvPr/>
         </p:nvSpPr>
@@ -35999,7 +37796,7 @@
                 </a:solidFill>
                 <a:latin typeface="Arial"/>
               </a:rPr>
-              <a:t>10 / 18</a:t>
+              <a:t>11 / 19</a:t>
             </a:r>
           </a:p>
         </p:txBody>

</xml_diff>